<commit_message>
Lesson sd-10-015: explain the three ways of running a program from the Python glossary, the OpenJDK java man page and MDN, with the figure, metadata and deck
Co-Authored-By: Claude Sonnet 5.5 <noreply@anthropic.com>
Claude-Session: https://claude.ai/code/session_011dmt3ZFdN8sjiTfDnyUVN7
</commit_message>
<xml_diff>
--- a/system-design-101/vi/lessons/sd-10-015/slides/sd-10-015.pptx
+++ b/system-design-101/vi/lessons/sd-10-015/slides/sd-10-015.pptx
@@ -2978,6 +2978,28 @@
               <a:t>JVM</a:t>
             </a:r>
             <a:r>
+              <a:rPr lang="en-US" sz="2387" dirty="0" spc="-2" kern="0">
+                <a:solidFill>
+                  <a:srgbClr val="C4C8D6"/>
+                </a:solidFill>
+                <a:latin typeface="Be Vietnam Pro" pitchFamily="34" charset="0"/>
+                <a:ea typeface="Be Vietnam Pro" pitchFamily="34" charset="-122"/>
+                <a:cs typeface="Be Vietnam Pro" pitchFamily="34" charset="-120"/>
+              </a:rPr>
+              <a:t> nạp</a:t>
+            </a:r>
+            <a:r>
+              <a:rPr lang="en-US" sz="2387" dirty="0" spc="-17" kern="0">
+                <a:solidFill>
+                  <a:srgbClr val="C4C8D6"/>
+                </a:solidFill>
+                <a:latin typeface="Be Vietnam Pro" pitchFamily="34" charset="0"/>
+                <a:ea typeface="Be Vietnam Pro" pitchFamily="34" charset="-122"/>
+                <a:cs typeface="Be Vietnam Pro" pitchFamily="34" charset="-120"/>
+              </a:rPr>
+              <a:t> và</a:t>
+            </a:r>
+            <a:r>
               <a:rPr lang="en-US" sz="2387" dirty="0" spc="-6" kern="0">
                 <a:solidFill>
                   <a:srgbClr val="C4C8D6"/>
@@ -2987,39 +3009,6 @@
                 <a:cs typeface="Be Vietnam Pro" pitchFamily="34" charset="-120"/>
               </a:rPr>
               <a:t> chạy</a:t>
-            </a:r>
-            <a:r>
-              <a:rPr lang="en-US" sz="2387" dirty="0" spc="5" kern="0">
-                <a:solidFill>
-                  <a:srgbClr val="C4C8D6"/>
-                </a:solidFill>
-                <a:latin typeface="Be Vietnam Pro" pitchFamily="34" charset="0"/>
-                <a:ea typeface="Be Vietnam Pro" pitchFamily="34" charset="-122"/>
-                <a:cs typeface="Be Vietnam Pro" pitchFamily="34" charset="-120"/>
-              </a:rPr>
-              <a:t> chương</a:t>
-            </a:r>
-            <a:r>
-              <a:rPr lang="en-US" sz="2387" dirty="0" spc="8" kern="0">
-                <a:solidFill>
-                  <a:srgbClr val="C4C8D6"/>
-                </a:solidFill>
-                <a:latin typeface="Be Vietnam Pro" pitchFamily="34" charset="0"/>
-                <a:ea typeface="Be Vietnam Pro" pitchFamily="34" charset="-122"/>
-                <a:cs typeface="Be Vietnam Pro" pitchFamily="34" charset="-120"/>
-              </a:rPr>
-              <a:t> trình</a:t>
-            </a:r>
-            <a:r>
-              <a:rPr lang="en-US" sz="2387" dirty="0" spc="-2" kern="0">
-                <a:solidFill>
-                  <a:srgbClr val="C4C8D6"/>
-                </a:solidFill>
-                <a:latin typeface="Be Vietnam Pro" pitchFamily="34" charset="0"/>
-                <a:ea typeface="Be Vietnam Pro" pitchFamily="34" charset="-122"/>
-                <a:cs typeface="Be Vietnam Pro" pitchFamily="34" charset="-120"/>
-              </a:rPr>
-              <a:t> từ</a:t>
             </a:r>
             <a:r>
               <a:rPr lang="en-US" sz="2387" dirty="0" spc="-12" kern="0">
@@ -3249,6 +3238,28 @@
               <a:t> chạy</a:t>
             </a:r>
             <a:r>
+              <a:rPr lang="en-US" sz="2400" dirty="0" spc="3" kern="0">
+                <a:solidFill>
+                  <a:srgbClr val="C4C8D6"/>
+                </a:solidFill>
+                <a:latin typeface="Be Vietnam Pro" pitchFamily="34" charset="0"/>
+                <a:ea typeface="Be Vietnam Pro" pitchFamily="34" charset="-122"/>
+                <a:cs typeface="Be Vietnam Pro" pitchFamily="34" charset="-120"/>
+              </a:rPr>
+              <a:t> từ</a:t>
+            </a:r>
+            <a:r>
+              <a:rPr lang="en-US" sz="2400" dirty="0" spc="4" kern="0">
+                <a:solidFill>
+                  <a:srgbClr val="C4C8D6"/>
+                </a:solidFill>
+                <a:latin typeface="Be Vietnam Pro" pitchFamily="34" charset="0"/>
+                <a:ea typeface="Be Vietnam Pro" pitchFamily="34" charset="-122"/>
+                <a:cs typeface="Be Vietnam Pro" pitchFamily="34" charset="-120"/>
+              </a:rPr>
+              <a:t> mã</a:t>
+            </a:r>
+            <a:r>
               <a:rPr lang="en-US" sz="2400" dirty="0" spc="1" kern="0">
                 <a:solidFill>
                   <a:srgbClr val="C4C8D6"/>
@@ -3257,18 +3268,7 @@
                 <a:ea typeface="Be Vietnam Pro" pitchFamily="34" charset="-122"/>
                 <a:cs typeface="Be Vietnam Pro" pitchFamily="34" charset="-120"/>
               </a:rPr>
-              <a:t> lúc</a:t>
-            </a:r>
-            <a:r>
-              <a:rPr lang="en-US" sz="2400" dirty="0" spc="-6" kern="0">
-                <a:solidFill>
-                  <a:srgbClr val="C4C8D6"/>
-                </a:solidFill>
-                <a:latin typeface="Be Vietnam Pro" pitchFamily="34" charset="0"/>
-                <a:ea typeface="Be Vietnam Pro" pitchFamily="34" charset="-122"/>
-                <a:cs typeface="Be Vietnam Pro" pitchFamily="34" charset="-120"/>
-              </a:rPr>
-              <a:t> chạy.</a:t>
+              <a:t> nguồn.</a:t>
             </a:r>
             <a:endParaRPr lang="en-US" sz="2400" dirty="0"/>
           </a:p>
@@ -4580,6 +4580,28 @@
               <a:t>JVM</a:t>
             </a:r>
             <a:r>
+              <a:rPr lang="en-US" sz="2250" dirty="0" spc="1" kern="0">
+                <a:solidFill>
+                  <a:srgbClr val="14161C"/>
+                </a:solidFill>
+                <a:latin typeface="Be Vietnam Pro" pitchFamily="34" charset="0"/>
+                <a:ea typeface="Be Vietnam Pro" pitchFamily="34" charset="-122"/>
+                <a:cs typeface="Be Vietnam Pro" pitchFamily="34" charset="-120"/>
+              </a:rPr>
+              <a:t> nạp</a:t>
+            </a:r>
+            <a:r>
+              <a:rPr lang="en-US" sz="2250" dirty="0" spc="-16" kern="0">
+                <a:solidFill>
+                  <a:srgbClr val="14161C"/>
+                </a:solidFill>
+                <a:latin typeface="Be Vietnam Pro" pitchFamily="34" charset="0"/>
+                <a:ea typeface="Be Vietnam Pro" pitchFamily="34" charset="-122"/>
+                <a:cs typeface="Be Vietnam Pro" pitchFamily="34" charset="-120"/>
+              </a:rPr>
+              <a:t> và</a:t>
+            </a:r>
+            <a:r>
               <a:rPr lang="en-US" sz="2250" dirty="0" spc="-6" kern="0">
                 <a:solidFill>
                   <a:srgbClr val="14161C"/>
@@ -4589,39 +4611,6 @@
                 <a:cs typeface="Be Vietnam Pro" pitchFamily="34" charset="-120"/>
               </a:rPr>
               <a:t> chạy</a:t>
-            </a:r>
-            <a:r>
-              <a:rPr lang="en-US" sz="2250" dirty="0" spc="4" kern="0">
-                <a:solidFill>
-                  <a:srgbClr val="14161C"/>
-                </a:solidFill>
-                <a:latin typeface="Be Vietnam Pro" pitchFamily="34" charset="0"/>
-                <a:ea typeface="Be Vietnam Pro" pitchFamily="34" charset="-122"/>
-                <a:cs typeface="Be Vietnam Pro" pitchFamily="34" charset="-120"/>
-              </a:rPr>
-              <a:t> chương</a:t>
-            </a:r>
-            <a:r>
-              <a:rPr lang="en-US" sz="2250" dirty="0" spc="7" kern="0">
-                <a:solidFill>
-                  <a:srgbClr val="14161C"/>
-                </a:solidFill>
-                <a:latin typeface="Be Vietnam Pro" pitchFamily="34" charset="0"/>
-                <a:ea typeface="Be Vietnam Pro" pitchFamily="34" charset="-122"/>
-                <a:cs typeface="Be Vietnam Pro" pitchFamily="34" charset="-120"/>
-              </a:rPr>
-              <a:t> trình</a:t>
-            </a:r>
-            <a:r>
-              <a:rPr lang="en-US" sz="2250" dirty="0" spc="4" kern="0">
-                <a:solidFill>
-                  <a:srgbClr val="14161C"/>
-                </a:solidFill>
-                <a:latin typeface="Be Vietnam Pro" pitchFamily="34" charset="0"/>
-                <a:ea typeface="Be Vietnam Pro" pitchFamily="34" charset="-122"/>
-                <a:cs typeface="Be Vietnam Pro" pitchFamily="34" charset="-120"/>
-              </a:rPr>
-              <a:t> từ</a:t>
             </a:r>
             <a:r>
               <a:rPr lang="en-US" sz="2250" dirty="0" spc="-9" kern="0">
@@ -4880,18 +4869,29 @@
                 <a:ea typeface="Be Vietnam Pro" pitchFamily="34" charset="-122"/>
                 <a:cs typeface="Be Vietnam Pro" pitchFamily="34" charset="-120"/>
               </a:rPr>
-              <a:t> lúc</a:t>
-            </a:r>
-            <a:r>
-              <a:rPr lang="en-US" sz="2250" dirty="0" spc="-5" kern="0">
-                <a:solidFill>
-                  <a:srgbClr val="14161C"/>
-                </a:solidFill>
-                <a:latin typeface="Be Vietnam Pro" pitchFamily="34" charset="0"/>
-                <a:ea typeface="Be Vietnam Pro" pitchFamily="34" charset="-122"/>
-                <a:cs typeface="Be Vietnam Pro" pitchFamily="34" charset="-120"/>
-              </a:rPr>
-              <a:t> chạy.</a:t>
+              <a:t> từ</a:t>
+            </a:r>
+            <a:r>
+              <a:rPr lang="en-US" sz="2250" dirty="0" spc="-2" kern="0">
+                <a:solidFill>
+                  <a:srgbClr val="14161C"/>
+                </a:solidFill>
+                <a:latin typeface="Be Vietnam Pro" pitchFamily="34" charset="0"/>
+                <a:ea typeface="Be Vietnam Pro" pitchFamily="34" charset="-122"/>
+                <a:cs typeface="Be Vietnam Pro" pitchFamily="34" charset="-120"/>
+              </a:rPr>
+              <a:t> mã</a:t>
+            </a:r>
+            <a:r>
+              <a:rPr lang="en-US" sz="2250" dirty="0" spc="2" kern="0">
+                <a:solidFill>
+                  <a:srgbClr val="14161C"/>
+                </a:solidFill>
+                <a:latin typeface="Be Vietnam Pro" pitchFamily="34" charset="0"/>
+                <a:ea typeface="Be Vietnam Pro" pitchFamily="34" charset="-122"/>
+                <a:cs typeface="Be Vietnam Pro" pitchFamily="34" charset="-120"/>
+              </a:rPr>
+              <a:t> nguồn.</a:t>
             </a:r>
             <a:endParaRPr lang="en-US" sz="2250" dirty="0"/>
           </a:p>
@@ -5789,7 +5789,7 @@
               <a:buNone/>
             </a:pPr>
             <a:r>
-              <a:rPr lang="en-US" sz="2850" dirty="0" spc="-28" kern="0">
+              <a:rPr lang="en-US" sz="2850" dirty="0" spc="6" kern="0">
                 <a:solidFill>
                   <a:srgbClr val="F3EEE3"/>
                 </a:solidFill>
@@ -5797,7 +5797,84 @@
                 <a:ea typeface="Be Vietnam Pro" pitchFamily="34" charset="-122"/>
                 <a:cs typeface="Be Vietnam Pro" pitchFamily="34" charset="-120"/>
               </a:rPr>
-              <a:t>Trình</a:t>
+              <a:t>Chương</a:t>
+            </a:r>
+            <a:r>
+              <a:rPr lang="en-US" sz="2850" dirty="0" spc="10" kern="0">
+                <a:solidFill>
+                  <a:srgbClr val="F3EEE3"/>
+                </a:solidFill>
+                <a:latin typeface="Be Vietnam Pro" pitchFamily="34" charset="0"/>
+                <a:ea typeface="Be Vietnam Pro" pitchFamily="34" charset="-122"/>
+                <a:cs typeface="Be Vietnam Pro" pitchFamily="34" charset="-120"/>
+              </a:rPr>
+              <a:t> trình</a:t>
+            </a:r>
+            <a:r>
+              <a:rPr lang="en-US" sz="2850" dirty="0" spc="-2" kern="0">
+                <a:solidFill>
+                  <a:srgbClr val="F3EEE3"/>
+                </a:solidFill>
+                <a:latin typeface="Be Vietnam Pro" pitchFamily="34" charset="0"/>
+                <a:ea typeface="Be Vietnam Pro" pitchFamily="34" charset="-122"/>
+                <a:cs typeface="Be Vietnam Pro" pitchFamily="34" charset="-120"/>
+              </a:rPr>
+              <a:t> thành</a:t>
+            </a:r>
+            <a:r>
+              <a:rPr lang="en-US" sz="2850" dirty="0" spc="0" kern="0">
+                <a:solidFill>
+                  <a:srgbClr val="F3EEE3"/>
+                </a:solidFill>
+                <a:latin typeface="Be Vietnam Pro" pitchFamily="34" charset="0"/>
+                <a:ea typeface="Be Vietnam Pro" pitchFamily="34" charset="-122"/>
+                <a:cs typeface="Be Vietnam Pro" pitchFamily="34" charset="-120"/>
+              </a:rPr>
+              <a:t> mã</a:t>
+            </a:r>
+            <a:r>
+              <a:rPr lang="en-US" sz="2850" dirty="0" spc="-11" kern="0">
+                <a:solidFill>
+                  <a:srgbClr val="F3EEE3"/>
+                </a:solidFill>
+                <a:latin typeface="Be Vietnam Pro" pitchFamily="34" charset="0"/>
+                <a:ea typeface="Be Vietnam Pro" pitchFamily="34" charset="-122"/>
+                <a:cs typeface="Be Vietnam Pro" pitchFamily="34" charset="-120"/>
+              </a:rPr>
+              <a:t> máy</a:t>
+            </a:r>
+            <a:r>
+              <a:rPr lang="en-US" sz="2850" dirty="0" spc="7" kern="0">
+                <a:solidFill>
+                  <a:srgbClr val="F3EEE3"/>
+                </a:solidFill>
+                <a:latin typeface="Be Vietnam Pro" pitchFamily="34" charset="0"/>
+                <a:ea typeface="Be Vietnam Pro" pitchFamily="34" charset="-122"/>
+                <a:cs typeface="Be Vietnam Pro" pitchFamily="34" charset="-120"/>
+              </a:rPr>
+              <a:t> trước</a:t>
+            </a:r>
+            <a:r>
+              <a:rPr lang="en-US" sz="2850" dirty="0" spc="1" kern="0">
+                <a:solidFill>
+                  <a:srgbClr val="F3EEE3"/>
+                </a:solidFill>
+                <a:latin typeface="Be Vietnam Pro" pitchFamily="34" charset="0"/>
+                <a:ea typeface="Be Vietnam Pro" pitchFamily="34" charset="-122"/>
+                <a:cs typeface="Be Vietnam Pro" pitchFamily="34" charset="-120"/>
+              </a:rPr>
+              <a:t> khi</a:t>
+            </a:r>
+            <a:r>
+              <a:rPr lang="en-US" sz="2850" dirty="0" spc="-7" kern="0">
+                <a:solidFill>
+                  <a:srgbClr val="F3EEE3"/>
+                </a:solidFill>
+                <a:latin typeface="Be Vietnam Pro" pitchFamily="34" charset="0"/>
+                <a:ea typeface="Be Vietnam Pro" pitchFamily="34" charset="-122"/>
+                <a:cs typeface="Be Vietnam Pro" pitchFamily="34" charset="-120"/>
+              </a:rPr>
+              <a:t> chạy.</a:t>
             </a:r>
             <a:r>
               <a:rPr lang="en-US" sz="2850" dirty="0" spc="-1" kern="0">
@@ -5808,7 +5885,62 @@
                 <a:ea typeface="Be Vietnam Pro" pitchFamily="34" charset="-122"/>
                 <a:cs typeface="Be Vietnam Pro" pitchFamily="34" charset="-120"/>
               </a:rPr>
-              <a:t> biên dịch</a:t>
+              <a:t> Bộ</a:t>
+            </a:r>
+            <a:r>
+              <a:rPr lang="en-US" sz="2850" dirty="0" spc="3" kern="0">
+                <a:solidFill>
+                  <a:srgbClr val="F3EEE3"/>
+                </a:solidFill>
+                <a:latin typeface="Be Vietnam Pro" pitchFamily="34" charset="0"/>
+                <a:ea typeface="Be Vietnam Pro" pitchFamily="34" charset="-122"/>
+                <a:cs typeface="Be Vietnam Pro" pitchFamily="34" charset="-120"/>
+              </a:rPr>
+              <a:t> xử</a:t>
+            </a:r>
+            <a:r>
+              <a:rPr lang="en-US" sz="2850" dirty="0" spc="2" kern="0">
+                <a:solidFill>
+                  <a:srgbClr val="F3EEE3"/>
+                </a:solidFill>
+                <a:latin typeface="Be Vietnam Pro" pitchFamily="34" charset="0"/>
+                <a:ea typeface="Be Vietnam Pro" pitchFamily="34" charset="-122"/>
+                <a:cs typeface="Be Vietnam Pro" pitchFamily="34" charset="-120"/>
+              </a:rPr>
+              <a:t> lý</a:t>
+            </a:r>
+            <a:r>
+              <a:rPr lang="en-US" sz="2850" dirty="0" spc="7" kern="0">
+                <a:solidFill>
+                  <a:srgbClr val="F3EEE3"/>
+                </a:solidFill>
+                <a:latin typeface="Be Vietnam Pro" pitchFamily="34" charset="0"/>
+                <a:ea typeface="Be Vietnam Pro" pitchFamily="34" charset="-122"/>
+                <a:cs typeface="Be Vietnam Pro" pitchFamily="34" charset="-120"/>
+              </a:rPr>
+              <a:t> thực</a:t>
+            </a:r>
+            <a:r>
+              <a:rPr lang="en-US" sz="2850" dirty="0" spc="1" kern="0">
+                <a:solidFill>
+                  <a:srgbClr val="F3EEE3"/>
+                </a:solidFill>
+                <a:latin typeface="Be Vietnam Pro" pitchFamily="34" charset="0"/>
+                <a:ea typeface="Be Vietnam Pro" pitchFamily="34" charset="-122"/>
+                <a:cs typeface="Be Vietnam Pro" pitchFamily="34" charset="-120"/>
+              </a:rPr>
+              <a:t> thi</a:t>
+            </a:r>
+            <a:r>
+              <a:rPr lang="en-US" sz="2850" dirty="0" spc="-2" kern="0">
+                <a:solidFill>
+                  <a:srgbClr val="F3EEE3"/>
+                </a:solidFill>
+                <a:latin typeface="Be Vietnam Pro" pitchFamily="34" charset="0"/>
+                <a:ea typeface="Be Vietnam Pro" pitchFamily="34" charset="-122"/>
+                <a:cs typeface="Be Vietnam Pro" pitchFamily="34" charset="-120"/>
+              </a:rPr>
+              <a:t> thẳng</a:t>
             </a:r>
             <a:r>
               <a:rPr lang="en-US" sz="2850" dirty="0" spc="0" kern="0">
@@ -5819,10 +5951,10 @@
                 <a:ea typeface="Be Vietnam Pro" pitchFamily="34" charset="-122"/>
                 <a:cs typeface="Be Vietnam Pro" pitchFamily="34" charset="-120"/>
               </a:rPr>
-              <a:t> dịch</a:t>
-            </a:r>
-            <a:r>
-              <a:rPr lang="en-US" sz="2850" dirty="0" spc="-1" kern="0">
+              <a:t> mã</a:t>
+            </a:r>
+            <a:r>
+              <a:rPr lang="en-US" sz="2850" dirty="0" spc="-9" kern="0">
                 <a:solidFill>
                   <a:srgbClr val="F3EEE3"/>
                 </a:solidFill>
@@ -5830,128 +5962,7 @@
                 <a:ea typeface="Be Vietnam Pro" pitchFamily="34" charset="-122"/>
                 <a:cs typeface="Be Vietnam Pro" pitchFamily="34" charset="-120"/>
               </a:rPr>
-              <a:t> mã</a:t>
-            </a:r>
-            <a:r>
-              <a:rPr lang="en-US" sz="2850" dirty="0" spc="-2" kern="0">
-                <a:solidFill>
-                  <a:srgbClr val="F3EEE3"/>
-                </a:solidFill>
-                <a:latin typeface="Be Vietnam Pro" pitchFamily="34" charset="0"/>
-                <a:ea typeface="Be Vietnam Pro" pitchFamily="34" charset="-122"/>
-                <a:cs typeface="Be Vietnam Pro" pitchFamily="34" charset="-120"/>
-              </a:rPr>
-              <a:t> nguồn</a:t>
-            </a:r>
-            <a:r>
-              <a:rPr lang="en-US" sz="2850" dirty="0" spc="-1" kern="0">
-                <a:solidFill>
-                  <a:srgbClr val="F3EEE3"/>
-                </a:solidFill>
-                <a:latin typeface="Be Vietnam Pro" pitchFamily="34" charset="0"/>
-                <a:ea typeface="Be Vietnam Pro" pitchFamily="34" charset="-122"/>
-                <a:cs typeface="Be Vietnam Pro" pitchFamily="34" charset="-120"/>
-              </a:rPr>
-              <a:t> thành mã</a:t>
-            </a:r>
-            <a:r>
-              <a:rPr lang="en-US" sz="2850" dirty="0" spc="-8" kern="0">
-                <a:solidFill>
-                  <a:srgbClr val="F3EEE3"/>
-                </a:solidFill>
-                <a:latin typeface="Be Vietnam Pro" pitchFamily="34" charset="0"/>
-                <a:ea typeface="Be Vietnam Pro" pitchFamily="34" charset="-122"/>
-                <a:cs typeface="Be Vietnam Pro" pitchFamily="34" charset="-120"/>
-              </a:rPr>
               <a:t> máy.</a:t>
-            </a:r>
-            <a:r>
-              <a:rPr lang="en-US" sz="2850" dirty="0" spc="2" kern="0">
-                <a:solidFill>
-                  <a:srgbClr val="F3EEE3"/>
-                </a:solidFill>
-                <a:latin typeface="Be Vietnam Pro" pitchFamily="34" charset="0"/>
-                <a:ea typeface="Be Vietnam Pro" pitchFamily="34" charset="-122"/>
-                <a:cs typeface="Be Vietnam Pro" pitchFamily="34" charset="-120"/>
-              </a:rPr>
-              <a:t> Sau</a:t>
-            </a:r>
-            <a:r>
-              <a:rPr lang="en-US" sz="2850" dirty="0" spc="19" kern="0">
-                <a:solidFill>
-                  <a:srgbClr val="F3EEE3"/>
-                </a:solidFill>
-                <a:latin typeface="Be Vietnam Pro" pitchFamily="34" charset="0"/>
-                <a:ea typeface="Be Vietnam Pro" pitchFamily="34" charset="-122"/>
-                <a:cs typeface="Be Vietnam Pro" pitchFamily="34" charset="-120"/>
-              </a:rPr>
-              <a:t> đó</a:t>
-            </a:r>
-            <a:r>
-              <a:rPr lang="en-US" sz="2850" dirty="0" spc="1" kern="0">
-                <a:solidFill>
-                  <a:srgbClr val="F3EEE3"/>
-                </a:solidFill>
-                <a:latin typeface="Be Vietnam Pro" pitchFamily="34" charset="0"/>
-                <a:ea typeface="Be Vietnam Pro" pitchFamily="34" charset="-122"/>
-                <a:cs typeface="Be Vietnam Pro" pitchFamily="34" charset="-120"/>
-              </a:rPr>
-              <a:t> CPU</a:t>
-            </a:r>
-            <a:r>
-              <a:rPr lang="en-US" sz="2850" dirty="0" spc="-9" kern="0">
-                <a:solidFill>
-                  <a:srgbClr val="F3EEE3"/>
-                </a:solidFill>
-                <a:latin typeface="Be Vietnam Pro" pitchFamily="34" charset="0"/>
-                <a:ea typeface="Be Vietnam Pro" pitchFamily="34" charset="-122"/>
-                <a:cs typeface="Be Vietnam Pro" pitchFamily="34" charset="-120"/>
-              </a:rPr>
-              <a:t> chạy</a:t>
-            </a:r>
-            <a:r>
-              <a:rPr lang="en-US" sz="2850" dirty="0" spc="0" kern="0">
-                <a:solidFill>
-                  <a:srgbClr val="F3EEE3"/>
-                </a:solidFill>
-                <a:latin typeface="Be Vietnam Pro" pitchFamily="34" charset="0"/>
-                <a:ea typeface="Be Vietnam Pro" pitchFamily="34" charset="-122"/>
-                <a:cs typeface="Be Vietnam Pro" pitchFamily="34" charset="-120"/>
-              </a:rPr>
-              <a:t> mã</a:t>
-            </a:r>
-            <a:r>
-              <a:rPr lang="en-US" sz="2850" dirty="0" spc="-11" kern="0">
-                <a:solidFill>
-                  <a:srgbClr val="F3EEE3"/>
-                </a:solidFill>
-                <a:latin typeface="Be Vietnam Pro" pitchFamily="34" charset="0"/>
-                <a:ea typeface="Be Vietnam Pro" pitchFamily="34" charset="-122"/>
-                <a:cs typeface="Be Vietnam Pro" pitchFamily="34" charset="-120"/>
-              </a:rPr>
-              <a:t> máy</a:t>
-            </a:r>
-            <a:r>
-              <a:rPr lang="en-US" sz="2850" dirty="0" spc="8" kern="0">
-                <a:solidFill>
-                  <a:srgbClr val="F3EEE3"/>
-                </a:solidFill>
-                <a:latin typeface="Be Vietnam Pro" pitchFamily="34" charset="0"/>
-                <a:ea typeface="Be Vietnam Pro" pitchFamily="34" charset="-122"/>
-                <a:cs typeface="Be Vietnam Pro" pitchFamily="34" charset="-120"/>
-              </a:rPr>
-              <a:t> trực</a:t>
-            </a:r>
-            <a:r>
-              <a:rPr lang="en-US" sz="2850" dirty="0" spc="0" kern="0">
-                <a:solidFill>
-                  <a:srgbClr val="F3EEE3"/>
-                </a:solidFill>
-                <a:latin typeface="Be Vietnam Pro" pitchFamily="34" charset="0"/>
-                <a:ea typeface="Be Vietnam Pro" pitchFamily="34" charset="-122"/>
-                <a:cs typeface="Be Vietnam Pro" pitchFamily="34" charset="-120"/>
-              </a:rPr>
-              <a:t> tiếp.</a:t>
             </a:r>
             <a:endParaRPr lang="en-US" sz="2850" dirty="0"/>
           </a:p>
@@ -6154,6 +6165,149 @@
               <a:buNone/>
             </a:pPr>
             <a:r>
+              <a:rPr lang="en-US" sz="2550" dirty="0" spc="1" kern="0">
+                <a:solidFill>
+                  <a:srgbClr val="F3EEE3"/>
+                </a:solidFill>
+                <a:latin typeface="Be Vietnam Pro" pitchFamily="34" charset="0"/>
+                <a:ea typeface="Be Vietnam Pro" pitchFamily="34" charset="-122"/>
+                <a:cs typeface="Be Vietnam Pro" pitchFamily="34" charset="-120"/>
+              </a:rPr>
+              <a:t>Mã</a:t>
+            </a:r>
+            <a:r>
+              <a:rPr lang="en-US" sz="2550" dirty="0" spc="-9" kern="0">
+                <a:solidFill>
+                  <a:srgbClr val="F3EEE3"/>
+                </a:solidFill>
+                <a:latin typeface="Be Vietnam Pro" pitchFamily="34" charset="0"/>
+                <a:ea typeface="Be Vietnam Pro" pitchFamily="34" charset="-122"/>
+                <a:cs typeface="Be Vietnam Pro" pitchFamily="34" charset="-120"/>
+              </a:rPr>
+              <a:t> máy</a:t>
+            </a:r>
+            <a:r>
+              <a:rPr lang="en-US" sz="2550" dirty="0" spc="7" kern="0">
+                <a:solidFill>
+                  <a:srgbClr val="F3EEE3"/>
+                </a:solidFill>
+                <a:latin typeface="Be Vietnam Pro" pitchFamily="34" charset="0"/>
+                <a:ea typeface="Be Vietnam Pro" pitchFamily="34" charset="-122"/>
+                <a:cs typeface="Be Vietnam Pro" pitchFamily="34" charset="-120"/>
+              </a:rPr>
+              <a:t> được</a:t>
+            </a:r>
+            <a:r>
+              <a:rPr lang="en-US" sz="2550" dirty="0" spc="-5" kern="0">
+                <a:solidFill>
+                  <a:srgbClr val="F3EEE3"/>
+                </a:solidFill>
+                <a:latin typeface="Be Vietnam Pro" pitchFamily="34" charset="0"/>
+                <a:ea typeface="Be Vietnam Pro" pitchFamily="34" charset="-122"/>
+                <a:cs typeface="Be Vietnam Pro" pitchFamily="34" charset="-120"/>
+              </a:rPr>
+              <a:t> bộ</a:t>
+            </a:r>
+            <a:r>
+              <a:rPr lang="en-US" sz="2550" dirty="0" spc="-2" kern="0">
+                <a:solidFill>
+                  <a:srgbClr val="F3EEE3"/>
+                </a:solidFill>
+                <a:latin typeface="Be Vietnam Pro" pitchFamily="34" charset="0"/>
+                <a:ea typeface="Be Vietnam Pro" pitchFamily="34" charset="-122"/>
+                <a:cs typeface="Be Vietnam Pro" pitchFamily="34" charset="-120"/>
+              </a:rPr>
+              <a:t> xử</a:t>
+            </a:r>
+            <a:r>
+              <a:rPr lang="en-US" sz="2550" dirty="0" spc="0" kern="0">
+                <a:solidFill>
+                  <a:srgbClr val="F3EEE3"/>
+                </a:solidFill>
+                <a:latin typeface="Be Vietnam Pro" pitchFamily="34" charset="0"/>
+                <a:ea typeface="Be Vietnam Pro" pitchFamily="34" charset="-122"/>
+                <a:cs typeface="Be Vietnam Pro" pitchFamily="34" charset="-120"/>
+              </a:rPr>
+              <a:t> lý</a:t>
+            </a:r>
+            <a:r>
+              <a:rPr lang="en-US" sz="2550" dirty="0" spc="7" kern="0">
+                <a:solidFill>
+                  <a:srgbClr val="F3EEE3"/>
+                </a:solidFill>
+                <a:latin typeface="Be Vietnam Pro" pitchFamily="34" charset="0"/>
+                <a:ea typeface="Be Vietnam Pro" pitchFamily="34" charset="-122"/>
+                <a:cs typeface="Be Vietnam Pro" pitchFamily="34" charset="-120"/>
+              </a:rPr>
+              <a:t> thực</a:t>
+            </a:r>
+            <a:r>
+              <a:rPr lang="en-US" sz="2550" dirty="0" spc="0" kern="0">
+                <a:solidFill>
+                  <a:srgbClr val="F3EEE3"/>
+                </a:solidFill>
+                <a:latin typeface="Be Vietnam Pro" pitchFamily="34" charset="0"/>
+                <a:ea typeface="Be Vietnam Pro" pitchFamily="34" charset="-122"/>
+                <a:cs typeface="Be Vietnam Pro" pitchFamily="34" charset="-120"/>
+              </a:rPr>
+              <a:t> thi</a:t>
+            </a:r>
+            <a:r>
+              <a:rPr lang="en-US" sz="2550" dirty="0" spc="7" kern="0">
+                <a:solidFill>
+                  <a:srgbClr val="F3EEE3"/>
+                </a:solidFill>
+                <a:latin typeface="Be Vietnam Pro" pitchFamily="34" charset="0"/>
+                <a:ea typeface="Be Vietnam Pro" pitchFamily="34" charset="-122"/>
+                <a:cs typeface="Be Vietnam Pro" pitchFamily="34" charset="-120"/>
+              </a:rPr>
+              <a:t> trực</a:t>
+            </a:r>
+            <a:r>
+              <a:rPr lang="en-US" sz="2550" dirty="0" spc="0" kern="0">
+                <a:solidFill>
+                  <a:srgbClr val="F3EEE3"/>
+                </a:solidFill>
+                <a:latin typeface="Be Vietnam Pro" pitchFamily="34" charset="0"/>
+                <a:ea typeface="Be Vietnam Pro" pitchFamily="34" charset="-122"/>
+                <a:cs typeface="Be Vietnam Pro" pitchFamily="34" charset="-120"/>
+              </a:rPr>
+              <a:t> tiếp,</a:t>
+            </a:r>
+            <a:r>
+              <a:rPr lang="en-US" sz="2550" dirty="0" spc="1" kern="0">
+                <a:solidFill>
+                  <a:srgbClr val="F3EEE3"/>
+                </a:solidFill>
+                <a:latin typeface="Be Vietnam Pro" pitchFamily="34" charset="0"/>
+                <a:ea typeface="Be Vietnam Pro" pitchFamily="34" charset="-122"/>
+                <a:cs typeface="Be Vietnam Pro" pitchFamily="34" charset="-120"/>
+              </a:rPr>
+              <a:t> không</a:t>
+            </a:r>
+            <a:r>
+              <a:rPr lang="en-US" sz="2550" dirty="0" spc="0" kern="0">
+                <a:solidFill>
+                  <a:srgbClr val="F3EEE3"/>
+                </a:solidFill>
+                <a:latin typeface="Be Vietnam Pro" pitchFamily="34" charset="0"/>
+                <a:ea typeface="Be Vietnam Pro" pitchFamily="34" charset="-122"/>
+                <a:cs typeface="Be Vietnam Pro" pitchFamily="34" charset="-120"/>
+              </a:rPr>
+              <a:t> cần</a:t>
+            </a:r>
+            <a:r>
+              <a:rPr lang="en-US" sz="2550" dirty="0" spc="6" kern="0">
+                <a:solidFill>
+                  <a:srgbClr val="F3EEE3"/>
+                </a:solidFill>
+                <a:latin typeface="Be Vietnam Pro" pitchFamily="34" charset="0"/>
+                <a:ea typeface="Be Vietnam Pro" pitchFamily="34" charset="-122"/>
+                <a:cs typeface="Be Vietnam Pro" pitchFamily="34" charset="-120"/>
+              </a:rPr>
+              <a:t> bước</a:t>
+            </a:r>
+            <a:r>
               <a:rPr lang="en-US" sz="2550" dirty="0" spc="2" kern="0">
                 <a:solidFill>
                   <a:srgbClr val="F3EEE3"/>
@@ -6162,10 +6316,10 @@
                 <a:ea typeface="Be Vietnam Pro" pitchFamily="34" charset="-122"/>
                 <a:cs typeface="Be Vietnam Pro" pitchFamily="34" charset="-120"/>
               </a:rPr>
-              <a:t>Nguồn</a:t>
-            </a:r>
-            <a:r>
-              <a:rPr lang="en-US" sz="2550" dirty="0" spc="-33" kern="0">
+              <a:t> trung</a:t>
+            </a:r>
+            <a:r>
+              <a:rPr lang="en-US" sz="2550" dirty="0" spc="0" kern="0">
                 <a:solidFill>
                   <a:srgbClr val="F3EEE3"/>
                 </a:solidFill>
@@ -6173,117 +6327,7 @@
                 <a:ea typeface="Be Vietnam Pro" pitchFamily="34" charset="-122"/>
                 <a:cs typeface="Be Vietnam Pro" pitchFamily="34" charset="-120"/>
               </a:rPr>
-              <a:t> kết</a:t>
-            </a:r>
-            <a:r>
-              <a:rPr lang="en-US" sz="2550" dirty="0" spc="2" kern="0">
-                <a:solidFill>
-                  <a:srgbClr val="F3EEE3"/>
-                </a:solidFill>
-                <a:latin typeface="Be Vietnam Pro" pitchFamily="34" charset="0"/>
-                <a:ea typeface="Be Vietnam Pro" pitchFamily="34" charset="-122"/>
-                <a:cs typeface="Be Vietnam Pro" pitchFamily="34" charset="-120"/>
-              </a:rPr>
-              <a:t> luận:</a:t>
-            </a:r>
-            <a:r>
-              <a:rPr lang="en-US" sz="2550" dirty="0" spc="0" kern="0">
-                <a:solidFill>
-                  <a:srgbClr val="F3EEE3"/>
-                </a:solidFill>
-                <a:latin typeface="Be Vietnam Pro" pitchFamily="34" charset="0"/>
-                <a:ea typeface="Be Vietnam Pro" pitchFamily="34" charset="-122"/>
-                <a:cs typeface="Be Vietnam Pro" pitchFamily="34" charset="-120"/>
-              </a:rPr>
-              <a:t> nhìn</a:t>
-            </a:r>
-            <a:r>
-              <a:rPr lang="en-US" sz="2550" dirty="0" spc="1" kern="0">
-                <a:solidFill>
-                  <a:srgbClr val="F3EEE3"/>
-                </a:solidFill>
-                <a:latin typeface="Be Vietnam Pro" pitchFamily="34" charset="0"/>
-                <a:ea typeface="Be Vietnam Pro" pitchFamily="34" charset="-122"/>
-                <a:cs typeface="Be Vietnam Pro" pitchFamily="34" charset="-120"/>
-              </a:rPr>
-              <a:t> chung</a:t>
-            </a:r>
-            <a:r>
-              <a:rPr lang="en-US" sz="2550" dirty="0" spc="-11" kern="0">
-                <a:solidFill>
-                  <a:srgbClr val="F3EEE3"/>
-                </a:solidFill>
-                <a:latin typeface="Be Vietnam Pro" pitchFamily="34" charset="0"/>
-                <a:ea typeface="Be Vietnam Pro" pitchFamily="34" charset="-122"/>
-                <a:cs typeface="Be Vietnam Pro" pitchFamily="34" charset="-120"/>
-              </a:rPr>
-              <a:t> ngôn</a:t>
-            </a:r>
-            <a:r>
-              <a:rPr lang="en-US" sz="2550" dirty="0" spc="-1" kern="0">
-                <a:solidFill>
-                  <a:srgbClr val="F3EEE3"/>
-                </a:solidFill>
-                <a:latin typeface="Be Vietnam Pro" pitchFamily="34" charset="0"/>
-                <a:ea typeface="Be Vietnam Pro" pitchFamily="34" charset="-122"/>
-                <a:cs typeface="Be Vietnam Pro" pitchFamily="34" charset="-120"/>
-              </a:rPr>
-              <a:t> ngữ</a:t>
-            </a:r>
-            <a:r>
-              <a:rPr lang="en-US" sz="2550" dirty="0" spc="0" kern="0">
-                <a:solidFill>
-                  <a:srgbClr val="F3EEE3"/>
-                </a:solidFill>
-                <a:latin typeface="Be Vietnam Pro" pitchFamily="34" charset="0"/>
-                <a:ea typeface="Be Vietnam Pro" pitchFamily="34" charset="-122"/>
-                <a:cs typeface="Be Vietnam Pro" pitchFamily="34" charset="-120"/>
-              </a:rPr>
-              <a:t> biên dịch</a:t>
-            </a:r>
-            <a:r>
-              <a:rPr lang="en-US" sz="2550" dirty="0" spc="-7" kern="0">
-                <a:solidFill>
-                  <a:srgbClr val="F3EEE3"/>
-                </a:solidFill>
-                <a:latin typeface="Be Vietnam Pro" pitchFamily="34" charset="0"/>
-                <a:ea typeface="Be Vietnam Pro" pitchFamily="34" charset="-122"/>
-                <a:cs typeface="Be Vietnam Pro" pitchFamily="34" charset="-120"/>
-              </a:rPr>
-              <a:t> chạy</a:t>
-            </a:r>
-            <a:r>
-              <a:rPr lang="en-US" sz="2550" dirty="0" spc="-1" kern="0">
-                <a:solidFill>
-                  <a:srgbClr val="F3EEE3"/>
-                </a:solidFill>
-                <a:latin typeface="Be Vietnam Pro" pitchFamily="34" charset="0"/>
-                <a:ea typeface="Be Vietnam Pro" pitchFamily="34" charset="-122"/>
-                <a:cs typeface="Be Vietnam Pro" pitchFamily="34" charset="-120"/>
-              </a:rPr>
-              <a:t> nhanh hơn</a:t>
-            </a:r>
-            <a:r>
-              <a:rPr lang="en-US" sz="2550" dirty="0" spc="0" kern="0">
-                <a:solidFill>
-                  <a:srgbClr val="F3EEE3"/>
-                </a:solidFill>
-                <a:latin typeface="Be Vietnam Pro" pitchFamily="34" charset="0"/>
-                <a:ea typeface="Be Vietnam Pro" pitchFamily="34" charset="-122"/>
-                <a:cs typeface="Be Vietnam Pro" pitchFamily="34" charset="-120"/>
-              </a:rPr>
-              <a:t> thông</a:t>
-            </a:r>
-            <a:r>
-              <a:rPr lang="en-US" sz="2550" dirty="0" spc="1" kern="0">
-                <a:solidFill>
-                  <a:srgbClr val="F3EEE3"/>
-                </a:solidFill>
-                <a:latin typeface="Be Vietnam Pro" pitchFamily="34" charset="0"/>
-                <a:ea typeface="Be Vietnam Pro" pitchFamily="34" charset="-122"/>
-                <a:cs typeface="Be Vietnam Pro" pitchFamily="34" charset="-120"/>
-              </a:rPr>
-              <a:t> dịch.</a:t>
+              <a:t> gian.</a:t>
             </a:r>
             <a:endParaRPr lang="en-US" sz="2550" dirty="0"/>
           </a:p>
@@ -6495,7 +6539,7 @@
               <a:buNone/>
             </a:pPr>
             <a:r>
-              <a:rPr lang="en-US" sz="3450" b="1" dirty="0" spc="-24" kern="0">
+              <a:rPr lang="en-US" sz="3450" b="1" dirty="0" spc="-8" kern="0">
                 <a:solidFill>
                   <a:srgbClr val="F3EEE3"/>
                 </a:solidFill>
@@ -6503,10 +6547,10 @@
                 <a:ea typeface="Be Vietnam Pro" pitchFamily="34" charset="-122"/>
                 <a:cs typeface="Be Vietnam Pro" pitchFamily="34" charset="-120"/>
               </a:rPr>
-              <a:t>Trình</a:t>
-            </a:r>
-            <a:r>
-              <a:rPr lang="en-US" sz="3450" b="1" dirty="0" spc="-4" kern="0">
+              <a:t>Biên</a:t>
+            </a:r>
+            <a:r>
+              <a:rPr lang="en-US" sz="3450" b="1" dirty="0" spc="1" kern="0">
                 <a:solidFill>
                   <a:srgbClr val="F3EEE3"/>
                 </a:solidFill>
@@ -6514,10 +6558,10 @@
                 <a:ea typeface="Be Vietnam Pro" pitchFamily="34" charset="-122"/>
                 <a:cs typeface="Be Vietnam Pro" pitchFamily="34" charset="-120"/>
               </a:rPr>
-              <a:t> biên</a:t>
-            </a:r>
-            <a:r>
-              <a:rPr lang="en-US" sz="3450" b="1" dirty="0" spc="2" kern="0">
+              <a:t> dịch</a:t>
+            </a:r>
+            <a:r>
+              <a:rPr lang="en-US" sz="3450" b="1" dirty="0" spc="13" kern="0">
                 <a:solidFill>
                   <a:srgbClr val="F3EEE3"/>
                 </a:solidFill>
@@ -6525,7 +6569,7 @@
                 <a:ea typeface="Be Vietnam Pro" pitchFamily="34" charset="-122"/>
                 <a:cs typeface="Be Vietnam Pro" pitchFamily="34" charset="-120"/>
               </a:rPr>
-              <a:t> dịch</a:t>
+              <a:t> trước</a:t>
             </a:r>
             <a:endParaRPr lang="en-US" sz="3450" dirty="0"/>
           </a:p>
@@ -6567,10 +6611,10 @@
                 <a:ea typeface="Be Vietnam Pro" pitchFamily="34" charset="-122"/>
                 <a:cs typeface="Be Vietnam Pro" pitchFamily="34" charset="-120"/>
               </a:rPr>
-              <a:t>Dịch</a:t>
-            </a:r>
-            <a:r>
-              <a:rPr lang="en-US" sz="2550" dirty="0" spc="2" kern="0">
+              <a:t>Thành</a:t>
+            </a:r>
+            <a:r>
+              <a:rPr lang="en-US" sz="2550" dirty="0" spc="1" kern="0">
                 <a:solidFill>
                   <a:srgbClr val="C4C8D6"/>
                 </a:solidFill>
@@ -6581,7 +6625,7 @@
               <a:t> mã</a:t>
             </a:r>
             <a:r>
-              <a:rPr lang="en-US" sz="2550" dirty="0" spc="1" kern="0">
+              <a:rPr lang="en-US" sz="2550" dirty="0" spc="-7" kern="0">
                 <a:solidFill>
                   <a:srgbClr val="C4C8D6"/>
                 </a:solidFill>
@@ -6589,10 +6633,10 @@
                 <a:ea typeface="Be Vietnam Pro" pitchFamily="34" charset="-122"/>
                 <a:cs typeface="Be Vietnam Pro" pitchFamily="34" charset="-120"/>
               </a:rPr>
-              <a:t> nguồn</a:t>
-            </a:r>
-            <a:r>
-              <a:rPr lang="en-US" sz="2550" dirty="0" spc="0" kern="0">
+              <a:t> máy,</a:t>
+            </a:r>
+            <a:r>
+              <a:rPr lang="en-US" sz="2550" dirty="0" spc="6" kern="0">
                 <a:solidFill>
                   <a:srgbClr val="C4C8D6"/>
                 </a:solidFill>
@@ -6600,10 +6644,10 @@
                 <a:ea typeface="Be Vietnam Pro" pitchFamily="34" charset="-122"/>
                 <a:cs typeface="Be Vietnam Pro" pitchFamily="34" charset="-120"/>
               </a:rPr>
-              <a:t> thành</a:t>
-            </a:r>
-            <a:r>
-              <a:rPr lang="en-US" sz="2550" dirty="0" spc="1" kern="0">
+              <a:t> trước</a:t>
+            </a:r>
+            <a:r>
+              <a:rPr lang="en-US" sz="2550" dirty="0" spc="-1" kern="0">
                 <a:solidFill>
                   <a:srgbClr val="C4C8D6"/>
                 </a:solidFill>
@@ -6611,7 +6655,7 @@
                 <a:ea typeface="Be Vietnam Pro" pitchFamily="34" charset="-122"/>
                 <a:cs typeface="Be Vietnam Pro" pitchFamily="34" charset="-120"/>
               </a:rPr>
-              <a:t> mã</a:t>
+              <a:t> khi</a:t>
             </a:r>
             <a:r>
               <a:rPr lang="en-US" sz="2550" dirty="0" spc="-6" kern="0">
@@ -6622,7 +6666,7 @@
                 <a:ea typeface="Be Vietnam Pro" pitchFamily="34" charset="-122"/>
                 <a:cs typeface="Be Vietnam Pro" pitchFamily="34" charset="-120"/>
               </a:rPr>
-              <a:t> máy.</a:t>
+              <a:t> chạy.</a:t>
             </a:r>
             <a:endParaRPr lang="en-US" sz="2550" dirty="0"/>
           </a:p>
@@ -6798,7 +6842,7 @@
               <a:buNone/>
             </a:pPr>
             <a:r>
-              <a:rPr lang="en-US" sz="3450" b="1" dirty="0" spc="2" kern="0">
+              <a:rPr lang="en-US" sz="3450" b="1" dirty="0" spc="-4" kern="0">
                 <a:solidFill>
                   <a:srgbClr val="F3EEE3"/>
                 </a:solidFill>
@@ -6806,7 +6850,29 @@
                 <a:ea typeface="Be Vietnam Pro" pitchFamily="34" charset="-122"/>
                 <a:cs typeface="Be Vietnam Pro" pitchFamily="34" charset="-120"/>
               </a:rPr>
-              <a:t>CPU</a:t>
+              <a:t>Bộ</a:t>
+            </a:r>
+            <a:r>
+              <a:rPr lang="en-US" sz="3450" b="1" dirty="0" spc="0" kern="0">
+                <a:solidFill>
+                  <a:srgbClr val="F3EEE3"/>
+                </a:solidFill>
+                <a:latin typeface="Be Vietnam Pro" pitchFamily="34" charset="0"/>
+                <a:ea typeface="Be Vietnam Pro" pitchFamily="34" charset="-122"/>
+                <a:cs typeface="Be Vietnam Pro" pitchFamily="34" charset="-120"/>
+              </a:rPr>
+              <a:t> xử</a:t>
+            </a:r>
+            <a:r>
+              <a:rPr lang="en-US" sz="3450" b="1" dirty="0" spc="3" kern="0">
+                <a:solidFill>
+                  <a:srgbClr val="F3EEE3"/>
+                </a:solidFill>
+                <a:latin typeface="Be Vietnam Pro" pitchFamily="34" charset="0"/>
+                <a:ea typeface="Be Vietnam Pro" pitchFamily="34" charset="-122"/>
+                <a:cs typeface="Be Vietnam Pro" pitchFamily="34" charset="-120"/>
+              </a:rPr>
+              <a:t> lý</a:t>
             </a:r>
             <a:endParaRPr lang="en-US" sz="3450" dirty="0"/>
           </a:p>
@@ -6840,7 +6906,7 @@
               <a:buNone/>
             </a:pPr>
             <a:r>
-              <a:rPr lang="en-US" sz="2550" dirty="0" spc="-9" kern="0">
+              <a:rPr lang="en-US" sz="2550" dirty="0" spc="7" kern="0">
                 <a:solidFill>
                   <a:srgbClr val="C4C8D6"/>
                 </a:solidFill>
@@ -6848,7 +6914,18 @@
                 <a:ea typeface="Be Vietnam Pro" pitchFamily="34" charset="-122"/>
                 <a:cs typeface="Be Vietnam Pro" pitchFamily="34" charset="-120"/>
               </a:rPr>
-              <a:t>Chạy</a:t>
+              <a:t>Thực</a:t>
+            </a:r>
+            <a:r>
+              <a:rPr lang="en-US" sz="2550" dirty="0" spc="0" kern="0">
+                <a:solidFill>
+                  <a:srgbClr val="C4C8D6"/>
+                </a:solidFill>
+                <a:latin typeface="Be Vietnam Pro" pitchFamily="34" charset="0"/>
+                <a:ea typeface="Be Vietnam Pro" pitchFamily="34" charset="-122"/>
+                <a:cs typeface="Be Vietnam Pro" pitchFamily="34" charset="-120"/>
+              </a:rPr>
+              <a:t> thi</a:t>
             </a:r>
             <a:r>
               <a:rPr lang="en-US" sz="2550" dirty="0" spc="1" kern="0">
@@ -6859,10 +6936,10 @@
                 <a:ea typeface="Be Vietnam Pro" pitchFamily="34" charset="-122"/>
                 <a:cs typeface="Be Vietnam Pro" pitchFamily="34" charset="-120"/>
               </a:rPr>
-              <a:t> mã</a:t>
-            </a:r>
-            <a:r>
-              <a:rPr lang="en-US" sz="2550" dirty="0" spc="-9" kern="0">
+              <a:t> thẳng mã</a:t>
+            </a:r>
+            <a:r>
+              <a:rPr lang="en-US" sz="2550" dirty="0" spc="-6" kern="0">
                 <a:solidFill>
                   <a:srgbClr val="C4C8D6"/>
                 </a:solidFill>
@@ -6870,29 +6947,7 @@
                 <a:ea typeface="Be Vietnam Pro" pitchFamily="34" charset="-122"/>
                 <a:cs typeface="Be Vietnam Pro" pitchFamily="34" charset="-120"/>
               </a:rPr>
-              <a:t> máy</a:t>
-            </a:r>
-            <a:r>
-              <a:rPr lang="en-US" sz="2550" dirty="0" spc="7" kern="0">
-                <a:solidFill>
-                  <a:srgbClr val="C4C8D6"/>
-                </a:solidFill>
-                <a:latin typeface="Be Vietnam Pro" pitchFamily="34" charset="0"/>
-                <a:ea typeface="Be Vietnam Pro" pitchFamily="34" charset="-122"/>
-                <a:cs typeface="Be Vietnam Pro" pitchFamily="34" charset="-120"/>
-              </a:rPr>
-              <a:t> trực</a:t>
-            </a:r>
-            <a:r>
-              <a:rPr lang="en-US" sz="2550" dirty="0" spc="2" kern="0">
-                <a:solidFill>
-                  <a:srgbClr val="C4C8D6"/>
-                </a:solidFill>
-                <a:latin typeface="Be Vietnam Pro" pitchFamily="34" charset="0"/>
-                <a:ea typeface="Be Vietnam Pro" pitchFamily="34" charset="-122"/>
-                <a:cs typeface="Be Vietnam Pro" pitchFamily="34" charset="-120"/>
-              </a:rPr>
-              <a:t> tiếp.</a:t>
+              <a:t> máy.</a:t>
             </a:r>
             <a:endParaRPr lang="en-US" sz="2550" dirty="0"/>
           </a:p>
@@ -7541,17 +7596,6 @@
               <a:t> nguồn</a:t>
             </a:r>
             <a:r>
-              <a:rPr lang="en-US" sz="2850" dirty="0" spc="9" kern="0">
-                <a:solidFill>
-                  <a:srgbClr val="14161C"/>
-                </a:solidFill>
-                <a:latin typeface="Be Vietnam Pro" pitchFamily="34" charset="0"/>
-                <a:ea typeface="Be Vietnam Pro" pitchFamily="34" charset="-122"/>
-                <a:cs typeface="Be Vietnam Pro" pitchFamily="34" charset="-120"/>
-              </a:rPr>
-              <a:t> được</a:t>
-            </a:r>
-            <a:r>
               <a:rPr lang="en-US" sz="2850" dirty="0" spc="-1" kern="0">
                 <a:solidFill>
                   <a:srgbClr val="14161C"/>
@@ -7560,7 +7604,62 @@
                 <a:ea typeface="Be Vietnam Pro" pitchFamily="34" charset="-122"/>
                 <a:cs typeface="Be Vietnam Pro" pitchFamily="34" charset="-120"/>
               </a:rPr>
-              <a:t> dịch thành</a:t>
+              <a:t> thành</a:t>
+            </a:r>
+            <a:r>
+              <a:rPr lang="en-US" sz="2850" dirty="0" spc="-15" kern="0">
+                <a:solidFill>
+                  <a:srgbClr val="14161C"/>
+                </a:solidFill>
+                <a:latin typeface="Be Vietnam Pro" pitchFamily="34" charset="0"/>
+                <a:ea typeface="Be Vietnam Pro" pitchFamily="34" charset="-122"/>
+                <a:cs typeface="Be Vietnam Pro" pitchFamily="34" charset="-120"/>
+              </a:rPr>
+              <a:t> bytecode,</a:t>
+            </a:r>
+            <a:r>
+              <a:rPr lang="en-US" sz="2850" dirty="0" spc="-1" kern="0">
+                <a:solidFill>
+                  <a:srgbClr val="14161C"/>
+                </a:solidFill>
+                <a:latin typeface="Be Vietnam Pro" pitchFamily="34" charset="0"/>
+                <a:ea typeface="Be Vietnam Pro" pitchFamily="34" charset="-122"/>
+                <a:cs typeface="Be Vietnam Pro" pitchFamily="34" charset="-120"/>
+              </a:rPr>
+              <a:t> dạng trung</a:t>
+            </a:r>
+            <a:r>
+              <a:rPr lang="en-US" sz="2850" dirty="0" spc="1" kern="0">
+                <a:solidFill>
+                  <a:srgbClr val="14161C"/>
+                </a:solidFill>
+                <a:latin typeface="Be Vietnam Pro" pitchFamily="34" charset="0"/>
+                <a:ea typeface="Be Vietnam Pro" pitchFamily="34" charset="-122"/>
+                <a:cs typeface="Be Vietnam Pro" pitchFamily="34" charset="-120"/>
+              </a:rPr>
+              <a:t> gian.</a:t>
+            </a:r>
+            <a:r>
+              <a:rPr lang="en-US" sz="2850" dirty="0" spc="17" kern="0">
+                <a:solidFill>
+                  <a:srgbClr val="14161C"/>
+                </a:solidFill>
+                <a:latin typeface="Be Vietnam Pro" pitchFamily="34" charset="0"/>
+                <a:ea typeface="Be Vietnam Pro" pitchFamily="34" charset="-122"/>
+                <a:cs typeface="Be Vietnam Pro" pitchFamily="34" charset="-120"/>
+              </a:rPr>
+              <a:t> JVM</a:t>
+            </a:r>
+            <a:r>
+              <a:rPr lang="en-US" sz="2850" dirty="0" spc="-1" kern="0">
+                <a:solidFill>
+                  <a:srgbClr val="14161C"/>
+                </a:solidFill>
+                <a:latin typeface="Be Vietnam Pro" pitchFamily="34" charset="0"/>
+                <a:ea typeface="Be Vietnam Pro" pitchFamily="34" charset="-122"/>
+                <a:cs typeface="Be Vietnam Pro" pitchFamily="34" charset="-120"/>
+              </a:rPr>
+              <a:t> nạp</a:t>
             </a:r>
             <a:r>
               <a:rPr lang="en-US" sz="2850" dirty="0" spc="-16" kern="0">
@@ -7571,40 +7670,7 @@
                 <a:ea typeface="Be Vietnam Pro" pitchFamily="34" charset="-122"/>
                 <a:cs typeface="Be Vietnam Pro" pitchFamily="34" charset="-120"/>
               </a:rPr>
-              <a:t> bytecode</a:t>
-            </a:r>
-            <a:r>
-              <a:rPr lang="en-US" sz="2850" dirty="0" spc="6" kern="0">
-                <a:solidFill>
-                  <a:srgbClr val="14161C"/>
-                </a:solidFill>
-                <a:latin typeface="Be Vietnam Pro" pitchFamily="34" charset="0"/>
-                <a:ea typeface="Be Vietnam Pro" pitchFamily="34" charset="-122"/>
-                <a:cs typeface="Be Vietnam Pro" pitchFamily="34" charset="-120"/>
-              </a:rPr>
-              <a:t> trước.</a:t>
-            </a:r>
-            <a:r>
-              <a:rPr lang="en-US" sz="2850" dirty="0" spc="-33" kern="0">
-                <a:solidFill>
-                  <a:srgbClr val="14161C"/>
-                </a:solidFill>
-                <a:latin typeface="Be Vietnam Pro" pitchFamily="34" charset="0"/>
-                <a:ea typeface="Be Vietnam Pro" pitchFamily="34" charset="-122"/>
-                <a:cs typeface="Be Vietnam Pro" pitchFamily="34" charset="-120"/>
-              </a:rPr>
-              <a:t> Rồi</a:t>
-            </a:r>
-            <a:r>
-              <a:rPr lang="en-US" sz="2850" dirty="0" spc="17" kern="0">
-                <a:solidFill>
-                  <a:srgbClr val="14161C"/>
-                </a:solidFill>
-                <a:latin typeface="Be Vietnam Pro" pitchFamily="34" charset="0"/>
-                <a:ea typeface="Be Vietnam Pro" pitchFamily="34" charset="-122"/>
-                <a:cs typeface="Be Vietnam Pro" pitchFamily="34" charset="-120"/>
-              </a:rPr>
-              <a:t> JVM</a:t>
+              <a:t> và</a:t>
             </a:r>
             <a:r>
               <a:rPr lang="en-US" sz="2850" dirty="0" spc="-9" kern="0">
@@ -7616,39 +7682,6 @@
                 <a:cs typeface="Be Vietnam Pro" pitchFamily="34" charset="-120"/>
               </a:rPr>
               <a:t> chạy</a:t>
-            </a:r>
-            <a:r>
-              <a:rPr lang="en-US" sz="2850" dirty="0" spc="6" kern="0">
-                <a:solidFill>
-                  <a:srgbClr val="14161C"/>
-                </a:solidFill>
-                <a:latin typeface="Be Vietnam Pro" pitchFamily="34" charset="0"/>
-                <a:ea typeface="Be Vietnam Pro" pitchFamily="34" charset="-122"/>
-                <a:cs typeface="Be Vietnam Pro" pitchFamily="34" charset="-120"/>
-              </a:rPr>
-              <a:t> chương</a:t>
-            </a:r>
-            <a:r>
-              <a:rPr lang="en-US" sz="2850" dirty="0" spc="10" kern="0">
-                <a:solidFill>
-                  <a:srgbClr val="14161C"/>
-                </a:solidFill>
-                <a:latin typeface="Be Vietnam Pro" pitchFamily="34" charset="0"/>
-                <a:ea typeface="Be Vietnam Pro" pitchFamily="34" charset="-122"/>
-                <a:cs typeface="Be Vietnam Pro" pitchFamily="34" charset="-120"/>
-              </a:rPr>
-              <a:t> trình</a:t>
-            </a:r>
-            <a:r>
-              <a:rPr lang="en-US" sz="2850" dirty="0" spc="-1" kern="0">
-                <a:solidFill>
-                  <a:srgbClr val="14161C"/>
-                </a:solidFill>
-                <a:latin typeface="Be Vietnam Pro" pitchFamily="34" charset="0"/>
-                <a:ea typeface="Be Vietnam Pro" pitchFamily="34" charset="-122"/>
-                <a:cs typeface="Be Vietnam Pro" pitchFamily="34" charset="-120"/>
-              </a:rPr>
-              <a:t> từ</a:t>
             </a:r>
             <a:r>
               <a:rPr lang="en-US" sz="2850" dirty="0" spc="-14" kern="0">
@@ -7894,48 +7927,15 @@
               <a:buNone/>
             </a:pPr>
             <a:r>
-              <a:rPr lang="en-US" sz="2550" dirty="0" spc="-2" kern="0">
-                <a:solidFill>
-                  <a:srgbClr val="14161C"/>
-                </a:solidFill>
-                <a:latin typeface="Be Vietnam Pro" pitchFamily="34" charset="0"/>
-                <a:ea typeface="Be Vietnam Pro" pitchFamily="34" charset="-122"/>
-                <a:cs typeface="Be Vietnam Pro" pitchFamily="34" charset="-120"/>
-              </a:rPr>
-              <a:t>Đôi</a:t>
-            </a:r>
-            <a:r>
-              <a:rPr lang="en-US" sz="2550" dirty="0" spc="0" kern="0">
-                <a:solidFill>
-                  <a:srgbClr val="14161C"/>
-                </a:solidFill>
-                <a:latin typeface="Be Vietnam Pro" pitchFamily="34" charset="0"/>
-                <a:ea typeface="Be Vietnam Pro" pitchFamily="34" charset="-122"/>
-                <a:cs typeface="Be Vietnam Pro" pitchFamily="34" charset="-120"/>
-              </a:rPr>
-              <a:t> khi</a:t>
-            </a:r>
-            <a:r>
-              <a:rPr lang="en-US" sz="2550" dirty="0" spc="9" kern="0">
-                <a:solidFill>
-                  <a:srgbClr val="14161C"/>
-                </a:solidFill>
-                <a:latin typeface="Be Vietnam Pro" pitchFamily="34" charset="0"/>
-                <a:ea typeface="Be Vietnam Pro" pitchFamily="34" charset="-122"/>
-                <a:cs typeface="Be Vietnam Pro" pitchFamily="34" charset="-120"/>
-              </a:rPr>
-              <a:t> trình</a:t>
-            </a:r>
-            <a:r>
-              <a:rPr lang="en-US" sz="2550" dirty="0" spc="0" kern="0">
-                <a:solidFill>
-                  <a:srgbClr val="14161C"/>
-                </a:solidFill>
-                <a:latin typeface="Be Vietnam Pro" pitchFamily="34" charset="0"/>
-                <a:ea typeface="Be Vietnam Pro" pitchFamily="34" charset="-122"/>
-                <a:cs typeface="Be Vietnam Pro" pitchFamily="34" charset="-120"/>
-              </a:rPr>
-              <a:t> biên</a:t>
+              <a:rPr lang="en-US" sz="2550" dirty="0" spc="-4" kern="0">
+                <a:solidFill>
+                  <a:srgbClr val="14161C"/>
+                </a:solidFill>
+                <a:latin typeface="Be Vietnam Pro" pitchFamily="34" charset="0"/>
+                <a:ea typeface="Be Vietnam Pro" pitchFamily="34" charset="-122"/>
+                <a:cs typeface="Be Vietnam Pro" pitchFamily="34" charset="-120"/>
+              </a:rPr>
+              <a:t>JIT</a:t>
             </a:r>
             <a:r>
               <a:rPr lang="en-US" sz="2550" dirty="0" spc="1" kern="0">
@@ -7949,15 +7949,26 @@
               <a:t> dịch</a:t>
             </a:r>
             <a:r>
-              <a:rPr lang="en-US" sz="2550" dirty="0" spc="-4" kern="0">
-                <a:solidFill>
-                  <a:srgbClr val="14161C"/>
-                </a:solidFill>
-                <a:latin typeface="Be Vietnam Pro" pitchFamily="34" charset="0"/>
-                <a:ea typeface="Be Vietnam Pro" pitchFamily="34" charset="-122"/>
-                <a:cs typeface="Be Vietnam Pro" pitchFamily="34" charset="-120"/>
-              </a:rPr>
-              <a:t> JIT</a:t>
+              <a:rPr lang="en-US" sz="2550" dirty="0" spc="7" kern="0">
+                <a:solidFill>
+                  <a:srgbClr val="14161C"/>
+                </a:solidFill>
+                <a:latin typeface="Be Vietnam Pro" pitchFamily="34" charset="0"/>
+                <a:ea typeface="Be Vietnam Pro" pitchFamily="34" charset="-122"/>
+                <a:cs typeface="Be Vietnam Pro" pitchFamily="34" charset="-120"/>
+              </a:rPr>
+              <a:t> đoạn</a:t>
+            </a:r>
+            <a:r>
+              <a:rPr lang="en-US" sz="2550" dirty="0" spc="-7" kern="0">
+                <a:solidFill>
+                  <a:srgbClr val="14161C"/>
+                </a:solidFill>
+                <a:latin typeface="Be Vietnam Pro" pitchFamily="34" charset="0"/>
+                <a:ea typeface="Be Vietnam Pro" pitchFamily="34" charset="-122"/>
+                <a:cs typeface="Be Vietnam Pro" pitchFamily="34" charset="-120"/>
+              </a:rPr>
+              <a:t> chạy</a:t>
             </a:r>
             <a:r>
               <a:rPr lang="en-US" sz="2550" dirty="0" spc="1" kern="0">
@@ -7968,7 +7979,51 @@
                 <a:ea typeface="Be Vietnam Pro" pitchFamily="34" charset="-122"/>
                 <a:cs typeface="Be Vietnam Pro" pitchFamily="34" charset="-120"/>
               </a:rPr>
-              <a:t> dịch</a:t>
+              <a:t> nhiều</a:t>
+            </a:r>
+            <a:r>
+              <a:rPr lang="en-US" sz="2550" dirty="0" spc="-7" kern="0">
+                <a:solidFill>
+                  <a:srgbClr val="14161C"/>
+                </a:solidFill>
+                <a:latin typeface="Be Vietnam Pro" pitchFamily="34" charset="0"/>
+                <a:ea typeface="Be Vietnam Pro" pitchFamily="34" charset="-122"/>
+                <a:cs typeface="Be Vietnam Pro" pitchFamily="34" charset="-120"/>
+              </a:rPr>
+              <a:t> sang</a:t>
+            </a:r>
+            <a:r>
+              <a:rPr lang="en-US" sz="2550" dirty="0" spc="2" kern="0">
+                <a:solidFill>
+                  <a:srgbClr val="14161C"/>
+                </a:solidFill>
+                <a:latin typeface="Be Vietnam Pro" pitchFamily="34" charset="0"/>
+                <a:ea typeface="Be Vietnam Pro" pitchFamily="34" charset="-122"/>
+                <a:cs typeface="Be Vietnam Pro" pitchFamily="34" charset="-120"/>
+              </a:rPr>
+              <a:t> mã</a:t>
+            </a:r>
+            <a:r>
+              <a:rPr lang="en-US" sz="2550" dirty="0" spc="-9" kern="0">
+                <a:solidFill>
+                  <a:srgbClr val="14161C"/>
+                </a:solidFill>
+                <a:latin typeface="Be Vietnam Pro" pitchFamily="34" charset="0"/>
+                <a:ea typeface="Be Vietnam Pro" pitchFamily="34" charset="-122"/>
+                <a:cs typeface="Be Vietnam Pro" pitchFamily="34" charset="-120"/>
+              </a:rPr>
+              <a:t> máy</a:t>
+            </a:r>
+            <a:r>
+              <a:rPr lang="en-US" sz="2550" dirty="0" spc="-1" kern="0">
+                <a:solidFill>
+                  <a:srgbClr val="14161C"/>
+                </a:solidFill>
+                <a:latin typeface="Be Vietnam Pro" pitchFamily="34" charset="0"/>
+                <a:ea typeface="Be Vietnam Pro" pitchFamily="34" charset="-122"/>
+                <a:cs typeface="Be Vietnam Pro" pitchFamily="34" charset="-120"/>
+              </a:rPr>
+              <a:t> lúc</a:t>
             </a:r>
             <a:r>
               <a:rPr lang="en-US" sz="2550" dirty="0" spc="-6" kern="0">
@@ -7979,73 +8034,7 @@
                 <a:ea typeface="Be Vietnam Pro" pitchFamily="34" charset="-122"/>
                 <a:cs typeface="Be Vietnam Pro" pitchFamily="34" charset="-120"/>
               </a:rPr>
-              <a:t> sang</a:t>
-            </a:r>
-            <a:r>
-              <a:rPr lang="en-US" sz="2550" dirty="0" spc="1" kern="0">
-                <a:solidFill>
-                  <a:srgbClr val="14161C"/>
-                </a:solidFill>
-                <a:latin typeface="Be Vietnam Pro" pitchFamily="34" charset="0"/>
-                <a:ea typeface="Be Vietnam Pro" pitchFamily="34" charset="-122"/>
-                <a:cs typeface="Be Vietnam Pro" pitchFamily="34" charset="-120"/>
-              </a:rPr>
-              <a:t> mã</a:t>
-            </a:r>
-            <a:r>
-              <a:rPr lang="en-US" sz="2550" dirty="0" spc="-9" kern="0">
-                <a:solidFill>
-                  <a:srgbClr val="14161C"/>
-                </a:solidFill>
-                <a:latin typeface="Be Vietnam Pro" pitchFamily="34" charset="0"/>
-                <a:ea typeface="Be Vietnam Pro" pitchFamily="34" charset="-122"/>
-                <a:cs typeface="Be Vietnam Pro" pitchFamily="34" charset="-120"/>
-              </a:rPr>
-              <a:t> máy</a:t>
-            </a:r>
-            <a:r>
-              <a:rPr lang="en-US" sz="2550" dirty="0" spc="18" kern="0">
-                <a:solidFill>
-                  <a:srgbClr val="14161C"/>
-                </a:solidFill>
-                <a:latin typeface="Be Vietnam Pro" pitchFamily="34" charset="0"/>
-                <a:ea typeface="Be Vietnam Pro" pitchFamily="34" charset="-122"/>
-                <a:cs typeface="Be Vietnam Pro" pitchFamily="34" charset="-120"/>
-              </a:rPr>
-              <a:t> để</a:t>
-            </a:r>
-            <a:r>
-              <a:rPr lang="en-US" sz="2550" dirty="0" spc="-8" kern="0">
-                <a:solidFill>
-                  <a:srgbClr val="14161C"/>
-                </a:solidFill>
-                <a:latin typeface="Be Vietnam Pro" pitchFamily="34" charset="0"/>
-                <a:ea typeface="Be Vietnam Pro" pitchFamily="34" charset="-122"/>
-                <a:cs typeface="Be Vietnam Pro" pitchFamily="34" charset="-120"/>
-              </a:rPr>
-              <a:t> chạy</a:t>
-            </a:r>
-            <a:r>
-              <a:rPr lang="en-US" sz="2550" dirty="0" spc="-1" kern="0">
-                <a:solidFill>
-                  <a:srgbClr val="14161C"/>
-                </a:solidFill>
-                <a:latin typeface="Be Vietnam Pro" pitchFamily="34" charset="0"/>
-                <a:ea typeface="Be Vietnam Pro" pitchFamily="34" charset="-122"/>
-                <a:cs typeface="Be Vietnam Pro" pitchFamily="34" charset="-120"/>
-              </a:rPr>
-              <a:t> nhanh</a:t>
-            </a:r>
-            <a:r>
-              <a:rPr lang="en-US" sz="2550" dirty="0" spc="1" kern="0">
-                <a:solidFill>
-                  <a:srgbClr val="14161C"/>
-                </a:solidFill>
-                <a:latin typeface="Be Vietnam Pro" pitchFamily="34" charset="0"/>
-                <a:ea typeface="Be Vietnam Pro" pitchFamily="34" charset="-122"/>
-                <a:cs typeface="Be Vietnam Pro" pitchFamily="34" charset="-120"/>
-              </a:rPr>
-              <a:t> hơn.</a:t>
+              <a:t> chạy.</a:t>
             </a:r>
             <a:endParaRPr lang="en-US" sz="2550" dirty="0"/>
           </a:p>
@@ -8543,48 +8532,37 @@
               <a:buNone/>
             </a:pPr>
             <a:r>
-              <a:rPr lang="en-US" sz="2400" dirty="0" spc="-9" kern="0">
-                <a:solidFill>
-                  <a:srgbClr val="14161C"/>
-                </a:solidFill>
-                <a:latin typeface="Be Vietnam Pro" pitchFamily="34" charset="0"/>
-                <a:ea typeface="Be Vietnam Pro" pitchFamily="34" charset="-122"/>
-                <a:cs typeface="Be Vietnam Pro" pitchFamily="34" charset="-120"/>
-              </a:rPr>
-              <a:t>Chạy</a:t>
-            </a:r>
-            <a:r>
-              <a:rPr lang="en-US" sz="2400" dirty="0" spc="5" kern="0">
-                <a:solidFill>
-                  <a:srgbClr val="14161C"/>
-                </a:solidFill>
-                <a:latin typeface="Be Vietnam Pro" pitchFamily="34" charset="0"/>
-                <a:ea typeface="Be Vietnam Pro" pitchFamily="34" charset="-122"/>
-                <a:cs typeface="Be Vietnam Pro" pitchFamily="34" charset="-120"/>
-              </a:rPr>
-              <a:t> chương</a:t>
-            </a:r>
-            <a:r>
-              <a:rPr lang="en-US" sz="2400" dirty="0" spc="10" kern="0">
-                <a:solidFill>
-                  <a:srgbClr val="14161C"/>
-                </a:solidFill>
-                <a:latin typeface="Be Vietnam Pro" pitchFamily="34" charset="0"/>
-                <a:ea typeface="Be Vietnam Pro" pitchFamily="34" charset="-122"/>
-                <a:cs typeface="Be Vietnam Pro" pitchFamily="34" charset="-120"/>
-              </a:rPr>
-              <a:t> trình</a:t>
-            </a:r>
-            <a:r>
-              <a:rPr lang="en-US" sz="2400" dirty="0" spc="3" kern="0">
-                <a:solidFill>
-                  <a:srgbClr val="14161C"/>
-                </a:solidFill>
-                <a:latin typeface="Be Vietnam Pro" pitchFamily="34" charset="0"/>
-                <a:ea typeface="Be Vietnam Pro" pitchFamily="34" charset="-122"/>
-                <a:cs typeface="Be Vietnam Pro" pitchFamily="34" charset="-120"/>
-              </a:rPr>
-              <a:t> từ</a:t>
+              <a:rPr lang="en-US" sz="2400" dirty="0" spc="0" kern="0">
+                <a:solidFill>
+                  <a:srgbClr val="14161C"/>
+                </a:solidFill>
+                <a:latin typeface="Be Vietnam Pro" pitchFamily="34" charset="0"/>
+                <a:ea typeface="Be Vietnam Pro" pitchFamily="34" charset="-122"/>
+                <a:cs typeface="Be Vietnam Pro" pitchFamily="34" charset="-120"/>
+              </a:rPr>
+              <a:t>Nạp</a:t>
+            </a:r>
+            <a:r>
+              <a:rPr lang="en-US" sz="2400" dirty="0" spc="-15" kern="0">
+                <a:solidFill>
+                  <a:srgbClr val="14161C"/>
+                </a:solidFill>
+                <a:latin typeface="Be Vietnam Pro" pitchFamily="34" charset="0"/>
+                <a:ea typeface="Be Vietnam Pro" pitchFamily="34" charset="-122"/>
+                <a:cs typeface="Be Vietnam Pro" pitchFamily="34" charset="-120"/>
+              </a:rPr>
+              <a:t> và</a:t>
+            </a:r>
+            <a:r>
+              <a:rPr lang="en-US" sz="2400" dirty="0" spc="-7" kern="0">
+                <a:solidFill>
+                  <a:srgbClr val="14161C"/>
+                </a:solidFill>
+                <a:latin typeface="Be Vietnam Pro" pitchFamily="34" charset="0"/>
+                <a:ea typeface="Be Vietnam Pro" pitchFamily="34" charset="-122"/>
+                <a:cs typeface="Be Vietnam Pro" pitchFamily="34" charset="-120"/>
+              </a:rPr>
+              <a:t> chạy</a:t>
             </a:r>
             <a:r>
               <a:rPr lang="en-US" sz="2400" dirty="0" spc="-10" kern="0">
@@ -8651,7 +8629,7 @@
               <a:buNone/>
             </a:pPr>
             <a:r>
-              <a:rPr lang="en-US" sz="2100" b="1" dirty="0" spc="2" kern="0">
+              <a:rPr lang="en-US" sz="2100" b="1" dirty="0" spc="-1" kern="0">
                 <a:solidFill>
                   <a:srgbClr val="B45309"/>
                 </a:solidFill>
@@ -8659,10 +8637,10 @@
                 <a:ea typeface="Be Vietnam Pro" pitchFamily="34" charset="-122"/>
                 <a:cs typeface="Be Vietnam Pro" pitchFamily="34" charset="-120"/>
               </a:rPr>
-              <a:t>đôi</a:t>
-            </a:r>
-            <a:r>
-              <a:rPr lang="en-US" sz="2100" b="1" dirty="0" spc="-3" kern="0">
+              <a:t>tùy</a:t>
+            </a:r>
+            <a:r>
+              <a:rPr lang="en-US" sz="2100" b="1" dirty="0" spc="-6" kern="0">
                 <a:solidFill>
                   <a:srgbClr val="B45309"/>
                 </a:solidFill>
@@ -8670,7 +8648,7 @@
                 <a:ea typeface="Be Vietnam Pro" pitchFamily="34" charset="-122"/>
                 <a:cs typeface="Be Vietnam Pro" pitchFamily="34" charset="-120"/>
               </a:rPr>
-              <a:t> khi</a:t>
+              <a:t> chọn</a:t>
             </a:r>
             <a:endParaRPr lang="en-US" sz="2100" dirty="0"/>
           </a:p>
@@ -8782,26 +8760,26 @@
               <a:t>JIT,</a:t>
             </a:r>
             <a:r>
-              <a:rPr lang="en-US" sz="3300" b="1" dirty="0" spc="4" kern="0">
-                <a:solidFill>
-                  <a:srgbClr val="14161C"/>
-                </a:solidFill>
-                <a:latin typeface="Be Vietnam Pro" pitchFamily="34" charset="0"/>
-                <a:ea typeface="Be Vietnam Pro" pitchFamily="34" charset="-122"/>
-                <a:cs typeface="Be Vietnam Pro" pitchFamily="34" charset="-120"/>
-              </a:rPr>
-              <a:t> đôi</a:t>
-            </a:r>
-            <a:r>
-              <a:rPr lang="en-US" sz="3300" b="1" dirty="0" spc="-2" kern="0">
-                <a:solidFill>
-                  <a:srgbClr val="14161C"/>
-                </a:solidFill>
-                <a:latin typeface="Be Vietnam Pro" pitchFamily="34" charset="0"/>
-                <a:ea typeface="Be Vietnam Pro" pitchFamily="34" charset="-122"/>
-                <a:cs typeface="Be Vietnam Pro" pitchFamily="34" charset="-120"/>
-              </a:rPr>
-              <a:t> khi</a:t>
+              <a:rPr lang="en-US" sz="3300" b="1" dirty="0" spc="-5" kern="0">
+                <a:solidFill>
+                  <a:srgbClr val="14161C"/>
+                </a:solidFill>
+                <a:latin typeface="Be Vietnam Pro" pitchFamily="34" charset="0"/>
+                <a:ea typeface="Be Vietnam Pro" pitchFamily="34" charset="-122"/>
+                <a:cs typeface="Be Vietnam Pro" pitchFamily="34" charset="-120"/>
+              </a:rPr>
+              <a:t> tùy</a:t>
+            </a:r>
+            <a:r>
+              <a:rPr lang="en-US" sz="3300" b="1" dirty="0" spc="-10" kern="0">
+                <a:solidFill>
+                  <a:srgbClr val="14161C"/>
+                </a:solidFill>
+                <a:latin typeface="Be Vietnam Pro" pitchFamily="34" charset="0"/>
+                <a:ea typeface="Be Vietnam Pro" pitchFamily="34" charset="-122"/>
+                <a:cs typeface="Be Vietnam Pro" pitchFamily="34" charset="-120"/>
+              </a:rPr>
+              <a:t> chọn</a:t>
             </a:r>
             <a:endParaRPr lang="en-US" sz="3300" dirty="0"/>
           </a:p>
@@ -8835,26 +8813,48 @@
               <a:buNone/>
             </a:pPr>
             <a:r>
-              <a:rPr lang="en-US" sz="2400" dirty="0" spc="-2" kern="0">
-                <a:solidFill>
-                  <a:srgbClr val="14161C"/>
-                </a:solidFill>
-                <a:latin typeface="Be Vietnam Pro" pitchFamily="34" charset="0"/>
-                <a:ea typeface="Be Vietnam Pro" pitchFamily="34" charset="-122"/>
-                <a:cs typeface="Be Vietnam Pro" pitchFamily="34" charset="-120"/>
-              </a:rPr>
-              <a:t>Dịch</a:t>
-            </a:r>
-            <a:r>
-              <a:rPr lang="en-US" sz="2400" dirty="0" spc="-29" kern="0">
-                <a:solidFill>
-                  <a:srgbClr val="14161C"/>
-                </a:solidFill>
-                <a:latin typeface="Be Vietnam Pro" pitchFamily="34" charset="0"/>
-                <a:ea typeface="Be Vietnam Pro" pitchFamily="34" charset="-122"/>
-                <a:cs typeface="Be Vietnam Pro" pitchFamily="34" charset="-120"/>
-              </a:rPr>
-              <a:t> ra</a:t>
+              <a:rPr lang="en-US" sz="2400" dirty="0" spc="0" kern="0">
+                <a:solidFill>
+                  <a:srgbClr val="14161C"/>
+                </a:solidFill>
+                <a:latin typeface="Be Vietnam Pro" pitchFamily="34" charset="0"/>
+                <a:ea typeface="Be Vietnam Pro" pitchFamily="34" charset="-122"/>
+                <a:cs typeface="Be Vietnam Pro" pitchFamily="34" charset="-120"/>
+              </a:rPr>
+              <a:t>Đoạn</a:t>
+            </a:r>
+            <a:r>
+              <a:rPr lang="en-US" sz="2400" dirty="0" spc="-7" kern="0">
+                <a:solidFill>
+                  <a:srgbClr val="14161C"/>
+                </a:solidFill>
+                <a:latin typeface="Be Vietnam Pro" pitchFamily="34" charset="0"/>
+                <a:ea typeface="Be Vietnam Pro" pitchFamily="34" charset="-122"/>
+                <a:cs typeface="Be Vietnam Pro" pitchFamily="34" charset="-120"/>
+              </a:rPr>
+              <a:t> chạy</a:t>
+            </a:r>
+            <a:r>
+              <a:rPr lang="en-US" sz="2400" dirty="0" spc="-1" kern="0">
+                <a:solidFill>
+                  <a:srgbClr val="14161C"/>
+                </a:solidFill>
+                <a:latin typeface="Be Vietnam Pro" pitchFamily="34" charset="0"/>
+                <a:ea typeface="Be Vietnam Pro" pitchFamily="34" charset="-122"/>
+                <a:cs typeface="Be Vietnam Pro" pitchFamily="34" charset="-120"/>
+              </a:rPr>
+              <a:t> nhiều</a:t>
+            </a:r>
+            <a:r>
+              <a:rPr lang="en-US" sz="2400" dirty="0" spc="1" kern="0">
+                <a:solidFill>
+                  <a:srgbClr val="14161C"/>
+                </a:solidFill>
+                <a:latin typeface="Be Vietnam Pro" pitchFamily="34" charset="0"/>
+                <a:ea typeface="Be Vietnam Pro" pitchFamily="34" charset="-122"/>
+                <a:cs typeface="Be Vietnam Pro" pitchFamily="34" charset="-120"/>
+              </a:rPr>
+              <a:t> thành</a:t>
             </a:r>
             <a:r>
               <a:rPr lang="en-US" sz="2400" dirty="0" spc="4" kern="0">
@@ -8879,28 +8879,6 @@
               <a:t> máy</a:t>
             </a:r>
             <a:r>
-              <a:rPr lang="en-US" sz="2400" dirty="0" spc="17" kern="0">
-                <a:solidFill>
-                  <a:srgbClr val="14161C"/>
-                </a:solidFill>
-                <a:latin typeface="Be Vietnam Pro" pitchFamily="34" charset="0"/>
-                <a:ea typeface="Be Vietnam Pro" pitchFamily="34" charset="-122"/>
-                <a:cs typeface="Be Vietnam Pro" pitchFamily="34" charset="-120"/>
-              </a:rPr>
-              <a:t> để</a:t>
-            </a:r>
-            <a:r>
-              <a:rPr lang="en-US" sz="2400" dirty="0" spc="-7" kern="0">
-                <a:solidFill>
-                  <a:srgbClr val="14161C"/>
-                </a:solidFill>
-                <a:latin typeface="Be Vietnam Pro" pitchFamily="34" charset="0"/>
-                <a:ea typeface="Be Vietnam Pro" pitchFamily="34" charset="-122"/>
-                <a:cs typeface="Be Vietnam Pro" pitchFamily="34" charset="-120"/>
-              </a:rPr>
-              <a:t> chạy</a:t>
-            </a:r>
-            <a:r>
               <a:rPr lang="en-US" sz="2400" dirty="0" spc="1" kern="0">
                 <a:solidFill>
                   <a:srgbClr val="14161C"/>
@@ -8909,18 +8887,18 @@
                 <a:ea typeface="Be Vietnam Pro" pitchFamily="34" charset="-122"/>
                 <a:cs typeface="Be Vietnam Pro" pitchFamily="34" charset="-120"/>
               </a:rPr>
-              <a:t> nhanh</a:t>
-            </a:r>
-            <a:r>
-              <a:rPr lang="en-US" sz="2400" dirty="0" spc="0" kern="0">
-                <a:solidFill>
-                  <a:srgbClr val="14161C"/>
-                </a:solidFill>
-                <a:latin typeface="Be Vietnam Pro" pitchFamily="34" charset="0"/>
-                <a:ea typeface="Be Vietnam Pro" pitchFamily="34" charset="-122"/>
-                <a:cs typeface="Be Vietnam Pro" pitchFamily="34" charset="-120"/>
-              </a:rPr>
-              <a:t> hơn.</a:t>
+              <a:t> lúc</a:t>
+            </a:r>
+            <a:r>
+              <a:rPr lang="en-US" sz="2400" dirty="0" spc="-6" kern="0">
+                <a:solidFill>
+                  <a:srgbClr val="14161C"/>
+                </a:solidFill>
+                <a:latin typeface="Be Vietnam Pro" pitchFamily="34" charset="0"/>
+                <a:ea typeface="Be Vietnam Pro" pitchFamily="34" charset="-122"/>
+                <a:cs typeface="Be Vietnam Pro" pitchFamily="34" charset="-120"/>
+              </a:rPr>
+              <a:t> chạy.</a:t>
             </a:r>
             <a:endParaRPr lang="en-US" sz="2400" dirty="0"/>
           </a:p>
@@ -9558,7 +9536,7 @@
               <a:buNone/>
             </a:pPr>
             <a:r>
-              <a:rPr lang="en-US" sz="2850" dirty="0" spc="6" kern="0">
+              <a:rPr lang="en-US" sz="2850" dirty="0" spc="-12" kern="0">
                 <a:solidFill>
                   <a:srgbClr val="F3EEE3"/>
                 </a:solidFill>
@@ -9566,10 +9544,10 @@
                 <a:ea typeface="Be Vietnam Pro" pitchFamily="34" charset="-122"/>
                 <a:cs typeface="Be Vietnam Pro" pitchFamily="34" charset="-120"/>
               </a:rPr>
-              <a:t>Chương</a:t>
-            </a:r>
-            <a:r>
-              <a:rPr lang="en-US" sz="2850" dirty="0" spc="10" kern="0">
+              <a:t>Chạy</a:t>
+            </a:r>
+            <a:r>
+              <a:rPr lang="en-US" sz="2850" dirty="0" spc="-2" kern="0">
                 <a:solidFill>
                   <a:srgbClr val="F3EEE3"/>
                 </a:solidFill>
@@ -9577,7 +9555,18 @@
                 <a:ea typeface="Be Vietnam Pro" pitchFamily="34" charset="-122"/>
                 <a:cs typeface="Be Vietnam Pro" pitchFamily="34" charset="-120"/>
               </a:rPr>
-              <a:t> trình</a:t>
+              <a:t> thẳng</a:t>
+            </a:r>
+            <a:r>
+              <a:rPr lang="en-US" sz="2850" dirty="0" spc="-1" kern="0">
+                <a:solidFill>
+                  <a:srgbClr val="F3EEE3"/>
+                </a:solidFill>
+                <a:latin typeface="Be Vietnam Pro" pitchFamily="34" charset="0"/>
+                <a:ea typeface="Be Vietnam Pro" pitchFamily="34" charset="-122"/>
+                <a:cs typeface="Be Vietnam Pro" pitchFamily="34" charset="-120"/>
+              </a:rPr>
+              <a:t> từ mã nguồn,</a:t>
             </a:r>
             <a:r>
               <a:rPr lang="en-US" sz="2850" dirty="0" spc="-3" kern="0">
@@ -9591,7 +9580,7 @@
               <a:t> không</a:t>
             </a:r>
             <a:r>
-              <a:rPr lang="en-US" sz="2850" dirty="0" spc="9" kern="0">
+              <a:rPr lang="en-US" sz="2850" dirty="0" spc="-13" kern="0">
                 <a:solidFill>
                   <a:srgbClr val="F3EEE3"/>
                 </a:solidFill>
@@ -9599,10 +9588,10 @@
                 <a:ea typeface="Be Vietnam Pro" pitchFamily="34" charset="-122"/>
                 <a:cs typeface="Be Vietnam Pro" pitchFamily="34" charset="-120"/>
               </a:rPr>
-              <a:t> được</a:t>
-            </a:r>
-            <a:r>
-              <a:rPr lang="en-US" sz="2850" dirty="0" spc="-1" kern="0">
+              <a:t> tạo</a:t>
+            </a:r>
+            <a:r>
+              <a:rPr lang="en-US" sz="2850" dirty="0" spc="-16" kern="0">
                 <a:solidFill>
                   <a:srgbClr val="F3EEE3"/>
                 </a:solidFill>
@@ -9610,10 +9599,10 @@
                 <a:ea typeface="Be Vietnam Pro" pitchFamily="34" charset="-122"/>
                 <a:cs typeface="Be Vietnam Pro" pitchFamily="34" charset="-120"/>
               </a:rPr>
-              <a:t> biên</a:t>
-            </a:r>
-            <a:r>
-              <a:rPr lang="en-US" sz="2850" dirty="0" spc="0" kern="0">
+              <a:t> tệp</a:t>
+            </a:r>
+            <a:r>
+              <a:rPr lang="en-US" sz="2850" dirty="0" spc="7" kern="0">
                 <a:solidFill>
                   <a:srgbClr val="F3EEE3"/>
                 </a:solidFill>
@@ -9621,10 +9610,10 @@
                 <a:ea typeface="Be Vietnam Pro" pitchFamily="34" charset="-122"/>
                 <a:cs typeface="Be Vietnam Pro" pitchFamily="34" charset="-120"/>
               </a:rPr>
-              <a:t> dịch</a:t>
-            </a:r>
-            <a:r>
-              <a:rPr lang="en-US" sz="2850" dirty="0" spc="6" kern="0">
+              <a:t> thực</a:t>
+            </a:r>
+            <a:r>
+              <a:rPr lang="en-US" sz="2850" dirty="0" spc="1" kern="0">
                 <a:solidFill>
                   <a:srgbClr val="F3EEE3"/>
                 </a:solidFill>
@@ -9632,10 +9621,10 @@
                 <a:ea typeface="Be Vietnam Pro" pitchFamily="34" charset="-122"/>
                 <a:cs typeface="Be Vietnam Pro" pitchFamily="34" charset="-120"/>
               </a:rPr>
-              <a:t> trước.</a:t>
-            </a:r>
-            <a:r>
-              <a:rPr lang="en-US" sz="2850" dirty="0" spc="-22" kern="0">
+              <a:t> thi</a:t>
+            </a:r>
+            <a:r>
+              <a:rPr lang="en-US" sz="2850" dirty="0" spc="8" kern="0">
                 <a:solidFill>
                   <a:srgbClr val="F3EEE3"/>
                 </a:solidFill>
@@ -9643,84 +9632,7 @@
                 <a:ea typeface="Be Vietnam Pro" pitchFamily="34" charset="-122"/>
                 <a:cs typeface="Be Vietnam Pro" pitchFamily="34" charset="-120"/>
               </a:rPr>
-              <a:t> Trình</a:t>
-            </a:r>
-            <a:r>
-              <a:rPr lang="en-US" sz="2850" dirty="0" spc="-2" kern="0">
-                <a:solidFill>
-                  <a:srgbClr val="F3EEE3"/>
-                </a:solidFill>
-                <a:latin typeface="Be Vietnam Pro" pitchFamily="34" charset="0"/>
-                <a:ea typeface="Be Vietnam Pro" pitchFamily="34" charset="-122"/>
-                <a:cs typeface="Be Vietnam Pro" pitchFamily="34" charset="-120"/>
-              </a:rPr>
-              <a:t> thông</a:t>
-            </a:r>
-            <a:r>
-              <a:rPr lang="en-US" sz="2850" dirty="0" spc="-1" kern="0">
-                <a:solidFill>
-                  <a:srgbClr val="F3EEE3"/>
-                </a:solidFill>
-                <a:latin typeface="Be Vietnam Pro" pitchFamily="34" charset="0"/>
-                <a:ea typeface="Be Vietnam Pro" pitchFamily="34" charset="-122"/>
-                <a:cs typeface="Be Vietnam Pro" pitchFamily="34" charset="-120"/>
-              </a:rPr>
-              <a:t> dịch</a:t>
-            </a:r>
-            <a:r>
-              <a:rPr lang="en-US" sz="2850" dirty="0" spc="-9" kern="0">
-                <a:solidFill>
-                  <a:srgbClr val="F3EEE3"/>
-                </a:solidFill>
-                <a:latin typeface="Be Vietnam Pro" pitchFamily="34" charset="0"/>
-                <a:ea typeface="Be Vietnam Pro" pitchFamily="34" charset="-122"/>
-                <a:cs typeface="Be Vietnam Pro" pitchFamily="34" charset="-120"/>
-              </a:rPr>
-              <a:t> chạy</a:t>
-            </a:r>
-            <a:r>
-              <a:rPr lang="en-US" sz="2850" dirty="0" spc="-1" kern="0">
-                <a:solidFill>
-                  <a:srgbClr val="F3EEE3"/>
-                </a:solidFill>
-                <a:latin typeface="Be Vietnam Pro" pitchFamily="34" charset="0"/>
-                <a:ea typeface="Be Vietnam Pro" pitchFamily="34" charset="-122"/>
-                <a:cs typeface="Be Vietnam Pro" pitchFamily="34" charset="-120"/>
-              </a:rPr>
-              <a:t> nó</a:t>
-            </a:r>
-            <a:r>
-              <a:rPr lang="en-US" sz="2850" dirty="0" spc="-20" kern="0">
-                <a:solidFill>
-                  <a:srgbClr val="F3EEE3"/>
-                </a:solidFill>
-                <a:latin typeface="Be Vietnam Pro" pitchFamily="34" charset="0"/>
-                <a:ea typeface="Be Vietnam Pro" pitchFamily="34" charset="-122"/>
-                <a:cs typeface="Be Vietnam Pro" pitchFamily="34" charset="-120"/>
-              </a:rPr>
-              <a:t> ngay</a:t>
-            </a:r>
-            <a:r>
-              <a:rPr lang="en-US" sz="2850" dirty="0" spc="0" kern="0">
-                <a:solidFill>
-                  <a:srgbClr val="F3EEE3"/>
-                </a:solidFill>
-                <a:latin typeface="Be Vietnam Pro" pitchFamily="34" charset="0"/>
-                <a:ea typeface="Be Vietnam Pro" pitchFamily="34" charset="-122"/>
-                <a:cs typeface="Be Vietnam Pro" pitchFamily="34" charset="-120"/>
-              </a:rPr>
-              <a:t> lúc</a:t>
-            </a:r>
-            <a:r>
-              <a:rPr lang="en-US" sz="2850" dirty="0" spc="-7" kern="0">
-                <a:solidFill>
-                  <a:srgbClr val="F3EEE3"/>
-                </a:solidFill>
-                <a:latin typeface="Be Vietnam Pro" pitchFamily="34" charset="0"/>
-                <a:ea typeface="Be Vietnam Pro" pitchFamily="34" charset="-122"/>
-                <a:cs typeface="Be Vietnam Pro" pitchFamily="34" charset="-120"/>
-              </a:rPr>
-              <a:t> chạy.</a:t>
+              <a:t> riêng.</a:t>
             </a:r>
             <a:endParaRPr lang="en-US" sz="2850" dirty="0"/>
           </a:p>
@@ -9923,6 +9835,61 @@
               <a:buNone/>
             </a:pPr>
             <a:r>
+              <a:rPr lang="en-US" sz="2550" dirty="0" spc="-78" kern="0">
+                <a:solidFill>
+                  <a:srgbClr val="F3EEE3"/>
+                </a:solidFill>
+                <a:latin typeface="Be Vietnam Pro" pitchFamily="34" charset="0"/>
+                <a:ea typeface="Be Vietnam Pro" pitchFamily="34" charset="-122"/>
+                <a:cs typeface="Be Vietnam Pro" pitchFamily="34" charset="-120"/>
+              </a:rPr>
+              <a:t>Tài</a:t>
+            </a:r>
+            <a:r>
+              <a:rPr lang="en-US" sz="2550" dirty="0" spc="1" kern="0">
+                <a:solidFill>
+                  <a:srgbClr val="F3EEE3"/>
+                </a:solidFill>
+                <a:latin typeface="Be Vietnam Pro" pitchFamily="34" charset="0"/>
+                <a:ea typeface="Be Vietnam Pro" pitchFamily="34" charset="-122"/>
+                <a:cs typeface="Be Vietnam Pro" pitchFamily="34" charset="-120"/>
+              </a:rPr>
+              <a:t> liệu</a:t>
+            </a:r>
+            <a:r>
+              <a:rPr lang="en-US" sz="2550" dirty="0" spc="8" kern="0">
+                <a:solidFill>
+                  <a:srgbClr val="F3EEE3"/>
+                </a:solidFill>
+                <a:latin typeface="Be Vietnam Pro" pitchFamily="34" charset="0"/>
+                <a:ea typeface="Be Vietnam Pro" pitchFamily="34" charset="-122"/>
+                <a:cs typeface="Be Vietnam Pro" pitchFamily="34" charset="-120"/>
+              </a:rPr>
+              <a:t> Python:</a:t>
+            </a:r>
+            <a:r>
+              <a:rPr lang="en-US" sz="2550" dirty="0" spc="0" kern="0">
+                <a:solidFill>
+                  <a:srgbClr val="F3EEE3"/>
+                </a:solidFill>
+                <a:latin typeface="Be Vietnam Pro" pitchFamily="34" charset="0"/>
+                <a:ea typeface="Be Vietnam Pro" pitchFamily="34" charset="-122"/>
+                <a:cs typeface="Be Vietnam Pro" pitchFamily="34" charset="-120"/>
+              </a:rPr>
+              <a:t> thông</a:t>
+            </a:r>
+            <a:r>
+              <a:rPr lang="en-US" sz="2550" dirty="0" spc="1" kern="0">
+                <a:solidFill>
+                  <a:srgbClr val="F3EEE3"/>
+                </a:solidFill>
+                <a:latin typeface="Be Vietnam Pro" pitchFamily="34" charset="0"/>
+                <a:ea typeface="Be Vietnam Pro" pitchFamily="34" charset="-122"/>
+                <a:cs typeface="Be Vietnam Pro" pitchFamily="34" charset="-120"/>
+              </a:rPr>
+              <a:t> dịch</a:t>
+            </a:r>
+            <a:r>
               <a:rPr lang="en-US" sz="2550" dirty="0" spc="5" kern="0">
                 <a:solidFill>
                   <a:srgbClr val="F3EEE3"/>
@@ -9931,10 +9898,10 @@
                 <a:ea typeface="Be Vietnam Pro" pitchFamily="34" charset="-122"/>
                 <a:cs typeface="Be Vietnam Pro" pitchFamily="34" charset="-120"/>
               </a:rPr>
-              <a:t>Chương</a:t>
-            </a:r>
-            <a:r>
-              <a:rPr lang="en-US" sz="2550" dirty="0" spc="10" kern="0">
+              <a:t> thường</a:t>
+            </a:r>
+            <a:r>
+              <a:rPr lang="en-US" sz="2550" dirty="0" spc="-8" kern="0">
                 <a:solidFill>
                   <a:srgbClr val="F3EEE3"/>
                 </a:solidFill>
@@ -9942,10 +9909,10 @@
                 <a:ea typeface="Be Vietnam Pro" pitchFamily="34" charset="-122"/>
                 <a:cs typeface="Be Vietnam Pro" pitchFamily="34" charset="-120"/>
               </a:rPr>
-              <a:t> trình</a:t>
-            </a:r>
-            <a:r>
-              <a:rPr lang="en-US" sz="2550" dirty="0" spc="-2" kern="0">
+              <a:t> chạy</a:t>
+            </a:r>
+            <a:r>
+              <a:rPr lang="en-US" sz="2550" dirty="0" spc="1" kern="0">
                 <a:solidFill>
                   <a:srgbClr val="F3EEE3"/>
                 </a:solidFill>
@@ -9953,10 +9920,10 @@
                 <a:ea typeface="Be Vietnam Pro" pitchFamily="34" charset="-122"/>
                 <a:cs typeface="Be Vietnam Pro" pitchFamily="34" charset="-120"/>
               </a:rPr>
-              <a:t> giữ</a:t>
-            </a:r>
-            <a:r>
-              <a:rPr lang="en-US" sz="2550" dirty="0" spc="-12" kern="0">
+              <a:t> chậm</a:t>
+            </a:r>
+            <a:r>
+              <a:rPr lang="en-US" sz="2550" dirty="0" spc="0" kern="0">
                 <a:solidFill>
                   <a:srgbClr val="F3EEE3"/>
                 </a:solidFill>
@@ -9964,95 +9931,7 @@
                 <a:ea typeface="Be Vietnam Pro" pitchFamily="34" charset="-122"/>
                 <a:cs typeface="Be Vietnam Pro" pitchFamily="34" charset="-120"/>
               </a:rPr>
-              <a:t> nguyên</a:t>
-            </a:r>
-            <a:r>
-              <a:rPr lang="en-US" sz="2550" dirty="0" spc="1" kern="0">
-                <a:solidFill>
-                  <a:srgbClr val="F3EEE3"/>
-                </a:solidFill>
-                <a:latin typeface="Be Vietnam Pro" pitchFamily="34" charset="0"/>
-                <a:ea typeface="Be Vietnam Pro" pitchFamily="34" charset="-122"/>
-                <a:cs typeface="Be Vietnam Pro" pitchFamily="34" charset="-120"/>
-              </a:rPr>
-              <a:t> dạng mã</a:t>
-            </a:r>
-            <a:r>
-              <a:rPr lang="en-US" sz="2550" dirty="0" spc="0" kern="0">
-                <a:solidFill>
-                  <a:srgbClr val="F3EEE3"/>
-                </a:solidFill>
-                <a:latin typeface="Be Vietnam Pro" pitchFamily="34" charset="0"/>
-                <a:ea typeface="Be Vietnam Pro" pitchFamily="34" charset="-122"/>
-                <a:cs typeface="Be Vietnam Pro" pitchFamily="34" charset="-120"/>
-              </a:rPr>
-              <a:t> nguồn,</a:t>
-            </a:r>
-            <a:r>
-              <a:rPr lang="en-US" sz="2550" dirty="0" spc="1" kern="0">
-                <a:solidFill>
-                  <a:srgbClr val="F3EEE3"/>
-                </a:solidFill>
-                <a:latin typeface="Be Vietnam Pro" pitchFamily="34" charset="0"/>
-                <a:ea typeface="Be Vietnam Pro" pitchFamily="34" charset="-122"/>
-                <a:cs typeface="Be Vietnam Pro" pitchFamily="34" charset="-120"/>
-              </a:rPr>
-              <a:t> không</a:t>
-            </a:r>
-            <a:r>
-              <a:rPr lang="en-US" sz="2550" dirty="0" spc="-1" kern="0">
-                <a:solidFill>
-                  <a:srgbClr val="F3EEE3"/>
-                </a:solidFill>
-                <a:latin typeface="Be Vietnam Pro" pitchFamily="34" charset="0"/>
-                <a:ea typeface="Be Vietnam Pro" pitchFamily="34" charset="-122"/>
-                <a:cs typeface="Be Vietnam Pro" pitchFamily="34" charset="-120"/>
-              </a:rPr>
-              <a:t> có</a:t>
-            </a:r>
-            <a:r>
-              <a:rPr lang="en-US" sz="2550" dirty="0" spc="6" kern="0">
-                <a:solidFill>
-                  <a:srgbClr val="F3EEE3"/>
-                </a:solidFill>
-                <a:latin typeface="Be Vietnam Pro" pitchFamily="34" charset="0"/>
-                <a:ea typeface="Be Vietnam Pro" pitchFamily="34" charset="-122"/>
-                <a:cs typeface="Be Vietnam Pro" pitchFamily="34" charset="-120"/>
-              </a:rPr>
-              <a:t> bước</a:t>
-            </a:r>
-            <a:r>
-              <a:rPr lang="en-US" sz="2550" dirty="0" spc="0" kern="0">
-                <a:solidFill>
-                  <a:srgbClr val="F3EEE3"/>
-                </a:solidFill>
-                <a:latin typeface="Be Vietnam Pro" pitchFamily="34" charset="0"/>
-                <a:ea typeface="Be Vietnam Pro" pitchFamily="34" charset="-122"/>
-                <a:cs typeface="Be Vietnam Pro" pitchFamily="34" charset="-120"/>
-              </a:rPr>
-              <a:t> biên</a:t>
-            </a:r>
-            <a:r>
-              <a:rPr lang="en-US" sz="2550" dirty="0" spc="1" kern="0">
-                <a:solidFill>
-                  <a:srgbClr val="F3EEE3"/>
-                </a:solidFill>
-                <a:latin typeface="Be Vietnam Pro" pitchFamily="34" charset="0"/>
-                <a:ea typeface="Be Vietnam Pro" pitchFamily="34" charset="-122"/>
-                <a:cs typeface="Be Vietnam Pro" pitchFamily="34" charset="-120"/>
-              </a:rPr>
-              <a:t> dịch</a:t>
-            </a:r>
-            <a:r>
-              <a:rPr lang="en-US" sz="2550" dirty="0" spc="5" kern="0">
-                <a:solidFill>
-                  <a:srgbClr val="F3EEE3"/>
-                </a:solidFill>
-                <a:latin typeface="Be Vietnam Pro" pitchFamily="34" charset="0"/>
-                <a:ea typeface="Be Vietnam Pro" pitchFamily="34" charset="-122"/>
-                <a:cs typeface="Be Vietnam Pro" pitchFamily="34" charset="-120"/>
-              </a:rPr>
-              <a:t> trước.</a:t>
+              <a:t> hơn.</a:t>
             </a:r>
             <a:endParaRPr lang="en-US" sz="2550" dirty="0"/>
           </a:p>
@@ -10264,7 +10143,7 @@
               <a:buNone/>
             </a:pPr>
             <a:r>
-              <a:rPr lang="en-US" sz="3150" b="1" dirty="0" spc="-11" kern="0">
+              <a:rPr lang="en-US" sz="3150" b="1" dirty="0" spc="-13" kern="0">
                 <a:solidFill>
                   <a:srgbClr val="F3EEE3"/>
                 </a:solidFill>
@@ -10272,10 +10151,10 @@
                 <a:ea typeface="Be Vietnam Pro" pitchFamily="34" charset="-122"/>
                 <a:cs typeface="Be Vietnam Pro" pitchFamily="34" charset="-120"/>
               </a:rPr>
-              <a:t>Không</a:t>
-            </a:r>
-            <a:r>
-              <a:rPr lang="en-US" sz="3150" b="1" dirty="0" spc="-5" kern="0">
+              <a:t>Chạy</a:t>
+            </a:r>
+            <a:r>
+              <a:rPr lang="en-US" sz="3150" b="1" dirty="0" spc="-4" kern="0">
                 <a:solidFill>
                   <a:srgbClr val="F3EEE3"/>
                 </a:solidFill>
@@ -10283,10 +10162,10 @@
                 <a:ea typeface="Be Vietnam Pro" pitchFamily="34" charset="-122"/>
                 <a:cs typeface="Be Vietnam Pro" pitchFamily="34" charset="-120"/>
               </a:rPr>
-              <a:t> biên</a:t>
-            </a:r>
-            <a:r>
-              <a:rPr lang="en-US" sz="3150" b="1" dirty="0" spc="0" kern="0">
+              <a:t> thẳng</a:t>
+            </a:r>
+            <a:r>
+              <a:rPr lang="en-US" sz="3150" b="1" dirty="0" spc="-7" kern="0">
                 <a:solidFill>
                   <a:srgbClr val="F3EEE3"/>
                 </a:solidFill>
@@ -10294,10 +10173,10 @@
                 <a:ea typeface="Be Vietnam Pro" pitchFamily="34" charset="-122"/>
                 <a:cs typeface="Be Vietnam Pro" pitchFamily="34" charset="-120"/>
               </a:rPr>
-              <a:t> dịch</a:t>
-            </a:r>
-            <a:r>
-              <a:rPr lang="en-US" sz="3150" b="1" dirty="0" spc="11" kern="0">
+              <a:t> mã</a:t>
+            </a:r>
+            <a:r>
+              <a:rPr lang="en-US" sz="3150" b="1" dirty="0" spc="-8" kern="0">
                 <a:solidFill>
                   <a:srgbClr val="F3EEE3"/>
                 </a:solidFill>
@@ -10305,7 +10184,7 @@
                 <a:ea typeface="Be Vietnam Pro" pitchFamily="34" charset="-122"/>
                 <a:cs typeface="Be Vietnam Pro" pitchFamily="34" charset="-120"/>
               </a:rPr>
-              <a:t> trước</a:t>
+              <a:t> nguồn</a:t>
             </a:r>
             <a:endParaRPr lang="en-US" sz="3150" dirty="0"/>
           </a:p>
@@ -10545,7 +10424,7 @@
               <a:buNone/>
             </a:pPr>
             <a:r>
-              <a:rPr lang="en-US" sz="2550" dirty="0" spc="-9" kern="0">
+              <a:rPr lang="en-US" sz="2550" dirty="0" spc="-5" kern="0">
                 <a:solidFill>
                   <a:srgbClr val="C4C8D6"/>
                 </a:solidFill>
@@ -10553,7 +10432,29 @@
                 <a:ea typeface="Be Vietnam Pro" pitchFamily="34" charset="-122"/>
                 <a:cs typeface="Be Vietnam Pro" pitchFamily="34" charset="-120"/>
               </a:rPr>
-              <a:t>Chạy</a:t>
+              <a:t>Đọc</a:t>
+            </a:r>
+            <a:r>
+              <a:rPr lang="en-US" sz="2550" dirty="0" spc="-19" kern="0">
+                <a:solidFill>
+                  <a:srgbClr val="C4C8D6"/>
+                </a:solidFill>
+                <a:latin typeface="Be Vietnam Pro" pitchFamily="34" charset="0"/>
+                <a:ea typeface="Be Vietnam Pro" pitchFamily="34" charset="-122"/>
+                <a:cs typeface="Be Vietnam Pro" pitchFamily="34" charset="-120"/>
+              </a:rPr>
+              <a:t> và</a:t>
+            </a:r>
+            <a:r>
+              <a:rPr lang="en-US" sz="2550" dirty="0" spc="-7" kern="0">
+                <a:solidFill>
+                  <a:srgbClr val="C4C8D6"/>
+                </a:solidFill>
+                <a:latin typeface="Be Vietnam Pro" pitchFamily="34" charset="0"/>
+                <a:ea typeface="Be Vietnam Pro" pitchFamily="34" charset="-122"/>
+                <a:cs typeface="Be Vietnam Pro" pitchFamily="34" charset="-120"/>
+              </a:rPr>
+              <a:t> chạy</a:t>
             </a:r>
             <a:r>
               <a:rPr lang="en-US" sz="2550" dirty="0" spc="4" kern="0">
@@ -10578,7 +10479,7 @@
               <a:t> trình</a:t>
             </a:r>
             <a:r>
-              <a:rPr lang="en-US" sz="2550" dirty="0" spc="-18" kern="0">
+              <a:rPr lang="en-US" sz="2550" dirty="0" spc="-1" kern="0">
                 <a:solidFill>
                   <a:srgbClr val="C4C8D6"/>
                 </a:solidFill>
@@ -10586,10 +10487,10 @@
                 <a:ea typeface="Be Vietnam Pro" pitchFamily="34" charset="-122"/>
                 <a:cs typeface="Be Vietnam Pro" pitchFamily="34" charset="-120"/>
               </a:rPr>
-              <a:t> ngay</a:t>
-            </a:r>
-            <a:r>
-              <a:rPr lang="en-US" sz="2550" dirty="0" spc="-2" kern="0">
+              <a:t> khi</a:t>
+            </a:r>
+            <a:r>
+              <a:rPr lang="en-US" sz="2550" dirty="0" spc="1" kern="0">
                 <a:solidFill>
                   <a:srgbClr val="C4C8D6"/>
                 </a:solidFill>
@@ -10597,18 +10498,7 @@
                 <a:ea typeface="Be Vietnam Pro" pitchFamily="34" charset="-122"/>
                 <a:cs typeface="Be Vietnam Pro" pitchFamily="34" charset="-120"/>
               </a:rPr>
-              <a:t> lúc</a:t>
-            </a:r>
-            <a:r>
-              <a:rPr lang="en-US" sz="2550" dirty="0" spc="-6" kern="0">
-                <a:solidFill>
-                  <a:srgbClr val="C4C8D6"/>
-                </a:solidFill>
-                <a:latin typeface="Be Vietnam Pro" pitchFamily="34" charset="0"/>
-                <a:ea typeface="Be Vietnam Pro" pitchFamily="34" charset="-122"/>
-                <a:cs typeface="Be Vietnam Pro" pitchFamily="34" charset="-120"/>
-              </a:rPr>
-              <a:t> chạy.</a:t>
+              <a:t> cần.</a:t>
             </a:r>
             <a:endParaRPr lang="en-US" sz="2550" dirty="0"/>
           </a:p>
@@ -10961,7 +10851,7 @@
               <a:buNone/>
             </a:pPr>
             <a:r>
-              <a:rPr lang="en-US" sz="2550" dirty="0" spc="5" kern="0">
+              <a:rPr lang="en-US" sz="2550" dirty="0" spc="-1" kern="0">
                 <a:solidFill>
                   <a:srgbClr val="C4C8D6"/>
                 </a:solidFill>
@@ -10969,10 +10859,10 @@
                 <a:ea typeface="Be Vietnam Pro" pitchFamily="34" charset="-122"/>
                 <a:cs typeface="Be Vietnam Pro" pitchFamily="34" charset="-120"/>
               </a:rPr>
-              <a:t>Chương</a:t>
-            </a:r>
-            <a:r>
-              <a:rPr lang="en-US" sz="2550" dirty="0" spc="10" kern="0">
+              <a:t>Không</a:t>
+            </a:r>
+            <a:r>
+              <a:rPr lang="en-US" sz="2550" dirty="0" spc="-12" kern="0">
                 <a:solidFill>
                   <a:srgbClr val="C4C8D6"/>
                 </a:solidFill>
@@ -10980,10 +10870,10 @@
                 <a:ea typeface="Be Vietnam Pro" pitchFamily="34" charset="-122"/>
                 <a:cs typeface="Be Vietnam Pro" pitchFamily="34" charset="-120"/>
               </a:rPr>
-              <a:t> trình</a:t>
-            </a:r>
-            <a:r>
-              <a:rPr lang="en-US" sz="2550" dirty="0" spc="-2" kern="0">
+              <a:t> tạo</a:t>
+            </a:r>
+            <a:r>
+              <a:rPr lang="en-US" sz="2550" dirty="0" spc="-11" kern="0">
                 <a:solidFill>
                   <a:srgbClr val="C4C8D6"/>
                 </a:solidFill>
@@ -10991,18 +10881,7 @@
                 <a:ea typeface="Be Vietnam Pro" pitchFamily="34" charset="-122"/>
                 <a:cs typeface="Be Vietnam Pro" pitchFamily="34" charset="-120"/>
               </a:rPr>
-              <a:t> giữ</a:t>
-            </a:r>
-            <a:r>
-              <a:rPr lang="en-US" sz="2550" dirty="0" spc="-12" kern="0">
-                <a:solidFill>
-                  <a:srgbClr val="C4C8D6"/>
-                </a:solidFill>
-                <a:latin typeface="Be Vietnam Pro" pitchFamily="34" charset="0"/>
-                <a:ea typeface="Be Vietnam Pro" pitchFamily="34" charset="-122"/>
-                <a:cs typeface="Be Vietnam Pro" pitchFamily="34" charset="-120"/>
-              </a:rPr>
-              <a:t> nguyên</a:t>
+              <a:t> tệp</a:t>
             </a:r>
             <a:endParaRPr lang="en-US" sz="2550" dirty="0"/>
           </a:p>
@@ -11014,7 +10893,7 @@
               <a:buNone/>
             </a:pPr>
             <a:r>
-              <a:rPr lang="en-US" sz="2550" dirty="0" spc="1" kern="0">
+              <a:rPr lang="en-US" sz="2550" dirty="0" spc="-9" kern="0">
                 <a:solidFill>
                   <a:srgbClr val="C4C8D6"/>
                 </a:solidFill>
@@ -11022,7 +10901,29 @@
                 <a:ea typeface="Be Vietnam Pro" pitchFamily="34" charset="-122"/>
                 <a:cs typeface="Be Vietnam Pro" pitchFamily="34" charset="-120"/>
               </a:rPr>
-              <a:t>dạng mã nguồn.</a:t>
+              <a:t>chạy</a:t>
+            </a:r>
+            <a:r>
+              <a:rPr lang="en-US" sz="2550" dirty="0" spc="6" kern="0">
+                <a:solidFill>
+                  <a:srgbClr val="C4C8D6"/>
+                </a:solidFill>
+                <a:latin typeface="Be Vietnam Pro" pitchFamily="34" charset="0"/>
+                <a:ea typeface="Be Vietnam Pro" pitchFamily="34" charset="-122"/>
+                <a:cs typeface="Be Vietnam Pro" pitchFamily="34" charset="-120"/>
+              </a:rPr>
+              <a:t> được</a:t>
+            </a:r>
+            <a:r>
+              <a:rPr lang="en-US" sz="2550" dirty="0" spc="8" kern="0">
+                <a:solidFill>
+                  <a:srgbClr val="C4C8D6"/>
+                </a:solidFill>
+                <a:latin typeface="Be Vietnam Pro" pitchFamily="34" charset="0"/>
+                <a:ea typeface="Be Vietnam Pro" pitchFamily="34" charset="-122"/>
+                <a:cs typeface="Be Vietnam Pro" pitchFamily="34" charset="-120"/>
+              </a:rPr>
+              <a:t> riêng.</a:t>
             </a:r>
             <a:endParaRPr lang="en-US" sz="2550" dirty="0"/>
           </a:p>
@@ -13766,10 +13667,21 @@
                 <a:ea typeface="Be Vietnam Pro" pitchFamily="34" charset="-122"/>
                 <a:cs typeface="Be Vietnam Pro" pitchFamily="34" charset="-120"/>
               </a:rPr>
-              <a:t> Python</a:t>
-            </a:r>
-            <a:r>
-              <a:rPr lang="en-US" sz="2850" dirty="0" spc="-15" kern="0">
+              <a:t> Python,</a:t>
+            </a:r>
+            <a:r>
+              <a:rPr lang="en-US" sz="2850" dirty="0" spc="-3" kern="0">
+                <a:solidFill>
+                  <a:srgbClr val="F3EEE3"/>
+                </a:solidFill>
+                <a:latin typeface="Be Vietnam Pro" pitchFamily="34" charset="0"/>
+                <a:ea typeface="Be Vietnam Pro" pitchFamily="34" charset="-122"/>
+                <a:cs typeface="Be Vietnam Pro" pitchFamily="34" charset="-120"/>
+              </a:rPr>
+              <a:t> OpenJDK</a:t>
+            </a:r>
+            <a:r>
+              <a:rPr lang="en-US" sz="2850" dirty="0" spc="-16" kern="0">
                 <a:solidFill>
                   <a:srgbClr val="F3EEE3"/>
                 </a:solidFill>
@@ -14974,7 +14886,7 @@
               <a:buNone/>
             </a:pPr>
             <a:r>
-              <a:rPr lang="en-US" sz="3000" b="1" dirty="0" spc="-8" kern="0">
+              <a:rPr lang="en-US" sz="3000" b="1" dirty="0" spc="4" kern="0">
                 <a:solidFill>
                   <a:srgbClr val="F3EEE3"/>
                 </a:solidFill>
@@ -14982,10 +14894,10 @@
                 <a:ea typeface="Be Vietnam Pro" pitchFamily="34" charset="-122"/>
                 <a:cs typeface="Be Vietnam Pro" pitchFamily="34" charset="-120"/>
               </a:rPr>
-              <a:t>Nguồn</a:t>
-            </a:r>
-            <a:r>
-              <a:rPr lang="en-US" sz="3000" b="1" dirty="0" spc="-11" kern="0">
+              <a:t>Bài</a:t>
+            </a:r>
+            <a:r>
+              <a:rPr lang="en-US" sz="3000" b="1" dirty="0" spc="-10" kern="0">
                 <a:solidFill>
                   <a:srgbClr val="F3EEE3"/>
                 </a:solidFill>
@@ -14996,7 +14908,7 @@
               <a:t> không</a:t>
             </a:r>
             <a:r>
-              <a:rPr lang="en-US" sz="3000" b="1" dirty="0" spc="-5" kern="0">
+              <a:rPr lang="en-US" sz="3000" b="1" dirty="0" spc="-6" kern="0">
                 <a:solidFill>
                   <a:srgbClr val="F3EEE3"/>
                 </a:solidFill>
@@ -15018,7 +14930,7 @@
               <a:t> số</a:t>
             </a:r>
             <a:r>
-              <a:rPr lang="en-US" sz="3000" b="1" dirty="0" spc="9" kern="0">
+              <a:rPr lang="en-US" sz="3000" b="1" dirty="0" spc="10" kern="0">
                 <a:solidFill>
                   <a:srgbClr val="F3EEE3"/>
                 </a:solidFill>
@@ -15060,7 +14972,7 @@
               <a:buNone/>
             </a:pPr>
             <a:r>
-              <a:rPr lang="en-US" sz="2400" dirty="0" spc="-1" kern="0">
+              <a:rPr lang="en-US" sz="2400" dirty="0" spc="2" kern="0">
                 <a:solidFill>
                   <a:srgbClr val="C4C8D6"/>
                 </a:solidFill>
@@ -15068,10 +14980,10 @@
                 <a:ea typeface="Be Vietnam Pro" pitchFamily="34" charset="-122"/>
                 <a:cs typeface="Be Vietnam Pro" pitchFamily="34" charset="-120"/>
               </a:rPr>
-              <a:t>"Nhanh</a:t>
-            </a:r>
-            <a:r>
-              <a:rPr lang="en-US" sz="2400" dirty="0" spc="2" kern="0">
+              <a:t>"Chậm</a:t>
+            </a:r>
+            <a:r>
+              <a:rPr lang="en-US" sz="2400" dirty="0" spc="1" kern="0">
                 <a:solidFill>
                   <a:srgbClr val="C4C8D6"/>
                 </a:solidFill>
@@ -16052,32 +15964,43 @@
                 <a:ea typeface="Be Vietnam Pro" pitchFamily="34" charset="-122"/>
                 <a:cs typeface="Be Vietnam Pro" pitchFamily="34" charset="-120"/>
               </a:rPr>
-              <a:t> thì có gì khác</a:t>
-            </a:r>
-            <a:r>
-              <a:rPr lang="en-US" sz="2550" dirty="0" spc="-17" kern="0">
-                <a:solidFill>
-                  <a:srgbClr val="14161C"/>
-                </a:solidFill>
-                <a:latin typeface="Be Vietnam Pro" pitchFamily="34" charset="0"/>
-                <a:ea typeface="Be Vietnam Pro" pitchFamily="34" charset="-122"/>
-                <a:cs typeface="Be Vietnam Pro" pitchFamily="34" charset="-120"/>
-              </a:rPr>
-              <a:t> trong</a:t>
-            </a:r>
-            <a:r>
-              <a:rPr lang="en-US" sz="2550" dirty="0" spc="1" kern="0">
-                <a:solidFill>
-                  <a:srgbClr val="14161C"/>
-                </a:solidFill>
-                <a:latin typeface="Be Vietnam Pro" pitchFamily="34" charset="0"/>
-                <a:ea typeface="Be Vietnam Pro" pitchFamily="34" charset="-122"/>
-                <a:cs typeface="Be Vietnam Pro" pitchFamily="34" charset="-120"/>
-              </a:rPr>
-              <a:t> nguồn,</a:t>
-            </a:r>
-            <a:r>
-              <a:rPr lang="en-US" sz="2550" dirty="0" spc="-19" kern="0">
+              <a:t> thì</a:t>
+            </a:r>
+            <a:r>
+              <a:rPr lang="en-US" sz="2550" dirty="0" spc="-7" kern="0">
+                <a:solidFill>
+                  <a:srgbClr val="14161C"/>
+                </a:solidFill>
+                <a:latin typeface="Be Vietnam Pro" pitchFamily="34" charset="0"/>
+                <a:ea typeface="Be Vietnam Pro" pitchFamily="34" charset="-122"/>
+                <a:cs typeface="Be Vietnam Pro" pitchFamily="34" charset="-120"/>
+              </a:rPr>
+              <a:t> chạy</a:t>
+            </a:r>
+            <a:r>
+              <a:rPr lang="en-US" sz="2550" dirty="0" spc="-35" kern="0">
+                <a:solidFill>
+                  <a:srgbClr val="14161C"/>
+                </a:solidFill>
+                <a:latin typeface="Be Vietnam Pro" pitchFamily="34" charset="0"/>
+                <a:ea typeface="Be Vietnam Pro" pitchFamily="34" charset="-122"/>
+                <a:cs typeface="Be Vietnam Pro" pitchFamily="34" charset="-120"/>
+              </a:rPr>
+              <a:t> ra</a:t>
+            </a:r>
+            <a:r>
+              <a:rPr lang="en-US" sz="2550" dirty="0" spc="-7" kern="0">
+                <a:solidFill>
+                  <a:srgbClr val="14161C"/>
+                </a:solidFill>
+                <a:latin typeface="Be Vietnam Pro" pitchFamily="34" charset="0"/>
+                <a:ea typeface="Be Vietnam Pro" pitchFamily="34" charset="-122"/>
+                <a:cs typeface="Be Vietnam Pro" pitchFamily="34" charset="-120"/>
+              </a:rPr>
+              <a:t> sao,</a:t>
+            </a:r>
+            <a:r>
+              <a:rPr lang="en-US" sz="2550" dirty="0" spc="-18" kern="0">
                 <a:solidFill>
                   <a:srgbClr val="14161C"/>
                 </a:solidFill>
@@ -16088,48 +16011,48 @@
               <a:t> và</a:t>
             </a:r>
             <a:r>
-              <a:rPr lang="en-US" sz="2550" dirty="0" spc="-12" kern="0">
-                <a:solidFill>
-                  <a:srgbClr val="14161C"/>
-                </a:solidFill>
-                <a:latin typeface="Be Vietnam Pro" pitchFamily="34" charset="0"/>
-                <a:ea typeface="Be Vietnam Pro" pitchFamily="34" charset="-122"/>
-                <a:cs typeface="Be Vietnam Pro" pitchFamily="34" charset="-120"/>
-              </a:rPr>
-              <a:t> tài</a:t>
-            </a:r>
-            <a:r>
-              <a:rPr lang="en-US" sz="2550" dirty="0" spc="1" kern="0">
-                <a:solidFill>
-                  <a:srgbClr val="14161C"/>
-                </a:solidFill>
-                <a:latin typeface="Be Vietnam Pro" pitchFamily="34" charset="0"/>
-                <a:ea typeface="Be Vietnam Pro" pitchFamily="34" charset="-122"/>
-                <a:cs typeface="Be Vietnam Pro" pitchFamily="34" charset="-120"/>
-              </a:rPr>
-              <a:t> liệu</a:t>
-            </a:r>
-            <a:r>
-              <a:rPr lang="en-US" sz="2550" dirty="0" spc="8" kern="0">
-                <a:solidFill>
-                  <a:srgbClr val="14161C"/>
-                </a:solidFill>
-                <a:latin typeface="Be Vietnam Pro" pitchFamily="34" charset="0"/>
-                <a:ea typeface="Be Vietnam Pro" pitchFamily="34" charset="-122"/>
-                <a:cs typeface="Be Vietnam Pro" pitchFamily="34" charset="-120"/>
-              </a:rPr>
-              <a:t> Python</a:t>
-            </a:r>
-            <a:r>
-              <a:rPr lang="en-US" sz="2550" dirty="0" spc="-4" kern="0">
-                <a:solidFill>
-                  <a:srgbClr val="14161C"/>
-                </a:solidFill>
-                <a:latin typeface="Be Vietnam Pro" pitchFamily="34" charset="0"/>
-                <a:ea typeface="Be Vietnam Pro" pitchFamily="34" charset="-122"/>
-                <a:cs typeface="Be Vietnam Pro" pitchFamily="34" charset="-120"/>
-              </a:rPr>
-              <a:t> bổ</a:t>
+              <a:rPr lang="en-US" sz="2550" dirty="0" spc="-1" kern="0">
+                <a:solidFill>
+                  <a:srgbClr val="14161C"/>
+                </a:solidFill>
+                <a:latin typeface="Be Vietnam Pro" pitchFamily="34" charset="0"/>
+                <a:ea typeface="Be Vietnam Pro" pitchFamily="34" charset="-122"/>
+                <a:cs typeface="Be Vietnam Pro" pitchFamily="34" charset="-120"/>
+              </a:rPr>
+              <a:t> vì</a:t>
+            </a:r>
+            <a:r>
+              <a:rPr lang="en-US" sz="2550" dirty="0" spc="-8" kern="0">
+                <a:solidFill>
+                  <a:srgbClr val="14161C"/>
+                </a:solidFill>
+                <a:latin typeface="Be Vietnam Pro" pitchFamily="34" charset="0"/>
+                <a:ea typeface="Be Vietnam Pro" pitchFamily="34" charset="-122"/>
+                <a:cs typeface="Be Vietnam Pro" pitchFamily="34" charset="-120"/>
+              </a:rPr>
+              <a:t> sao</a:t>
+            </a:r>
+            <a:r>
+              <a:rPr lang="en-US" sz="2550" dirty="0" spc="-21" kern="0">
+                <a:solidFill>
+                  <a:srgbClr val="14161C"/>
+                </a:solidFill>
+                <a:latin typeface="Be Vietnam Pro" pitchFamily="34" charset="0"/>
+                <a:ea typeface="Be Vietnam Pro" pitchFamily="34" charset="-122"/>
+                <a:cs typeface="Be Vietnam Pro" pitchFamily="34" charset="-120"/>
+              </a:rPr>
+              <a:t> ranh</a:t>
+            </a:r>
+            <a:r>
+              <a:rPr lang="en-US" sz="2550" dirty="0" spc="-1" kern="0">
+                <a:solidFill>
+                  <a:srgbClr val="14161C"/>
+                </a:solidFill>
+                <a:latin typeface="Be Vietnam Pro" pitchFamily="34" charset="0"/>
+                <a:ea typeface="Be Vietnam Pro" pitchFamily="34" charset="-122"/>
+                <a:cs typeface="Be Vietnam Pro" pitchFamily="34" charset="-120"/>
+              </a:rPr>
+              <a:t> giới</a:t>
             </a:r>
             <a:r>
               <a:rPr lang="en-US" sz="2550" dirty="0" spc="0" kern="0">
@@ -16140,29 +16063,7 @@
                 <a:ea typeface="Be Vietnam Pro" pitchFamily="34" charset="-122"/>
                 <a:cs typeface="Be Vietnam Pro" pitchFamily="34" charset="-120"/>
               </a:rPr>
-              <a:t> sung</a:t>
-            </a:r>
-            <a:r>
-              <a:rPr lang="en-US" sz="2550" dirty="0" spc="22" kern="0">
-                <a:solidFill>
-                  <a:srgbClr val="14161C"/>
-                </a:solidFill>
-                <a:latin typeface="Be Vietnam Pro" pitchFamily="34" charset="0"/>
-                <a:ea typeface="Be Vietnam Pro" pitchFamily="34" charset="-122"/>
-                <a:cs typeface="Be Vietnam Pro" pitchFamily="34" charset="-120"/>
-              </a:rPr>
-              <a:t> điều</a:t>
-            </a:r>
-            <a:r>
-              <a:rPr lang="en-US" sz="2550" dirty="0" spc="0" kern="0">
-                <a:solidFill>
-                  <a:srgbClr val="14161C"/>
-                </a:solidFill>
-                <a:latin typeface="Be Vietnam Pro" pitchFamily="34" charset="0"/>
-                <a:ea typeface="Be Vietnam Pro" pitchFamily="34" charset="-122"/>
-                <a:cs typeface="Be Vietnam Pro" pitchFamily="34" charset="-120"/>
-              </a:rPr>
-              <a:t> gì?</a:t>
+              <a:t> mờ?</a:t>
             </a:r>
             <a:endParaRPr lang="en-US" sz="2550" dirty="0"/>
           </a:p>
@@ -16369,6 +16270,28 @@
               <a:t>JVM</a:t>
             </a:r>
             <a:r>
+              <a:rPr lang="en-US" sz="2400" dirty="0" spc="3" kern="0">
+                <a:solidFill>
+                  <a:srgbClr val="14161C"/>
+                </a:solidFill>
+                <a:latin typeface="Be Vietnam Pro" pitchFamily="34" charset="0"/>
+                <a:ea typeface="Be Vietnam Pro" pitchFamily="34" charset="-122"/>
+                <a:cs typeface="Be Vietnam Pro" pitchFamily="34" charset="-120"/>
+              </a:rPr>
+              <a:t> nạp</a:t>
+            </a:r>
+            <a:r>
+              <a:rPr lang="en-US" sz="2400" dirty="0" spc="-16" kern="0">
+                <a:solidFill>
+                  <a:srgbClr val="14161C"/>
+                </a:solidFill>
+                <a:latin typeface="Be Vietnam Pro" pitchFamily="34" charset="0"/>
+                <a:ea typeface="Be Vietnam Pro" pitchFamily="34" charset="-122"/>
+                <a:cs typeface="Be Vietnam Pro" pitchFamily="34" charset="-120"/>
+              </a:rPr>
+              <a:t> và</a:t>
+            </a:r>
+            <a:r>
               <a:rPr lang="en-US" sz="2400" dirty="0" spc="-7" kern="0">
                 <a:solidFill>
                   <a:srgbClr val="14161C"/>
@@ -16391,6 +16314,28 @@
               <a:t> bytecode.</a:t>
             </a:r>
             <a:r>
+              <a:rPr lang="en-US" sz="2400" dirty="0" spc="-1" kern="0">
+                <a:solidFill>
+                  <a:srgbClr val="14161C"/>
+                </a:solidFill>
+                <a:latin typeface="Be Vietnam Pro" pitchFamily="34" charset="0"/>
+                <a:ea typeface="Be Vietnam Pro" pitchFamily="34" charset="-122"/>
+                <a:cs typeface="Be Vietnam Pro" pitchFamily="34" charset="-120"/>
+              </a:rPr>
+              <a:t> JIT</a:t>
+            </a:r>
+            <a:r>
+              <a:rPr lang="en-US" sz="2400" dirty="0" spc="0" kern="0">
+                <a:solidFill>
+                  <a:srgbClr val="14161C"/>
+                </a:solidFill>
+                <a:latin typeface="Be Vietnam Pro" pitchFamily="34" charset="0"/>
+                <a:ea typeface="Be Vietnam Pro" pitchFamily="34" charset="-122"/>
+                <a:cs typeface="Be Vietnam Pro" pitchFamily="34" charset="-120"/>
+              </a:rPr>
+              <a:t> có</a:t>
+            </a:r>
+            <a:r>
               <a:rPr lang="en-US" sz="2400" dirty="0" spc="1" kern="0">
                 <a:solidFill>
                   <a:srgbClr val="14161C"/>
@@ -16399,18 +16344,40 @@
                 <a:ea typeface="Be Vietnam Pro" pitchFamily="34" charset="-122"/>
                 <a:cs typeface="Be Vietnam Pro" pitchFamily="34" charset="-120"/>
               </a:rPr>
-              <a:t> Đôi</a:t>
-            </a:r>
-            <a:r>
-              <a:rPr lang="en-US" sz="2400" dirty="0" spc="-2" kern="0">
-                <a:solidFill>
-                  <a:srgbClr val="14161C"/>
-                </a:solidFill>
-                <a:latin typeface="Be Vietnam Pro" pitchFamily="34" charset="0"/>
-                <a:ea typeface="Be Vietnam Pro" pitchFamily="34" charset="-122"/>
-                <a:cs typeface="Be Vietnam Pro" pitchFamily="34" charset="-120"/>
-              </a:rPr>
-              <a:t> khi</a:t>
+              <a:t> thể</a:t>
+            </a:r>
+            <a:r>
+              <a:rPr lang="en-US" sz="2400" dirty="0" spc="0" kern="0">
+                <a:solidFill>
+                  <a:srgbClr val="14161C"/>
+                </a:solidFill>
+                <a:latin typeface="Be Vietnam Pro" pitchFamily="34" charset="0"/>
+                <a:ea typeface="Be Vietnam Pro" pitchFamily="34" charset="-122"/>
+                <a:cs typeface="Be Vietnam Pro" pitchFamily="34" charset="-120"/>
+              </a:rPr>
+              <a:t> dịch</a:t>
+            </a:r>
+            <a:r>
+              <a:rPr lang="en-US" sz="2400" dirty="0" spc="9" kern="0">
+                <a:solidFill>
+                  <a:srgbClr val="14161C"/>
+                </a:solidFill>
+                <a:latin typeface="Be Vietnam Pro" pitchFamily="34" charset="0"/>
+                <a:ea typeface="Be Vietnam Pro" pitchFamily="34" charset="-122"/>
+                <a:cs typeface="Be Vietnam Pro" pitchFamily="34" charset="-120"/>
+              </a:rPr>
+              <a:t> đoạn</a:t>
+            </a:r>
+            <a:r>
+              <a:rPr lang="en-US" sz="2400" dirty="0" spc="-7" kern="0">
+                <a:solidFill>
+                  <a:srgbClr val="14161C"/>
+                </a:solidFill>
+                <a:latin typeface="Be Vietnam Pro" pitchFamily="34" charset="0"/>
+                <a:ea typeface="Be Vietnam Pro" pitchFamily="34" charset="-122"/>
+                <a:cs typeface="Be Vietnam Pro" pitchFamily="34" charset="-120"/>
+              </a:rPr>
+              <a:t> chạy</a:t>
             </a:r>
             <a:r>
               <a:rPr lang="en-US" sz="2400" dirty="0" spc="-1" kern="0">
@@ -16421,7 +16388,40 @@
                 <a:ea typeface="Be Vietnam Pro" pitchFamily="34" charset="-122"/>
                 <a:cs typeface="Be Vietnam Pro" pitchFamily="34" charset="-120"/>
               </a:rPr>
-              <a:t> JIT</a:t>
+              <a:t> nhiều</a:t>
+            </a:r>
+            <a:r>
+              <a:rPr lang="en-US" sz="2400" dirty="0" spc="-4" kern="0">
+                <a:solidFill>
+                  <a:srgbClr val="14161C"/>
+                </a:solidFill>
+                <a:latin typeface="Be Vietnam Pro" pitchFamily="34" charset="0"/>
+                <a:ea typeface="Be Vietnam Pro" pitchFamily="34" charset="-122"/>
+                <a:cs typeface="Be Vietnam Pro" pitchFamily="34" charset="-120"/>
+              </a:rPr>
+              <a:t> sang</a:t>
+            </a:r>
+            <a:r>
+              <a:rPr lang="en-US" sz="2400" dirty="0" spc="5" kern="0">
+                <a:solidFill>
+                  <a:srgbClr val="14161C"/>
+                </a:solidFill>
+                <a:latin typeface="Be Vietnam Pro" pitchFamily="34" charset="0"/>
+                <a:ea typeface="Be Vietnam Pro" pitchFamily="34" charset="-122"/>
+                <a:cs typeface="Be Vietnam Pro" pitchFamily="34" charset="-120"/>
+              </a:rPr>
+              <a:t> mã</a:t>
+            </a:r>
+            <a:r>
+              <a:rPr lang="en-US" sz="2400" dirty="0" spc="-6" kern="0">
+                <a:solidFill>
+                  <a:srgbClr val="14161C"/>
+                </a:solidFill>
+                <a:latin typeface="Be Vietnam Pro" pitchFamily="34" charset="0"/>
+                <a:ea typeface="Be Vietnam Pro" pitchFamily="34" charset="-122"/>
+                <a:cs typeface="Be Vietnam Pro" pitchFamily="34" charset="-120"/>
+              </a:rPr>
+              <a:t> máy</a:t>
             </a:r>
             <a:r>
               <a:rPr lang="en-US" sz="2400" dirty="0" spc="0" kern="0">
@@ -16432,29 +16432,7 @@
                 <a:ea typeface="Be Vietnam Pro" pitchFamily="34" charset="-122"/>
                 <a:cs typeface="Be Vietnam Pro" pitchFamily="34" charset="-120"/>
               </a:rPr>
-              <a:t> dịch</a:t>
-            </a:r>
-            <a:r>
-              <a:rPr lang="en-US" sz="2400" dirty="0" spc="-4" kern="0">
-                <a:solidFill>
-                  <a:srgbClr val="14161C"/>
-                </a:solidFill>
-                <a:latin typeface="Be Vietnam Pro" pitchFamily="34" charset="0"/>
-                <a:ea typeface="Be Vietnam Pro" pitchFamily="34" charset="-122"/>
-                <a:cs typeface="Be Vietnam Pro" pitchFamily="34" charset="-120"/>
-              </a:rPr>
-              <a:t> sang</a:t>
-            </a:r>
-            <a:r>
-              <a:rPr lang="en-US" sz="2400" dirty="0" spc="5" kern="0">
-                <a:solidFill>
-                  <a:srgbClr val="14161C"/>
-                </a:solidFill>
-                <a:latin typeface="Be Vietnam Pro" pitchFamily="34" charset="0"/>
-                <a:ea typeface="Be Vietnam Pro" pitchFamily="34" charset="-122"/>
-                <a:cs typeface="Be Vietnam Pro" pitchFamily="34" charset="-120"/>
-              </a:rPr>
-              <a:t> mã</a:t>
+              <a:t> lúc</a:t>
             </a:r>
             <a:r>
               <a:rPr lang="en-US" sz="2400" dirty="0" spc="-6" kern="0">
@@ -16465,51 +16443,7 @@
                 <a:ea typeface="Be Vietnam Pro" pitchFamily="34" charset="-122"/>
                 <a:cs typeface="Be Vietnam Pro" pitchFamily="34" charset="-120"/>
               </a:rPr>
-              <a:t> máy</a:t>
-            </a:r>
-            <a:r>
-              <a:rPr lang="en-US" sz="2400" dirty="0" spc="1" kern="0">
-                <a:solidFill>
-                  <a:srgbClr val="14161C"/>
-                </a:solidFill>
-                <a:latin typeface="Be Vietnam Pro" pitchFamily="34" charset="0"/>
-                <a:ea typeface="Be Vietnam Pro" pitchFamily="34" charset="-122"/>
-                <a:cs typeface="Be Vietnam Pro" pitchFamily="34" charset="-120"/>
-              </a:rPr>
-              <a:t> lúc</a:t>
-            </a:r>
-            <a:r>
-              <a:rPr lang="en-US" sz="2400" dirty="0" spc="-7" kern="0">
-                <a:solidFill>
-                  <a:srgbClr val="14161C"/>
-                </a:solidFill>
-                <a:latin typeface="Be Vietnam Pro" pitchFamily="34" charset="0"/>
-                <a:ea typeface="Be Vietnam Pro" pitchFamily="34" charset="-122"/>
-                <a:cs typeface="Be Vietnam Pro" pitchFamily="34" charset="-120"/>
-              </a:rPr>
-              <a:t> chạy</a:t>
-            </a:r>
-            <a:r>
-              <a:rPr lang="en-US" sz="2400" dirty="0" spc="16" kern="0">
-                <a:solidFill>
-                  <a:srgbClr val="14161C"/>
-                </a:solidFill>
-                <a:latin typeface="Be Vietnam Pro" pitchFamily="34" charset="0"/>
-                <a:ea typeface="Be Vietnam Pro" pitchFamily="34" charset="-122"/>
-                <a:cs typeface="Be Vietnam Pro" pitchFamily="34" charset="-120"/>
-              </a:rPr>
-              <a:t> để</a:t>
-            </a:r>
-            <a:r>
-              <a:rPr lang="en-US" sz="2400" dirty="0" spc="1" kern="0">
-                <a:solidFill>
-                  <a:srgbClr val="14161C"/>
-                </a:solidFill>
-                <a:latin typeface="Be Vietnam Pro" pitchFamily="34" charset="0"/>
-                <a:ea typeface="Be Vietnam Pro" pitchFamily="34" charset="-122"/>
-                <a:cs typeface="Be Vietnam Pro" pitchFamily="34" charset="-120"/>
-              </a:rPr>
-              <a:t> nhanh hơn.</a:t>
+              <a:t> chạy.</a:t>
             </a:r>
             <a:endParaRPr lang="en-US" sz="1950" dirty="0"/>
           </a:p>
@@ -16618,28 +16552,6 @@
               </a:rPr>
               <a:t>PYTHON</a:t>
             </a:r>
-            <a:r>
-              <a:rPr lang="en-US" sz="1950" b="1" spc="215" kern="0" dirty="0">
-                <a:solidFill>
-                  <a:srgbClr val="0F766E"/>
-                </a:solidFill>
-                <a:latin typeface="Be Vietnam Pro" pitchFamily="34" charset="0"/>
-                <a:ea typeface="Be Vietnam Pro" pitchFamily="34" charset="-122"/>
-                <a:cs typeface="Be Vietnam Pro" pitchFamily="34" charset="-120"/>
-              </a:rPr>
-              <a:t> TRONG</a:t>
-            </a:r>
-            <a:r>
-              <a:rPr lang="en-US" sz="1950" b="1" spc="225" kern="0" dirty="0">
-                <a:solidFill>
-                  <a:srgbClr val="0F766E"/>
-                </a:solidFill>
-                <a:latin typeface="Be Vietnam Pro" pitchFamily="34" charset="0"/>
-                <a:ea typeface="Be Vietnam Pro" pitchFamily="34" charset="-122"/>
-                <a:cs typeface="Be Vietnam Pro" pitchFamily="34" charset="-120"/>
-              </a:rPr>
-              <a:t> NGUỒN</a:t>
-            </a:r>
             <a:endParaRPr lang="en-US" sz="1950" dirty="0"/>
           </a:p>
           <a:p>
@@ -16650,6 +16562,72 @@
               <a:buNone/>
             </a:pPr>
             <a:r>
+              <a:rPr lang="en-US" sz="2400" dirty="0" spc="-9" kern="0">
+                <a:solidFill>
+                  <a:srgbClr val="14161C"/>
+                </a:solidFill>
+                <a:latin typeface="Be Vietnam Pro" pitchFamily="34" charset="0"/>
+                <a:ea typeface="Be Vietnam Pro" pitchFamily="34" charset="-122"/>
+                <a:cs typeface="Be Vietnam Pro" pitchFamily="34" charset="-120"/>
+              </a:rPr>
+              <a:t>Chạy</a:t>
+            </a:r>
+            <a:r>
+              <a:rPr lang="en-US" sz="2400" dirty="0" spc="2" kern="0">
+                <a:solidFill>
+                  <a:srgbClr val="14161C"/>
+                </a:solidFill>
+                <a:latin typeface="Be Vietnam Pro" pitchFamily="34" charset="0"/>
+                <a:ea typeface="Be Vietnam Pro" pitchFamily="34" charset="-122"/>
+                <a:cs typeface="Be Vietnam Pro" pitchFamily="34" charset="-120"/>
+              </a:rPr>
+              <a:t> thẳng</a:t>
+            </a:r>
+            <a:r>
+              <a:rPr lang="en-US" sz="2400" dirty="0" spc="4" kern="0">
+                <a:solidFill>
+                  <a:srgbClr val="14161C"/>
+                </a:solidFill>
+                <a:latin typeface="Be Vietnam Pro" pitchFamily="34" charset="0"/>
+                <a:ea typeface="Be Vietnam Pro" pitchFamily="34" charset="-122"/>
+                <a:cs typeface="Be Vietnam Pro" pitchFamily="34" charset="-120"/>
+              </a:rPr>
+              <a:t> từ mã</a:t>
+            </a:r>
+            <a:r>
+              <a:rPr lang="en-US" sz="2400" dirty="0" spc="1" kern="0">
+                <a:solidFill>
+                  <a:srgbClr val="14161C"/>
+                </a:solidFill>
+                <a:latin typeface="Be Vietnam Pro" pitchFamily="34" charset="0"/>
+                <a:ea typeface="Be Vietnam Pro" pitchFamily="34" charset="-122"/>
+                <a:cs typeface="Be Vietnam Pro" pitchFamily="34" charset="-120"/>
+              </a:rPr>
+              <a:t> nguồn qua</a:t>
+            </a:r>
+            <a:r>
+              <a:rPr lang="en-US" sz="2400" dirty="0" spc="9" kern="0">
+                <a:solidFill>
+                  <a:srgbClr val="14161C"/>
+                </a:solidFill>
+                <a:latin typeface="Be Vietnam Pro" pitchFamily="34" charset="0"/>
+                <a:ea typeface="Be Vietnam Pro" pitchFamily="34" charset="-122"/>
+                <a:cs typeface="Be Vietnam Pro" pitchFamily="34" charset="-120"/>
+              </a:rPr>
+              <a:t> trình</a:t>
+            </a:r>
+            <a:r>
+              <a:rPr lang="en-US" sz="2400" dirty="0" spc="2" kern="0">
+                <a:solidFill>
+                  <a:srgbClr val="14161C"/>
+                </a:solidFill>
+                <a:latin typeface="Be Vietnam Pro" pitchFamily="34" charset="0"/>
+                <a:ea typeface="Be Vietnam Pro" pitchFamily="34" charset="-122"/>
+                <a:cs typeface="Be Vietnam Pro" pitchFamily="34" charset="-120"/>
+              </a:rPr>
+              <a:t> thông</a:t>
+            </a:r>
+            <a:r>
               <a:rPr lang="en-US" sz="2400" dirty="0" spc="0" kern="0">
                 <a:solidFill>
                   <a:srgbClr val="14161C"/>
@@ -16658,139 +16636,7 @@
                 <a:ea typeface="Be Vietnam Pro" pitchFamily="34" charset="-122"/>
                 <a:cs typeface="Be Vietnam Pro" pitchFamily="34" charset="-120"/>
               </a:rPr>
-              <a:t>Nhóm</a:t>
-            </a:r>
-            <a:r>
-              <a:rPr lang="en-US" sz="2400" dirty="0" spc="2" kern="0">
-                <a:solidFill>
-                  <a:srgbClr val="14161C"/>
-                </a:solidFill>
-                <a:latin typeface="Be Vietnam Pro" pitchFamily="34" charset="0"/>
-                <a:ea typeface="Be Vietnam Pro" pitchFamily="34" charset="-122"/>
-                <a:cs typeface="Be Vietnam Pro" pitchFamily="34" charset="-120"/>
-              </a:rPr>
-              <a:t> thông</a:t>
-            </a:r>
-            <a:r>
-              <a:rPr lang="en-US" sz="2400" dirty="0" spc="0" kern="0">
-                <a:solidFill>
-                  <a:srgbClr val="14161C"/>
-                </a:solidFill>
-                <a:latin typeface="Be Vietnam Pro" pitchFamily="34" charset="0"/>
-                <a:ea typeface="Be Vietnam Pro" pitchFamily="34" charset="-122"/>
-                <a:cs typeface="Be Vietnam Pro" pitchFamily="34" charset="-120"/>
-              </a:rPr>
-              <a:t> dịch:</a:t>
-            </a:r>
-            <a:r>
-              <a:rPr lang="en-US" sz="2400" dirty="0" spc="1" kern="0">
-                <a:solidFill>
-                  <a:srgbClr val="14161C"/>
-                </a:solidFill>
-                <a:latin typeface="Be Vietnam Pro" pitchFamily="34" charset="0"/>
-                <a:ea typeface="Be Vietnam Pro" pitchFamily="34" charset="-122"/>
-                <a:cs typeface="Be Vietnam Pro" pitchFamily="34" charset="-120"/>
-              </a:rPr>
-              <a:t> không</a:t>
-            </a:r>
-            <a:r>
-              <a:rPr lang="en-US" sz="2400" dirty="0" spc="-1" kern="0">
-                <a:solidFill>
-                  <a:srgbClr val="14161C"/>
-                </a:solidFill>
-                <a:latin typeface="Be Vietnam Pro" pitchFamily="34" charset="0"/>
-                <a:ea typeface="Be Vietnam Pro" pitchFamily="34" charset="-122"/>
-                <a:cs typeface="Be Vietnam Pro" pitchFamily="34" charset="-120"/>
-              </a:rPr>
-              <a:t> biên</a:t>
-            </a:r>
-            <a:r>
-              <a:rPr lang="en-US" sz="2400" dirty="0" spc="0" kern="0">
-                <a:solidFill>
-                  <a:srgbClr val="14161C"/>
-                </a:solidFill>
-                <a:latin typeface="Be Vietnam Pro" pitchFamily="34" charset="0"/>
-                <a:ea typeface="Be Vietnam Pro" pitchFamily="34" charset="-122"/>
-                <a:cs typeface="Be Vietnam Pro" pitchFamily="34" charset="-120"/>
-              </a:rPr>
-              <a:t> dịch</a:t>
-            </a:r>
-            <a:r>
-              <a:rPr lang="en-US" sz="2400" dirty="0" spc="6" kern="0">
-                <a:solidFill>
-                  <a:srgbClr val="14161C"/>
-                </a:solidFill>
-                <a:latin typeface="Be Vietnam Pro" pitchFamily="34" charset="0"/>
-                <a:ea typeface="Be Vietnam Pro" pitchFamily="34" charset="-122"/>
-                <a:cs typeface="Be Vietnam Pro" pitchFamily="34" charset="-120"/>
-              </a:rPr>
-              <a:t> trước,</a:t>
-            </a:r>
-            <a:r>
-              <a:rPr lang="en-US" sz="2400" dirty="0" spc="9" kern="0">
-                <a:solidFill>
-                  <a:srgbClr val="14161C"/>
-                </a:solidFill>
-                <a:latin typeface="Be Vietnam Pro" pitchFamily="34" charset="0"/>
-                <a:ea typeface="Be Vietnam Pro" pitchFamily="34" charset="-122"/>
-                <a:cs typeface="Be Vietnam Pro" pitchFamily="34" charset="-120"/>
-              </a:rPr>
-              <a:t> trình</a:t>
-            </a:r>
-            <a:r>
-              <a:rPr lang="en-US" sz="2400" dirty="0" spc="2" kern="0">
-                <a:solidFill>
-                  <a:srgbClr val="14161C"/>
-                </a:solidFill>
-                <a:latin typeface="Be Vietnam Pro" pitchFamily="34" charset="0"/>
-                <a:ea typeface="Be Vietnam Pro" pitchFamily="34" charset="-122"/>
-                <a:cs typeface="Be Vietnam Pro" pitchFamily="34" charset="-120"/>
-              </a:rPr>
-              <a:t> thông</a:t>
-            </a:r>
-            <a:r>
-              <a:rPr lang="en-US" sz="2400" dirty="0" spc="0" kern="0">
-                <a:solidFill>
-                  <a:srgbClr val="14161C"/>
-                </a:solidFill>
-                <a:latin typeface="Be Vietnam Pro" pitchFamily="34" charset="0"/>
-                <a:ea typeface="Be Vietnam Pro" pitchFamily="34" charset="-122"/>
-                <a:cs typeface="Be Vietnam Pro" pitchFamily="34" charset="-120"/>
-              </a:rPr>
-              <a:t> dịch</a:t>
-            </a:r>
-            <a:r>
-              <a:rPr lang="en-US" sz="2400" dirty="0" spc="-7" kern="0">
-                <a:solidFill>
-                  <a:srgbClr val="14161C"/>
-                </a:solidFill>
-                <a:latin typeface="Be Vietnam Pro" pitchFamily="34" charset="0"/>
-                <a:ea typeface="Be Vietnam Pro" pitchFamily="34" charset="-122"/>
-                <a:cs typeface="Be Vietnam Pro" pitchFamily="34" charset="-120"/>
-              </a:rPr>
-              <a:t> chạy</a:t>
-            </a:r>
-            <a:r>
-              <a:rPr lang="en-US" sz="2400" dirty="0" spc="1" kern="0">
-                <a:solidFill>
-                  <a:srgbClr val="14161C"/>
-                </a:solidFill>
-                <a:latin typeface="Be Vietnam Pro" pitchFamily="34" charset="0"/>
-                <a:ea typeface="Be Vietnam Pro" pitchFamily="34" charset="-122"/>
-                <a:cs typeface="Be Vietnam Pro" pitchFamily="34" charset="-120"/>
-              </a:rPr>
-              <a:t> lúc</a:t>
-            </a:r>
-            <a:r>
-              <a:rPr lang="en-US" sz="2400" dirty="0" spc="-6" kern="0">
-                <a:solidFill>
-                  <a:srgbClr val="14161C"/>
-                </a:solidFill>
-                <a:latin typeface="Be Vietnam Pro" pitchFamily="34" charset="0"/>
-                <a:ea typeface="Be Vietnam Pro" pitchFamily="34" charset="-122"/>
-                <a:cs typeface="Be Vietnam Pro" pitchFamily="34" charset="-120"/>
-              </a:rPr>
-              <a:t> chạy.</a:t>
+              <a:t> dịch.</a:t>
             </a:r>
             <a:endParaRPr lang="en-US" sz="1950" dirty="0"/>
           </a:p>
@@ -18420,7 +18266,7 @@
               <a:buNone/>
             </a:pPr>
             <a:r>
-              <a:rPr lang="en-US" sz="2100" dirty="0" spc="1" kern="0">
+              <a:rPr lang="en-US" sz="2100" dirty="0" spc="2" kern="0">
                 <a:solidFill>
                   <a:srgbClr val="C4C8D6"/>
                 </a:solidFill>
@@ -18428,7 +18274,29 @@
                 <a:ea typeface="Be Vietnam Pro" pitchFamily="34" charset="-122"/>
                 <a:cs typeface="Be Vietnam Pro" pitchFamily="34" charset="-120"/>
               </a:rPr>
-              <a:t>Ba</a:t>
+              <a:t>Chỉ</a:t>
+            </a:r>
+            <a:r>
+              <a:rPr lang="en-US" sz="2100" dirty="0" spc="-10" kern="0">
+                <a:solidFill>
+                  <a:srgbClr val="C4C8D6"/>
+                </a:solidFill>
+                <a:latin typeface="Be Vietnam Pro" pitchFamily="34" charset="0"/>
+                <a:ea typeface="Be Vietnam Pro" pitchFamily="34" charset="-122"/>
+                <a:cs typeface="Be Vietnam Pro" pitchFamily="34" charset="-120"/>
+              </a:rPr>
+              <a:t> lấy</a:t>
+            </a:r>
+            <a:r>
+              <a:rPr lang="en-US" sz="2100" dirty="0" spc="-8" kern="0">
+                <a:solidFill>
+                  <a:srgbClr val="C4C8D6"/>
+                </a:solidFill>
+                <a:latin typeface="Be Vietnam Pro" pitchFamily="34" charset="0"/>
+                <a:ea typeface="Be Vietnam Pro" pitchFamily="34" charset="-122"/>
+                <a:cs typeface="Be Vietnam Pro" pitchFamily="34" charset="-120"/>
+              </a:rPr>
+              <a:t> ba</a:t>
             </a:r>
             <a:r>
               <a:rPr lang="en-US" sz="2100" dirty="0" spc="-2" kern="0">
@@ -18442,7 +18310,7 @@
               <a:t> nhóm</a:t>
             </a:r>
             <a:r>
-              <a:rPr lang="en-US" sz="2100" dirty="0" spc="-9" kern="0">
+              <a:rPr lang="en-US" sz="2100" dirty="0" spc="-17" kern="0">
                 <a:solidFill>
                   <a:srgbClr val="C4C8D6"/>
                 </a:solidFill>
@@ -18450,10 +18318,10 @@
                 <a:ea typeface="Be Vietnam Pro" pitchFamily="34" charset="-122"/>
                 <a:cs typeface="Be Vietnam Pro" pitchFamily="34" charset="-120"/>
               </a:rPr>
-              <a:t> ngôn</a:t>
-            </a:r>
-            <a:r>
-              <a:rPr lang="en-US" sz="2100" dirty="0" spc="1" kern="0">
+              <a:t> và</a:t>
+            </a:r>
+            <a:r>
+              <a:rPr lang="en-US" sz="2100" dirty="0" spc="-1" kern="0">
                 <a:solidFill>
                   <a:srgbClr val="C4C8D6"/>
                 </a:solidFill>
@@ -18461,40 +18329,7 @@
                 <a:ea typeface="Be Vietnam Pro" pitchFamily="34" charset="-122"/>
                 <a:cs typeface="Be Vietnam Pro" pitchFamily="34" charset="-120"/>
               </a:rPr>
-              <a:t> ngữ</a:t>
-            </a:r>
-            <a:r>
-              <a:rPr lang="en-US" sz="2100" dirty="0" spc="-18" kern="0">
-                <a:solidFill>
-                  <a:srgbClr val="C4C8D6"/>
-                </a:solidFill>
-                <a:latin typeface="Be Vietnam Pro" pitchFamily="34" charset="0"/>
-                <a:ea typeface="Be Vietnam Pro" pitchFamily="34" charset="-122"/>
-                <a:cs typeface="Be Vietnam Pro" pitchFamily="34" charset="-120"/>
-              </a:rPr>
-              <a:t> và</a:t>
-            </a:r>
-            <a:r>
-              <a:rPr lang="en-US" sz="2100" dirty="0" spc="-2" kern="0">
-                <a:solidFill>
-                  <a:srgbClr val="C4C8D6"/>
-                </a:solidFill>
-                <a:latin typeface="Be Vietnam Pro" pitchFamily="34" charset="0"/>
-                <a:ea typeface="Be Vietnam Pro" pitchFamily="34" charset="-122"/>
-                <a:cs typeface="Be Vietnam Pro" pitchFamily="34" charset="-120"/>
-              </a:rPr>
-              <a:t> cách</a:t>
-            </a:r>
-            <a:r>
-              <a:rPr lang="en-US" sz="2100" dirty="0" spc="-7" kern="0">
-                <a:solidFill>
-                  <a:srgbClr val="C4C8D6"/>
-                </a:solidFill>
-                <a:latin typeface="Be Vietnam Pro" pitchFamily="34" charset="0"/>
-                <a:ea typeface="Be Vietnam Pro" pitchFamily="34" charset="-122"/>
-                <a:cs typeface="Be Vietnam Pro" pitchFamily="34" charset="-120"/>
-              </a:rPr>
-              <a:t> chạy.</a:t>
+              <a:t> ví dụ.</a:t>
             </a:r>
             <a:endParaRPr lang="en-US" sz="2100" dirty="0"/>
           </a:p>
@@ -18666,7 +18501,7 @@
               <a:t> (tệp</a:t>
             </a:r>
             <a:r>
-              <a:rPr lang="en-US" sz="2100" dirty="0" spc="-27" kern="0">
+              <a:rPr lang="en-US" sz="2100" dirty="0" spc="-23" kern="0">
                 <a:solidFill>
                   <a:srgbClr val="C4C8D6"/>
                 </a:solidFill>
@@ -18674,10 +18509,10 @@
                 <a:ea typeface="Be Vietnam Pro" pitchFamily="34" charset="-122"/>
                 <a:cs typeface="Be Vietnam Pro" pitchFamily="34" charset="-120"/>
               </a:rPr>
-              <a:t> .pyc)</a:t>
-            </a:r>
-            <a:r>
-              <a:rPr lang="en-US" sz="2100" dirty="0" spc="-17" kern="0">
+              <a:t> .pyc),</a:t>
+            </a:r>
+            <a:r>
+              <a:rPr lang="en-US" sz="2100" dirty="0" spc="-21" kern="0">
                 <a:solidFill>
                   <a:srgbClr val="C4C8D6"/>
                 </a:solidFill>
@@ -18685,7 +18520,18 @@
                 <a:ea typeface="Be Vietnam Pro" pitchFamily="34" charset="-122"/>
                 <a:cs typeface="Be Vietnam Pro" pitchFamily="34" charset="-120"/>
               </a:rPr>
-              <a:t> và</a:t>
+              <a:t> interpreted,</a:t>
+            </a:r>
+            <a:r>
+              <a:rPr lang="en-US" sz="2100" dirty="0" spc="-1" kern="0">
+                <a:solidFill>
+                  <a:srgbClr val="C4C8D6"/>
+                </a:solidFill>
+                <a:latin typeface="Be Vietnam Pro" pitchFamily="34" charset="0"/>
+                <a:ea typeface="Be Vietnam Pro" pitchFamily="34" charset="-122"/>
+                <a:cs typeface="Be Vietnam Pro" pitchFamily="34" charset="-120"/>
+              </a:rPr>
+              <a:t> virtual</a:t>
             </a:r>
             <a:r>
               <a:rPr lang="en-US" sz="2100" dirty="0" spc="0" kern="0">
@@ -18696,18 +18542,7 @@
                 <a:ea typeface="Be Vietnam Pro" pitchFamily="34" charset="-122"/>
                 <a:cs typeface="Be Vietnam Pro" pitchFamily="34" charset="-120"/>
               </a:rPr>
-              <a:t> mục</a:t>
-            </a:r>
-            <a:r>
-              <a:rPr lang="en-US" sz="2100" dirty="0" spc="-21" kern="0">
-                <a:solidFill>
-                  <a:srgbClr val="C4C8D6"/>
-                </a:solidFill>
-                <a:latin typeface="Be Vietnam Pro" pitchFamily="34" charset="0"/>
-                <a:ea typeface="Be Vietnam Pro" pitchFamily="34" charset="-122"/>
-                <a:cs typeface="Be Vietnam Pro" pitchFamily="34" charset="-120"/>
-              </a:rPr>
-              <a:t> interpreted.</a:t>
+              <a:t> machine.</a:t>
             </a:r>
             <a:endParaRPr lang="en-US" sz="2100" dirty="0"/>
           </a:p>
@@ -18769,6 +18604,28 @@
                 <a:cs typeface="Be Vietnam Pro" pitchFamily="34" charset="-120"/>
               </a:rPr>
               <a:t>MDN</a:t>
+            </a:r>
+            <a:r>
+              <a:rPr lang="en-US" sz="2250" b="1" dirty="0" spc="2" kern="0">
+                <a:solidFill>
+                  <a:srgbClr val="F3EEE3"/>
+                </a:solidFill>
+                <a:latin typeface="Be Vietnam Pro" pitchFamily="34" charset="0"/>
+                <a:ea typeface="Be Vietnam Pro" pitchFamily="34" charset="-122"/>
+                <a:cs typeface="Be Vietnam Pro" pitchFamily="34" charset="-120"/>
+              </a:rPr>
+              <a:t> ·</a:t>
+            </a:r>
+            <a:r>
+              <a:rPr lang="en-US" sz="2250" b="1" dirty="0" spc="0" kern="0">
+                <a:solidFill>
+                  <a:srgbClr val="F3EEE3"/>
+                </a:solidFill>
+                <a:latin typeface="Be Vietnam Pro" pitchFamily="34" charset="0"/>
+                <a:ea typeface="Be Vietnam Pro" pitchFamily="34" charset="-122"/>
+                <a:cs typeface="Be Vietnam Pro" pitchFamily="34" charset="-120"/>
+              </a:rPr>
+              <a:t> OpenJDK</a:t>
             </a:r>
             <a:endParaRPr lang="en-US" sz="2250" dirty="0"/>
           </a:p>
@@ -18802,7 +18659,7 @@
               <a:buNone/>
             </a:pPr>
             <a:r>
-              <a:rPr lang="en-US" sz="2100" dirty="0" spc="1" kern="0">
+              <a:rPr lang="en-US" sz="2100" dirty="0" spc="-1" kern="0">
                 <a:solidFill>
                   <a:srgbClr val="C4C8D6"/>
                 </a:solidFill>
@@ -18810,10 +18667,10 @@
                 <a:ea typeface="Be Vietnam Pro" pitchFamily="34" charset="-122"/>
                 <a:cs typeface="Be Vietnam Pro" pitchFamily="34" charset="-120"/>
               </a:rPr>
-              <a:t>Mozilla</a:t>
-            </a:r>
-            <a:r>
-              <a:rPr lang="en-US" sz="2100" dirty="0" spc="-13" kern="0">
+              <a:t>Compile,</a:t>
+            </a:r>
+            <a:r>
+              <a:rPr lang="en-US" sz="2100" dirty="0" spc="0" kern="0">
                 <a:solidFill>
                   <a:srgbClr val="C4C8D6"/>
                 </a:solidFill>
@@ -18821,10 +18678,10 @@
                 <a:ea typeface="Be Vietnam Pro" pitchFamily="34" charset="-122"/>
                 <a:cs typeface="Be Vietnam Pro" pitchFamily="34" charset="-120"/>
               </a:rPr>
-              <a:t> Developer</a:t>
-            </a:r>
-            <a:r>
-              <a:rPr lang="en-US" sz="2100" dirty="0" spc="-8" kern="0">
+              <a:t> JIT;</a:t>
+            </a:r>
+            <a:r>
+              <a:rPr lang="en-US" sz="2100" dirty="0" spc="-11" kern="0">
                 <a:solidFill>
                   <a:srgbClr val="C4C8D6"/>
                 </a:solidFill>
@@ -18832,10 +18689,10 @@
                 <a:ea typeface="Be Vietnam Pro" pitchFamily="34" charset="-122"/>
                 <a:cs typeface="Be Vietnam Pro" pitchFamily="34" charset="-120"/>
               </a:rPr>
-              <a:t> Network,</a:t>
-            </a:r>
-            <a:r>
-              <a:rPr lang="en-US" sz="2100" dirty="0" spc="1" kern="0">
+              <a:t> tài</a:t>
+            </a:r>
+            <a:r>
+              <a:rPr lang="en-US" sz="2100" dirty="0" spc="0" kern="0">
                 <a:solidFill>
                   <a:srgbClr val="C4C8D6"/>
                 </a:solidFill>
@@ -18843,10 +18700,10 @@
                 <a:ea typeface="Be Vietnam Pro" pitchFamily="34" charset="-122"/>
                 <a:cs typeface="Be Vietnam Pro" pitchFamily="34" charset="-120"/>
               </a:rPr>
-              <a:t> mục</a:t>
-            </a:r>
-            <a:r>
-              <a:rPr lang="en-US" sz="2100" dirty="0" spc="-1" kern="0">
+              <a:t> liệu lệnh</a:t>
+            </a:r>
+            <a:r>
+              <a:rPr lang="en-US" sz="2100" dirty="0" spc="-22" kern="0">
                 <a:solidFill>
                   <a:srgbClr val="C4C8D6"/>
                 </a:solidFill>
@@ -18854,18 +18711,7 @@
                 <a:ea typeface="Be Vietnam Pro" pitchFamily="34" charset="-122"/>
                 <a:cs typeface="Be Vietnam Pro" pitchFamily="34" charset="-120"/>
               </a:rPr>
-              <a:t> Just-In-Time</a:t>
-            </a:r>
-            <a:r>
-              <a:rPr lang="en-US" sz="2100" dirty="0" spc="-3" kern="0">
-                <a:solidFill>
-                  <a:srgbClr val="C4C8D6"/>
-                </a:solidFill>
-                <a:latin typeface="Be Vietnam Pro" pitchFamily="34" charset="0"/>
-                <a:ea typeface="Be Vietnam Pro" pitchFamily="34" charset="-122"/>
-                <a:cs typeface="Be Vietnam Pro" pitchFamily="34" charset="-120"/>
-              </a:rPr>
-              <a:t> Compilation.</a:t>
+              <a:t> java.</a:t>
             </a:r>
             <a:endParaRPr lang="en-US" sz="2100" dirty="0"/>
           </a:p>
@@ -18940,7 +18786,7 @@
               <a:t> ngày</a:t>
             </a:r>
             <a:r>
-              <a:rPr lang="en-US" sz="2100" dirty="0" spc="-1" kern="0">
+              <a:rPr lang="en-US" sz="2100" dirty="0" spc="0" kern="0">
                 <a:solidFill>
                   <a:srgbClr val="F3EEE3"/>
                 </a:solidFill>
@@ -18948,10 +18794,10 @@
                 <a:ea typeface="Be Vietnam Pro" pitchFamily="34" charset="-122"/>
                 <a:cs typeface="Be Vietnam Pro" pitchFamily="34" charset="-120"/>
               </a:rPr>
-              <a:t> 2026-10-18.</a:t>
-            </a:r>
-            <a:r>
-              <a:rPr lang="en-US" sz="2100" dirty="0" spc="0" kern="0">
+              <a:t> 2026-10-19. Hình minh</a:t>
+            </a:r>
+            <a:r>
+              <a:rPr lang="en-US" sz="2100" dirty="0" spc="-5" kern="0">
                 <a:solidFill>
                   <a:srgbClr val="F3EEE3"/>
                 </a:solidFill>
@@ -18959,10 +18805,10 @@
                 <a:ea typeface="Be Vietnam Pro" pitchFamily="34" charset="-122"/>
                 <a:cs typeface="Be Vietnam Pro" pitchFamily="34" charset="-120"/>
               </a:rPr>
-              <a:t> Hình</a:t>
-            </a:r>
-            <a:r>
-              <a:rPr lang="en-US" sz="2100" dirty="0" spc="1" kern="0">
+              <a:t> họa</a:t>
+            </a:r>
+            <a:r>
+              <a:rPr lang="en-US" sz="2100" dirty="0" spc="-4" kern="0">
                 <a:solidFill>
                   <a:srgbClr val="F3EEE3"/>
                 </a:solidFill>
@@ -18970,10 +18816,10 @@
                 <a:ea typeface="Be Vietnam Pro" pitchFamily="34" charset="-122"/>
                 <a:cs typeface="Be Vietnam Pro" pitchFamily="34" charset="-120"/>
               </a:rPr>
-              <a:t> minh</a:t>
-            </a:r>
-            <a:r>
-              <a:rPr lang="en-US" sz="2100" dirty="0" spc="-6" kern="0">
+              <a:t> là</a:t>
+            </a:r>
+            <a:r>
+              <a:rPr lang="en-US" sz="2100" dirty="0" spc="-3" kern="0">
                 <a:solidFill>
                   <a:srgbClr val="F3EEE3"/>
                 </a:solidFill>
@@ -18981,32 +18827,10 @@
                 <a:ea typeface="Be Vietnam Pro" pitchFamily="34" charset="-122"/>
                 <a:cs typeface="Be Vietnam Pro" pitchFamily="34" charset="-120"/>
               </a:rPr>
-              <a:t> họa</a:t>
-            </a:r>
-            <a:r>
-              <a:rPr lang="en-US" sz="2100" dirty="0" spc="-3" kern="0">
-                <a:solidFill>
-                  <a:srgbClr val="F3EEE3"/>
-                </a:solidFill>
-                <a:latin typeface="Be Vietnam Pro" pitchFamily="34" charset="0"/>
-                <a:ea typeface="Be Vietnam Pro" pitchFamily="34" charset="-122"/>
-                <a:cs typeface="Be Vietnam Pro" pitchFamily="34" charset="-120"/>
-              </a:rPr>
-              <a:t> là</a:t>
-            </a:r>
-            <a:r>
-              <a:rPr lang="en-US" sz="2100" dirty="0" spc="-4" kern="0">
-                <a:solidFill>
-                  <a:srgbClr val="F3EEE3"/>
-                </a:solidFill>
-                <a:latin typeface="Be Vietnam Pro" pitchFamily="34" charset="0"/>
-                <a:ea typeface="Be Vietnam Pro" pitchFamily="34" charset="-122"/>
-                <a:cs typeface="Be Vietnam Pro" pitchFamily="34" charset="-120"/>
-              </a:rPr>
               <a:t> thiết</a:t>
             </a:r>
             <a:r>
-              <a:rPr lang="en-US" sz="2100" dirty="0" spc="-30" kern="0">
+              <a:rPr lang="en-US" sz="2100" dirty="0" spc="-31" kern="0">
                 <a:solidFill>
                   <a:srgbClr val="F3EEE3"/>
                 </a:solidFill>
@@ -19064,7 +18888,18 @@
                 <a:ea typeface="Be Vietnam Pro" pitchFamily="34" charset="-122"/>
                 <a:cs typeface="Be Vietnam Pro" pitchFamily="34" charset="-120"/>
               </a:rPr>
-              <a:t>Giải nghĩa CPU</a:t>
+              <a:t>Giải nghĩa CPU,</a:t>
+            </a:r>
+            <a:r>
+              <a:rPr lang="en-US" sz="1800" dirty="0" spc="7" kern="0">
+                <a:solidFill>
+                  <a:srgbClr val="9AA0B5"/>
+                </a:solidFill>
+                <a:latin typeface="Be Vietnam Pro" pitchFamily="34" charset="0"/>
+                <a:ea typeface="Be Vietnam Pro" pitchFamily="34" charset="-122"/>
+                <a:cs typeface="Be Vietnam Pro" pitchFamily="34" charset="-120"/>
+              </a:rPr>
+              <a:t> JVM</a:t>
             </a:r>
             <a:r>
               <a:rPr lang="en-US" sz="1800" dirty="0" spc="-11" kern="0">
@@ -19078,7 +18913,7 @@
               <a:t> và</a:t>
             </a:r>
             <a:r>
-              <a:rPr lang="en-US" sz="1800" dirty="0" spc="8" kern="0">
+              <a:rPr lang="en-US" sz="1800" dirty="0" spc="-51" kern="0">
                 <a:solidFill>
                   <a:srgbClr val="9AA0B5"/>
                 </a:solidFill>
@@ -19086,7 +18921,73 @@
                 <a:ea typeface="Be Vietnam Pro" pitchFamily="34" charset="-122"/>
                 <a:cs typeface="Be Vietnam Pro" pitchFamily="34" charset="-120"/>
               </a:rPr>
-              <a:t> JVM</a:t>
+              <a:t> AOT</a:t>
+            </a:r>
+            <a:r>
+              <a:rPr lang="en-US" sz="1800" dirty="0" spc="0" kern="0">
+                <a:solidFill>
+                  <a:srgbClr val="9AA0B5"/>
+                </a:solidFill>
+                <a:latin typeface="Be Vietnam Pro" pitchFamily="34" charset="0"/>
+                <a:ea typeface="Be Vietnam Pro" pitchFamily="34" charset="-122"/>
+                <a:cs typeface="Be Vietnam Pro" pitchFamily="34" charset="-120"/>
+              </a:rPr>
+              <a:t> là</a:t>
+            </a:r>
+            <a:r>
+              <a:rPr lang="en-US" sz="1800" dirty="0" spc="-2" kern="0">
+                <a:solidFill>
+                  <a:srgbClr val="9AA0B5"/>
+                </a:solidFill>
+                <a:latin typeface="Be Vietnam Pro" pitchFamily="34" charset="0"/>
+                <a:ea typeface="Be Vietnam Pro" pitchFamily="34" charset="-122"/>
+                <a:cs typeface="Be Vietnam Pro" pitchFamily="34" charset="-120"/>
+              </a:rPr>
+              <a:t> kiến</a:t>
+            </a:r>
+            <a:r>
+              <a:rPr lang="en-US" sz="1800" dirty="0" spc="6" kern="0">
+                <a:solidFill>
+                  <a:srgbClr val="9AA0B5"/>
+                </a:solidFill>
+                <a:latin typeface="Be Vietnam Pro" pitchFamily="34" charset="0"/>
+                <a:ea typeface="Be Vietnam Pro" pitchFamily="34" charset="-122"/>
+                <a:cs typeface="Be Vietnam Pro" pitchFamily="34" charset="-120"/>
+              </a:rPr>
+              <a:t> thức</a:t>
+            </a:r>
+            <a:r>
+              <a:rPr lang="en-US" sz="1800" dirty="0" spc="-3" kern="0">
+                <a:solidFill>
+                  <a:srgbClr val="9AA0B5"/>
+                </a:solidFill>
+                <a:latin typeface="Be Vietnam Pro" pitchFamily="34" charset="0"/>
+                <a:ea typeface="Be Vietnam Pro" pitchFamily="34" charset="-122"/>
+                <a:cs typeface="Be Vietnam Pro" pitchFamily="34" charset="-120"/>
+              </a:rPr>
+              <a:t> chung</a:t>
+            </a:r>
+            <a:r>
+              <a:rPr lang="en-US" sz="1800" dirty="0" spc="4" kern="0">
+                <a:solidFill>
+                  <a:srgbClr val="9AA0B5"/>
+                </a:solidFill>
+                <a:latin typeface="Be Vietnam Pro" pitchFamily="34" charset="0"/>
+                <a:ea typeface="Be Vietnam Pro" pitchFamily="34" charset="-122"/>
+                <a:cs typeface="Be Vietnam Pro" pitchFamily="34" charset="-120"/>
+              </a:rPr>
+              <a:t> của</a:t>
+            </a:r>
+            <a:r>
+              <a:rPr lang="en-US" sz="1800" dirty="0" spc="2" kern="0">
+                <a:solidFill>
+                  <a:srgbClr val="9AA0B5"/>
+                </a:solidFill>
+                <a:latin typeface="Be Vietnam Pro" pitchFamily="34" charset="0"/>
+                <a:ea typeface="Be Vietnam Pro" pitchFamily="34" charset="-122"/>
+                <a:cs typeface="Be Vietnam Pro" pitchFamily="34" charset="-120"/>
+              </a:rPr>
+              <a:t> người</a:t>
             </a:r>
             <a:r>
               <a:rPr lang="en-US" sz="1800" dirty="0" spc="-1" kern="0">
@@ -19097,10 +18998,10 @@
                 <a:ea typeface="Be Vietnam Pro" pitchFamily="34" charset="-122"/>
                 <a:cs typeface="Be Vietnam Pro" pitchFamily="34" charset="-120"/>
               </a:rPr>
-              <a:t> là</a:t>
-            </a:r>
-            <a:r>
-              <a:rPr lang="en-US" sz="1800" dirty="0" spc="-2" kern="0">
+              <a:t> biên</a:t>
+            </a:r>
+            <a:r>
+              <a:rPr lang="en-US" sz="1800" dirty="0" spc="-5" kern="0">
                 <a:solidFill>
                   <a:srgbClr val="9AA0B5"/>
                 </a:solidFill>
@@ -19108,10 +19009,10 @@
                 <a:ea typeface="Be Vietnam Pro" pitchFamily="34" charset="-122"/>
                 <a:cs typeface="Be Vietnam Pro" pitchFamily="34" charset="-120"/>
               </a:rPr>
-              <a:t> kiến</a:t>
-            </a:r>
-            <a:r>
-              <a:rPr lang="en-US" sz="1800" dirty="0" spc="6" kern="0">
+              <a:t> soạn,</a:t>
+            </a:r>
+            <a:r>
+              <a:rPr lang="en-US" sz="1800" dirty="0" spc="7" kern="0">
                 <a:solidFill>
                   <a:srgbClr val="9AA0B5"/>
                 </a:solidFill>
@@ -19119,10 +19020,10 @@
                 <a:ea typeface="Be Vietnam Pro" pitchFamily="34" charset="-122"/>
                 <a:cs typeface="Be Vietnam Pro" pitchFamily="34" charset="-120"/>
               </a:rPr>
-              <a:t> thức</a:t>
-            </a:r>
-            <a:r>
-              <a:rPr lang="en-US" sz="1800" dirty="0" spc="-2" kern="0">
+              <a:t> chưa</a:t>
+            </a:r>
+            <a:r>
+              <a:rPr lang="en-US" sz="1800" dirty="0" spc="10" kern="0">
                 <a:solidFill>
                   <a:srgbClr val="9AA0B5"/>
                 </a:solidFill>
@@ -19130,10 +19031,10 @@
                 <a:ea typeface="Be Vietnam Pro" pitchFamily="34" charset="-122"/>
                 <a:cs typeface="Be Vietnam Pro" pitchFamily="34" charset="-120"/>
               </a:rPr>
-              <a:t> chung</a:t>
-            </a:r>
-            <a:r>
-              <a:rPr lang="en-US" sz="1800" dirty="0" spc="2" kern="0">
+              <a:t> đối</a:t>
+            </a:r>
+            <a:r>
+              <a:rPr lang="en-US" sz="1800" dirty="0" spc="-1" kern="0">
                 <a:solidFill>
                   <a:srgbClr val="9AA0B5"/>
                 </a:solidFill>
@@ -19141,10 +19042,10 @@
                 <a:ea typeface="Be Vietnam Pro" pitchFamily="34" charset="-122"/>
                 <a:cs typeface="Be Vietnam Pro" pitchFamily="34" charset="-120"/>
               </a:rPr>
-              <a:t> của</a:t>
-            </a:r>
-            <a:r>
-              <a:rPr lang="en-US" sz="1800" dirty="0" spc="3" kern="0">
+              <a:t> chiếu</a:t>
+            </a:r>
+            <a:r>
+              <a:rPr lang="en-US" sz="1800" dirty="0" spc="-9" kern="0">
                 <a:solidFill>
                   <a:srgbClr val="9AA0B5"/>
                 </a:solidFill>
@@ -19152,10 +19053,10 @@
                 <a:ea typeface="Be Vietnam Pro" pitchFamily="34" charset="-122"/>
                 <a:cs typeface="Be Vietnam Pro" pitchFamily="34" charset="-120"/>
               </a:rPr>
-              <a:t> người</a:t>
-            </a:r>
-            <a:r>
-              <a:rPr lang="en-US" sz="1800" dirty="0" spc="-2" kern="0">
+              <a:t> tài</a:t>
+            </a:r>
+            <a:r>
+              <a:rPr lang="en-US" sz="1800" dirty="0" spc="-3" kern="0">
                 <a:solidFill>
                   <a:srgbClr val="9AA0B5"/>
                 </a:solidFill>
@@ -19163,76 +19064,10 @@
                 <a:ea typeface="Be Vietnam Pro" pitchFamily="34" charset="-122"/>
                 <a:cs typeface="Be Vietnam Pro" pitchFamily="34" charset="-120"/>
               </a:rPr>
-              <a:t> biên</a:t>
-            </a:r>
-            <a:r>
-              <a:rPr lang="en-US" sz="1800" dirty="0" spc="-5" kern="0">
-                <a:solidFill>
-                  <a:srgbClr val="9AA0B5"/>
-                </a:solidFill>
-                <a:latin typeface="Be Vietnam Pro" pitchFamily="34" charset="0"/>
-                <a:ea typeface="Be Vietnam Pro" pitchFamily="34" charset="-122"/>
-                <a:cs typeface="Be Vietnam Pro" pitchFamily="34" charset="-120"/>
-              </a:rPr>
-              <a:t> soạn,</a:t>
-            </a:r>
-            <a:r>
-              <a:rPr lang="en-US" sz="1800" dirty="0" spc="7" kern="0">
-                <a:solidFill>
-                  <a:srgbClr val="9AA0B5"/>
-                </a:solidFill>
-                <a:latin typeface="Be Vietnam Pro" pitchFamily="34" charset="0"/>
-                <a:ea typeface="Be Vietnam Pro" pitchFamily="34" charset="-122"/>
-                <a:cs typeface="Be Vietnam Pro" pitchFamily="34" charset="-120"/>
-              </a:rPr>
-              <a:t> chưa</a:t>
-            </a:r>
-            <a:r>
-              <a:rPr lang="en-US" sz="1800" dirty="0" spc="11" kern="0">
-                <a:solidFill>
-                  <a:srgbClr val="9AA0B5"/>
-                </a:solidFill>
-                <a:latin typeface="Be Vietnam Pro" pitchFamily="34" charset="0"/>
-                <a:ea typeface="Be Vietnam Pro" pitchFamily="34" charset="-122"/>
-                <a:cs typeface="Be Vietnam Pro" pitchFamily="34" charset="-120"/>
-              </a:rPr>
-              <a:t> đối</a:t>
-            </a:r>
-            <a:r>
-              <a:rPr lang="en-US" sz="1800" dirty="0" spc="-1" kern="0">
-                <a:solidFill>
-                  <a:srgbClr val="9AA0B5"/>
-                </a:solidFill>
-                <a:latin typeface="Be Vietnam Pro" pitchFamily="34" charset="0"/>
-                <a:ea typeface="Be Vietnam Pro" pitchFamily="34" charset="-122"/>
-                <a:cs typeface="Be Vietnam Pro" pitchFamily="34" charset="-120"/>
-              </a:rPr>
-              <a:t> chiếu</a:t>
-            </a:r>
-            <a:r>
-              <a:rPr lang="en-US" sz="1800" dirty="0" spc="-10" kern="0">
-                <a:solidFill>
-                  <a:srgbClr val="9AA0B5"/>
-                </a:solidFill>
-                <a:latin typeface="Be Vietnam Pro" pitchFamily="34" charset="0"/>
-                <a:ea typeface="Be Vietnam Pro" pitchFamily="34" charset="-122"/>
-                <a:cs typeface="Be Vietnam Pro" pitchFamily="34" charset="-120"/>
-              </a:rPr>
-              <a:t> tài</a:t>
-            </a:r>
-            <a:r>
-              <a:rPr lang="en-US" sz="1800" dirty="0" spc="-2" kern="0">
-                <a:solidFill>
-                  <a:srgbClr val="9AA0B5"/>
-                </a:solidFill>
-                <a:latin typeface="Be Vietnam Pro" pitchFamily="34" charset="0"/>
-                <a:ea typeface="Be Vietnam Pro" pitchFamily="34" charset="-122"/>
-                <a:cs typeface="Be Vietnam Pro" pitchFamily="34" charset="-120"/>
-              </a:rPr>
               <a:t> liệu</a:t>
             </a:r>
             <a:r>
-              <a:rPr lang="en-US" sz="1800" dirty="0" spc="-1" kern="0">
+              <a:rPr lang="en-US" sz="1800" dirty="0" spc="0" kern="0">
                 <a:solidFill>
                   <a:srgbClr val="9AA0B5"/>
                 </a:solidFill>

</xml_diff>

<commit_message>
Lessons sd-10-014, 015, 016: qualify HTTP as text-based only for HTTP/1.x, say when CPython writes a .pyc file, and describe a heap by priority instead of the minimum
Co-Authored-By: Claude Sonnet 5.5 <noreply@anthropic.com>
Claude-Session: https://claude.ai/code/session_011dmt3ZFdN8sjiTfDnyUVN7
</commit_message>
<xml_diff>
--- a/system-design-101/vi/lessons/sd-10-015/slides/sd-10-015.pptx
+++ b/system-design-101/vi/lessons/sd-10-015/slides/sd-10-015.pptx
@@ -12128,6 +12128,28 @@
               <a:t>Bytecode</a:t>
             </a:r>
             <a:r>
+              <a:rPr lang="en-US" sz="2250" dirty="0" spc="4" kern="0">
+                <a:solidFill>
+                  <a:srgbClr val="14161C"/>
+                </a:solidFill>
+                <a:latin typeface="Be Vietnam Pro" pitchFamily="34" charset="0"/>
+                <a:ea typeface="Be Vietnam Pro" pitchFamily="34" charset="-122"/>
+                <a:cs typeface="Be Vietnam Pro" pitchFamily="34" charset="-120"/>
+              </a:rPr>
+              <a:t> có</a:t>
+            </a:r>
+            <a:r>
+              <a:rPr lang="en-US" sz="2250" dirty="0" spc="0" kern="0">
+                <a:solidFill>
+                  <a:srgbClr val="14161C"/>
+                </a:solidFill>
+                <a:latin typeface="Be Vietnam Pro" pitchFamily="34" charset="0"/>
+                <a:ea typeface="Be Vietnam Pro" pitchFamily="34" charset="-122"/>
+                <a:cs typeface="Be Vietnam Pro" pitchFamily="34" charset="-120"/>
+              </a:rPr>
+              <a:t> thể</a:t>
+            </a:r>
+            <a:r>
               <a:rPr lang="en-US" sz="2250" dirty="0" spc="16" kern="0">
                 <a:solidFill>
                   <a:srgbClr val="14161C"/>
@@ -12150,59 +12172,48 @@
               <a:t> tạm</a:t>
             </a:r>
             <a:r>
-              <a:rPr lang="en-US" sz="2250" dirty="0" spc="15" kern="0">
-                <a:solidFill>
-                  <a:srgbClr val="14161C"/>
-                </a:solidFill>
-                <a:latin typeface="Be Vietnam Pro" pitchFamily="34" charset="0"/>
-                <a:ea typeface="Be Vietnam Pro" pitchFamily="34" charset="-122"/>
-                <a:cs typeface="Be Vietnam Pro" pitchFamily="34" charset="-120"/>
-              </a:rPr>
-              <a:t> để</a:t>
-            </a:r>
-            <a:r>
-              <a:rPr lang="en-US" sz="2250" dirty="0" spc="0" kern="0">
-                <a:solidFill>
-                  <a:srgbClr val="14161C"/>
-                </a:solidFill>
-                <a:latin typeface="Be Vietnam Pro" pitchFamily="34" charset="0"/>
-                <a:ea typeface="Be Vietnam Pro" pitchFamily="34" charset="-122"/>
-                <a:cs typeface="Be Vietnam Pro" pitchFamily="34" charset="-120"/>
-              </a:rPr>
-              <a:t> lần</a:t>
-            </a:r>
-            <a:r>
-              <a:rPr lang="en-US" sz="2250" dirty="0" spc="-6" kern="0">
-                <a:solidFill>
-                  <a:srgbClr val="14161C"/>
-                </a:solidFill>
-                <a:latin typeface="Be Vietnam Pro" pitchFamily="34" charset="0"/>
-                <a:ea typeface="Be Vietnam Pro" pitchFamily="34" charset="-122"/>
-                <a:cs typeface="Be Vietnam Pro" pitchFamily="34" charset="-120"/>
-              </a:rPr>
-              <a:t> chạy</a:t>
-            </a:r>
-            <a:r>
-              <a:rPr lang="en-US" sz="2250" dirty="0" spc="-5" kern="0">
-                <a:solidFill>
-                  <a:srgbClr val="14161C"/>
-                </a:solidFill>
-                <a:latin typeface="Be Vietnam Pro" pitchFamily="34" charset="0"/>
-                <a:ea typeface="Be Vietnam Pro" pitchFamily="34" charset="-122"/>
-                <a:cs typeface="Be Vietnam Pro" pitchFamily="34" charset="-120"/>
-              </a:rPr>
-              <a:t> sau</a:t>
-            </a:r>
-            <a:r>
-              <a:rPr lang="en-US" sz="2250" dirty="0" spc="0" kern="0">
-                <a:solidFill>
-                  <a:srgbClr val="14161C"/>
-                </a:solidFill>
-                <a:latin typeface="Be Vietnam Pro" pitchFamily="34" charset="0"/>
-                <a:ea typeface="Be Vietnam Pro" pitchFamily="34" charset="-122"/>
-                <a:cs typeface="Be Vietnam Pro" pitchFamily="34" charset="-120"/>
-              </a:rPr>
-              <a:t> nhanh hơn</a:t>
+              <a:rPr lang="en-US" sz="2250" dirty="0" spc="1" kern="0">
+                <a:solidFill>
+                  <a:srgbClr val="14161C"/>
+                </a:solidFill>
+                <a:latin typeface="Be Vietnam Pro" pitchFamily="34" charset="0"/>
+                <a:ea typeface="Be Vietnam Pro" pitchFamily="34" charset="-122"/>
+                <a:cs typeface="Be Vietnam Pro" pitchFamily="34" charset="-120"/>
+              </a:rPr>
+              <a:t> cho</a:t>
+            </a:r>
+            <a:r>
+              <a:rPr lang="en-US" sz="2250" dirty="0" spc="-2" kern="0">
+                <a:solidFill>
+                  <a:srgbClr val="14161C"/>
+                </a:solidFill>
+                <a:latin typeface="Be Vietnam Pro" pitchFamily="34" charset="0"/>
+                <a:ea typeface="Be Vietnam Pro" pitchFamily="34" charset="-122"/>
+                <a:cs typeface="Be Vietnam Pro" pitchFamily="34" charset="-120"/>
+              </a:rPr>
+              <a:t> module</a:t>
+            </a:r>
+            <a:r>
+              <a:rPr lang="en-US" sz="2250" dirty="0" spc="9" kern="0">
+                <a:solidFill>
+                  <a:srgbClr val="14161C"/>
+                </a:solidFill>
+                <a:latin typeface="Be Vietnam Pro" pitchFamily="34" charset="0"/>
+                <a:ea typeface="Be Vietnam Pro" pitchFamily="34" charset="-122"/>
+                <a:cs typeface="Be Vietnam Pro" pitchFamily="34" charset="-120"/>
+              </a:rPr>
+              <a:t> được</a:t>
+            </a:r>
+            <a:r>
+              <a:rPr lang="en-US" sz="2250" dirty="0" spc="1" kern="0">
+                <a:solidFill>
+                  <a:srgbClr val="14161C"/>
+                </a:solidFill>
+                <a:latin typeface="Be Vietnam Pro" pitchFamily="34" charset="0"/>
+                <a:ea typeface="Be Vietnam Pro" pitchFamily="34" charset="-122"/>
+                <a:cs typeface="Be Vietnam Pro" pitchFamily="34" charset="-120"/>
+              </a:rPr>
+              <a:t> nạp</a:t>
             </a:r>
             <a:endParaRPr lang="en-US" sz="2250" dirty="0"/>
           </a:p>
@@ -16848,15 +16859,59 @@
               <a:t> bytecode</a:t>
             </a:r>
             <a:r>
-              <a:rPr lang="en-US" sz="2400" dirty="0" spc="-8" kern="0">
-                <a:solidFill>
-                  <a:srgbClr val="14161C"/>
-                </a:solidFill>
-                <a:latin typeface="Be Vietnam Pro" pitchFamily="34" charset="0"/>
-                <a:ea typeface="Be Vietnam Pro" pitchFamily="34" charset="-122"/>
-                <a:cs typeface="Be Vietnam Pro" pitchFamily="34" charset="-120"/>
-              </a:rPr>
-              <a:t> (tệp</a:t>
+              <a:rPr lang="en-US" sz="2400" dirty="0" spc="1" kern="0">
+                <a:solidFill>
+                  <a:srgbClr val="14161C"/>
+                </a:solidFill>
+                <a:latin typeface="Be Vietnam Pro" pitchFamily="34" charset="0"/>
+                <a:ea typeface="Be Vietnam Pro" pitchFamily="34" charset="-122"/>
+                <a:cs typeface="Be Vietnam Pro" pitchFamily="34" charset="-120"/>
+              </a:rPr>
+              <a:t> (có</a:t>
+            </a:r>
+            <a:r>
+              <a:rPr lang="en-US" sz="2400" dirty="0" spc="0" kern="0">
+                <a:solidFill>
+                  <a:srgbClr val="14161C"/>
+                </a:solidFill>
+                <a:latin typeface="Be Vietnam Pro" pitchFamily="34" charset="0"/>
+                <a:ea typeface="Be Vietnam Pro" pitchFamily="34" charset="-122"/>
+                <a:cs typeface="Be Vietnam Pro" pitchFamily="34" charset="-120"/>
+              </a:rPr>
+              <a:t> thể</a:t>
+            </a:r>
+            <a:r>
+              <a:rPr lang="en-US" sz="2400" dirty="0" spc="16" kern="0">
+                <a:solidFill>
+                  <a:srgbClr val="14161C"/>
+                </a:solidFill>
+                <a:latin typeface="Be Vietnam Pro" pitchFamily="34" charset="0"/>
+                <a:ea typeface="Be Vietnam Pro" pitchFamily="34" charset="-122"/>
+                <a:cs typeface="Be Vietnam Pro" pitchFamily="34" charset="-120"/>
+              </a:rPr>
+              <a:t> lưu</a:t>
+            </a:r>
+            <a:r>
+              <a:rPr lang="en-US" sz="2400" dirty="0" spc="1" kern="0">
+                <a:solidFill>
+                  <a:srgbClr val="14161C"/>
+                </a:solidFill>
+                <a:latin typeface="Be Vietnam Pro" pitchFamily="34" charset="0"/>
+                <a:ea typeface="Be Vietnam Pro" pitchFamily="34" charset="-122"/>
+                <a:cs typeface="Be Vietnam Pro" pitchFamily="34" charset="-120"/>
+              </a:rPr>
+              <a:t> thành</a:t>
+            </a:r>
+            <a:r>
+              <a:rPr lang="en-US" sz="2400" dirty="0" spc="-10" kern="0">
+                <a:solidFill>
+                  <a:srgbClr val="14161C"/>
+                </a:solidFill>
+                <a:latin typeface="Be Vietnam Pro" pitchFamily="34" charset="0"/>
+                <a:ea typeface="Be Vietnam Pro" pitchFamily="34" charset="-122"/>
+                <a:cs typeface="Be Vietnam Pro" pitchFamily="34" charset="-120"/>
+              </a:rPr>
+              <a:t> tệp</a:t>
             </a:r>
             <a:r>
               <a:rPr lang="en-US" sz="2400" dirty="0" spc="-23" kern="0">
@@ -16903,29 +16958,18 @@
               <a:t> giới</a:t>
             </a:r>
             <a:r>
-              <a:rPr lang="en-US" sz="2400" dirty="0" spc="-1" kern="0">
-                <a:solidFill>
-                  <a:srgbClr val="14161C"/>
-                </a:solidFill>
-                <a:latin typeface="Be Vietnam Pro" pitchFamily="34" charset="0"/>
-                <a:ea typeface="Be Vietnam Pro" pitchFamily="34" charset="-122"/>
-                <a:cs typeface="Be Vietnam Pro" pitchFamily="34" charset="-120"/>
-              </a:rPr>
-              <a:t> có</a:t>
-            </a:r>
-            <a:r>
-              <a:rPr lang="en-US" sz="2400" dirty="0" spc="1" kern="0">
-                <a:solidFill>
-                  <a:srgbClr val="14161C"/>
-                </a:solidFill>
-                <a:latin typeface="Be Vietnam Pro" pitchFamily="34" charset="0"/>
-                <a:ea typeface="Be Vietnam Pro" pitchFamily="34" charset="-122"/>
-                <a:cs typeface="Be Vietnam Pro" pitchFamily="34" charset="-120"/>
-              </a:rPr>
-              <a:t> thể</a:t>
-            </a:r>
-            <a:r>
-              <a:rPr lang="en-US" sz="2400" dirty="0" spc="2" kern="0">
+              <a:rPr lang="en-US" sz="2400" dirty="0" spc="0" kern="0">
+                <a:solidFill>
+                  <a:srgbClr val="14161C"/>
+                </a:solidFill>
+                <a:latin typeface="Be Vietnam Pro" pitchFamily="34" charset="0"/>
+                <a:ea typeface="Be Vietnam Pro" pitchFamily="34" charset="-122"/>
+                <a:cs typeface="Be Vietnam Pro" pitchFamily="34" charset="-120"/>
+              </a:rPr>
+              <a:t> có thể</a:t>
+            </a:r>
+            <a:r>
+              <a:rPr lang="en-US" sz="2400" dirty="0" spc="3" kern="0">
                 <a:solidFill>
                   <a:srgbClr val="14161C"/>
                 </a:solidFill>

</xml_diff>

<commit_message>
Lesson sd-10-015: run Java bytecode on the JVM and C# on the CLR instead of sending both through the JVM, in the lesson, figure, metadata and deck
Co-Authored-By: Claude Sonnet 5.5 <noreply@anthropic.com>
Claude-Session: https://claude.ai/code/session_011dmt3ZFdN8sjiTfDnyUVN7
</commit_message>
<xml_diff>
--- a/system-design-101/vi/lessons/sd-10-015/slides/sd-10-015.pptx
+++ b/system-design-101/vi/lessons/sd-10-015/slides/sd-10-015.pptx
@@ -2967,7 +2967,7 @@
               <a:buNone/>
             </a:pPr>
             <a:r>
-              <a:rPr lang="en-US" sz="2387" dirty="0" spc="14" kern="0">
+              <a:rPr lang="en-US" sz="2387" dirty="0" spc="-12" kern="0">
                 <a:solidFill>
                   <a:srgbClr val="C4C8D6"/>
                 </a:solidFill>
@@ -2975,10 +2975,10 @@
                 <a:ea typeface="Be Vietnam Pro" pitchFamily="34" charset="-122"/>
                 <a:cs typeface="Be Vietnam Pro" pitchFamily="34" charset="-120"/>
               </a:rPr>
-              <a:t>JVM</a:t>
-            </a:r>
-            <a:r>
-              <a:rPr lang="en-US" sz="2387" dirty="0" spc="-2" kern="0">
+              <a:t>Máy</a:t>
+            </a:r>
+            <a:r>
+              <a:rPr lang="en-US" sz="2387" dirty="0" spc="-4" kern="0">
                 <a:solidFill>
                   <a:srgbClr val="C4C8D6"/>
                 </a:solidFill>
@@ -2986,10 +2986,21 @@
                 <a:ea typeface="Be Vietnam Pro" pitchFamily="34" charset="-122"/>
                 <a:cs typeface="Be Vietnam Pro" pitchFamily="34" charset="-120"/>
               </a:rPr>
+              <a:t> ảo</a:t>
+            </a:r>
+            <a:r>
+              <a:rPr lang="en-US" sz="2387" dirty="0" spc="-1" kern="0">
+                <a:solidFill>
+                  <a:srgbClr val="C4C8D6"/>
+                </a:solidFill>
+                <a:latin typeface="Be Vietnam Pro" pitchFamily="34" charset="0"/>
+                <a:ea typeface="Be Vietnam Pro" pitchFamily="34" charset="-122"/>
+                <a:cs typeface="Be Vietnam Pro" pitchFamily="34" charset="-120"/>
+              </a:rPr>
               <a:t> nạp</a:t>
             </a:r>
             <a:r>
-              <a:rPr lang="en-US" sz="2387" dirty="0" spc="-17" kern="0">
+              <a:rPr lang="en-US" sz="2387" dirty="0" spc="-18" kern="0">
                 <a:solidFill>
                   <a:srgbClr val="C4C8D6"/>
                 </a:solidFill>
@@ -4569,15 +4580,26 @@
               <a:buNone/>
             </a:pPr>
             <a:r>
-              <a:rPr lang="en-US" sz="2250" dirty="0" spc="12" kern="0">
-                <a:solidFill>
-                  <a:srgbClr val="14161C"/>
-                </a:solidFill>
-                <a:latin typeface="Be Vietnam Pro" pitchFamily="34" charset="0"/>
-                <a:ea typeface="Be Vietnam Pro" pitchFamily="34" charset="-122"/>
-                <a:cs typeface="Be Vietnam Pro" pitchFamily="34" charset="-120"/>
-              </a:rPr>
-              <a:t>JVM</a:t>
+              <a:rPr lang="en-US" sz="2250" dirty="0" spc="-15" kern="0">
+                <a:solidFill>
+                  <a:srgbClr val="14161C"/>
+                </a:solidFill>
+                <a:latin typeface="Be Vietnam Pro" pitchFamily="34" charset="0"/>
+                <a:ea typeface="Be Vietnam Pro" pitchFamily="34" charset="-122"/>
+                <a:cs typeface="Be Vietnam Pro" pitchFamily="34" charset="-120"/>
+              </a:rPr>
+              <a:t>Máy</a:t>
+            </a:r>
+            <a:r>
+              <a:rPr lang="en-US" sz="2250" dirty="0" spc="-2" kern="0">
+                <a:solidFill>
+                  <a:srgbClr val="14161C"/>
+                </a:solidFill>
+                <a:latin typeface="Be Vietnam Pro" pitchFamily="34" charset="0"/>
+                <a:ea typeface="Be Vietnam Pro" pitchFamily="34" charset="-122"/>
+                <a:cs typeface="Be Vietnam Pro" pitchFamily="34" charset="-120"/>
+              </a:rPr>
+              <a:t> ảo</a:t>
             </a:r>
             <a:r>
               <a:rPr lang="en-US" sz="2250" dirty="0" spc="1" kern="0">
@@ -4602,7 +4624,7 @@
               <a:t> và</a:t>
             </a:r>
             <a:r>
-              <a:rPr lang="en-US" sz="2250" dirty="0" spc="-6" kern="0">
+              <a:rPr lang="en-US" sz="2250" dirty="0" spc="-7" kern="0">
                 <a:solidFill>
                   <a:srgbClr val="14161C"/>
                 </a:solidFill>
@@ -7640,15 +7662,26 @@
               <a:t> gian.</a:t>
             </a:r>
             <a:r>
-              <a:rPr lang="en-US" sz="2850" dirty="0" spc="17" kern="0">
-                <a:solidFill>
-                  <a:srgbClr val="14161C"/>
-                </a:solidFill>
-                <a:latin typeface="Be Vietnam Pro" pitchFamily="34" charset="0"/>
-                <a:ea typeface="Be Vietnam Pro" pitchFamily="34" charset="-122"/>
-                <a:cs typeface="Be Vietnam Pro" pitchFamily="34" charset="-120"/>
-              </a:rPr>
-              <a:t> JVM</a:t>
+              <a:rPr lang="en-US" sz="2850" dirty="0" spc="-8" kern="0">
+                <a:solidFill>
+                  <a:srgbClr val="14161C"/>
+                </a:solidFill>
+                <a:latin typeface="Be Vietnam Pro" pitchFamily="34" charset="0"/>
+                <a:ea typeface="Be Vietnam Pro" pitchFamily="34" charset="-122"/>
+                <a:cs typeface="Be Vietnam Pro" pitchFamily="34" charset="-120"/>
+              </a:rPr>
+              <a:t> Máy</a:t>
+            </a:r>
+            <a:r>
+              <a:rPr lang="en-US" sz="2850" dirty="0" spc="3" kern="0">
+                <a:solidFill>
+                  <a:srgbClr val="14161C"/>
+                </a:solidFill>
+                <a:latin typeface="Be Vietnam Pro" pitchFamily="34" charset="0"/>
+                <a:ea typeface="Be Vietnam Pro" pitchFamily="34" charset="-122"/>
+                <a:cs typeface="Be Vietnam Pro" pitchFamily="34" charset="-120"/>
+              </a:rPr>
+              <a:t> ảo</a:t>
             </a:r>
             <a:r>
               <a:rPr lang="en-US" sz="2850" dirty="0" spc="-1" kern="0">
@@ -7662,7 +7695,7 @@
               <a:t> nạp</a:t>
             </a:r>
             <a:r>
-              <a:rPr lang="en-US" sz="2850" dirty="0" spc="-16" kern="0">
+              <a:rPr lang="en-US" sz="2850" dirty="0" spc="-17" kern="0">
                 <a:solidFill>
                   <a:srgbClr val="14161C"/>
                 </a:solidFill>
@@ -8490,15 +8523,26 @@
               <a:t> ảo</a:t>
             </a:r>
             <a:r>
-              <a:rPr lang="en-US" sz="3300" b="1" dirty="0" spc="2" kern="0">
-                <a:solidFill>
-                  <a:srgbClr val="14161C"/>
-                </a:solidFill>
-                <a:latin typeface="Be Vietnam Pro" pitchFamily="34" charset="0"/>
-                <a:ea typeface="Be Vietnam Pro" pitchFamily="34" charset="-122"/>
-                <a:cs typeface="Be Vietnam Pro" pitchFamily="34" charset="-120"/>
-              </a:rPr>
-              <a:t> (JVM)</a:t>
+              <a:rPr lang="en-US" sz="3300" b="1" dirty="0" spc="3" kern="0">
+                <a:solidFill>
+                  <a:srgbClr val="14161C"/>
+                </a:solidFill>
+                <a:latin typeface="Be Vietnam Pro" pitchFamily="34" charset="0"/>
+                <a:ea typeface="Be Vietnam Pro" pitchFamily="34" charset="-122"/>
+                <a:cs typeface="Be Vietnam Pro" pitchFamily="34" charset="-120"/>
+              </a:rPr>
+              <a:t> (JVM,</a:t>
+            </a:r>
+            <a:r>
+              <a:rPr lang="en-US" sz="3300" b="1" dirty="0" spc="-3" kern="0">
+                <a:solidFill>
+                  <a:srgbClr val="14161C"/>
+                </a:solidFill>
+                <a:latin typeface="Be Vietnam Pro" pitchFamily="34" charset="0"/>
+                <a:ea typeface="Be Vietnam Pro" pitchFamily="34" charset="-122"/>
+                <a:cs typeface="Be Vietnam Pro" pitchFamily="34" charset="-120"/>
+              </a:rPr>
+              <a:t> CLR)</a:t>
             </a:r>
             <a:endParaRPr lang="en-US" sz="3300" dirty="0"/>
           </a:p>
@@ -8532,6 +8576,39 @@
               <a:buNone/>
             </a:pPr>
             <a:r>
+              <a:rPr lang="en-US" sz="2400" dirty="0" spc="-18" kern="0">
+                <a:solidFill>
+                  <a:srgbClr val="14161C"/>
+                </a:solidFill>
+                <a:latin typeface="Be Vietnam Pro" pitchFamily="34" charset="0"/>
+                <a:ea typeface="Be Vietnam Pro" pitchFamily="34" charset="-122"/>
+                <a:cs typeface="Be Vietnam Pro" pitchFamily="34" charset="-120"/>
+              </a:rPr>
+              <a:t>Java:</a:t>
+            </a:r>
+            <a:r>
+              <a:rPr lang="en-US" sz="2400" dirty="0" spc="9" kern="0">
+                <a:solidFill>
+                  <a:srgbClr val="14161C"/>
+                </a:solidFill>
+                <a:latin typeface="Be Vietnam Pro" pitchFamily="34" charset="0"/>
+                <a:ea typeface="Be Vietnam Pro" pitchFamily="34" charset="-122"/>
+                <a:cs typeface="Be Vietnam Pro" pitchFamily="34" charset="-120"/>
+              </a:rPr>
+              <a:t> JVM;</a:t>
+            </a:r>
+            <a:r>
+              <a:rPr lang="en-US" sz="2400" dirty="0" spc="-1" kern="0">
+                <a:solidFill>
+                  <a:srgbClr val="14161C"/>
+                </a:solidFill>
+                <a:latin typeface="Be Vietnam Pro" pitchFamily="34" charset="0"/>
+                <a:ea typeface="Be Vietnam Pro" pitchFamily="34" charset="-122"/>
+                <a:cs typeface="Be Vietnam Pro" pitchFamily="34" charset="-120"/>
+              </a:rPr>
+              <a:t> C#:</a:t>
+            </a:r>
+            <a:r>
               <a:rPr lang="en-US" sz="2400" dirty="0" spc="0" kern="0">
                 <a:solidFill>
                   <a:srgbClr val="14161C"/>
@@ -8540,40 +8617,7 @@
                 <a:ea typeface="Be Vietnam Pro" pitchFamily="34" charset="-122"/>
                 <a:cs typeface="Be Vietnam Pro" pitchFamily="34" charset="-120"/>
               </a:rPr>
-              <a:t>Nạp</a:t>
-            </a:r>
-            <a:r>
-              <a:rPr lang="en-US" sz="2400" dirty="0" spc="-15" kern="0">
-                <a:solidFill>
-                  <a:srgbClr val="14161C"/>
-                </a:solidFill>
-                <a:latin typeface="Be Vietnam Pro" pitchFamily="34" charset="0"/>
-                <a:ea typeface="Be Vietnam Pro" pitchFamily="34" charset="-122"/>
-                <a:cs typeface="Be Vietnam Pro" pitchFamily="34" charset="-120"/>
-              </a:rPr>
-              <a:t> và</a:t>
-            </a:r>
-            <a:r>
-              <a:rPr lang="en-US" sz="2400" dirty="0" spc="-7" kern="0">
-                <a:solidFill>
-                  <a:srgbClr val="14161C"/>
-                </a:solidFill>
-                <a:latin typeface="Be Vietnam Pro" pitchFamily="34" charset="0"/>
-                <a:ea typeface="Be Vietnam Pro" pitchFamily="34" charset="-122"/>
-                <a:cs typeface="Be Vietnam Pro" pitchFamily="34" charset="-120"/>
-              </a:rPr>
-              <a:t> chạy</a:t>
-            </a:r>
-            <a:r>
-              <a:rPr lang="en-US" sz="2400" dirty="0" spc="-10" kern="0">
-                <a:solidFill>
-                  <a:srgbClr val="14161C"/>
-                </a:solidFill>
-                <a:latin typeface="Be Vietnam Pro" pitchFamily="34" charset="0"/>
-                <a:ea typeface="Be Vietnam Pro" pitchFamily="34" charset="-122"/>
-                <a:cs typeface="Be Vietnam Pro" pitchFamily="34" charset="-120"/>
-              </a:rPr>
-              <a:t> bytecode.</a:t>
+              <a:t> CLR.</a:t>
             </a:r>
             <a:endParaRPr lang="en-US" sz="2400" dirty="0"/>
           </a:p>
@@ -16270,18 +16314,29 @@
               <a:buNone/>
             </a:pPr>
             <a:r>
-              <a:rPr lang="en-US" sz="2400" dirty="0" spc="14" kern="0">
-                <a:solidFill>
-                  <a:srgbClr val="14161C"/>
-                </a:solidFill>
-                <a:latin typeface="Be Vietnam Pro" pitchFamily="34" charset="0"/>
-                <a:ea typeface="Be Vietnam Pro" pitchFamily="34" charset="-122"/>
-                <a:cs typeface="Be Vietnam Pro" pitchFamily="34" charset="-120"/>
-              </a:rPr>
-              <a:t>JVM</a:t>
-            </a:r>
-            <a:r>
-              <a:rPr lang="en-US" sz="2400" dirty="0" spc="3" kern="0">
+              <a:rPr lang="en-US" sz="2400" dirty="0" spc="-12" kern="0">
+                <a:solidFill>
+                  <a:srgbClr val="14161C"/>
+                </a:solidFill>
+                <a:latin typeface="Be Vietnam Pro" pitchFamily="34" charset="0"/>
+                <a:ea typeface="Be Vietnam Pro" pitchFamily="34" charset="-122"/>
+                <a:cs typeface="Be Vietnam Pro" pitchFamily="34" charset="-120"/>
+              </a:rPr>
+              <a:t>Máy</a:t>
+            </a:r>
+            <a:r>
+              <a:rPr lang="en-US" sz="2400" dirty="0" spc="4" kern="0">
+                <a:solidFill>
+                  <a:srgbClr val="14161C"/>
+                </a:solidFill>
+                <a:latin typeface="Be Vietnam Pro" pitchFamily="34" charset="0"/>
+                <a:ea typeface="Be Vietnam Pro" pitchFamily="34" charset="-122"/>
+                <a:cs typeface="Be Vietnam Pro" pitchFamily="34" charset="-120"/>
+              </a:rPr>
+              <a:t> ảo</a:t>
+            </a:r>
+            <a:r>
+              <a:rPr lang="en-US" sz="2400" dirty="0" spc="2" kern="0">
                 <a:solidFill>
                   <a:srgbClr val="14161C"/>
                 </a:solidFill>
@@ -16292,7 +16347,7 @@
               <a:t> nạp</a:t>
             </a:r>
             <a:r>
-              <a:rPr lang="en-US" sz="2400" dirty="0" spc="-16" kern="0">
+              <a:rPr lang="en-US" sz="2400" dirty="0" spc="-15" kern="0">
                 <a:solidFill>
                   <a:srgbClr val="14161C"/>
                 </a:solidFill>
@@ -16413,7 +16468,7 @@
               <a:t> sang</a:t>
             </a:r>
             <a:r>
-              <a:rPr lang="en-US" sz="2400" dirty="0" spc="5" kern="0">
+              <a:rPr lang="en-US" sz="2400" dirty="0" spc="4" kern="0">
                 <a:solidFill>
                   <a:srgbClr val="14161C"/>
                 </a:solidFill>
@@ -16435,7 +16490,7 @@
               <a:t> máy</a:t>
             </a:r>
             <a:r>
-              <a:rPr lang="en-US" sz="2400" dirty="0" spc="0" kern="0">
+              <a:rPr lang="en-US" sz="2400" dirty="0" spc="1" kern="0">
                 <a:solidFill>
                   <a:srgbClr val="14161C"/>
                 </a:solidFill>

</xml_diff>

<commit_message>
Lesson sd-10-015: update the deck limits slide so it no longer says nothing is known about how C# runs
Co-Authored-By: Claude Sonnet 5.5 <noreply@anthropic.com>
Claude-Session: https://claude.ai/code/session_011dmt3ZFdN8sjiTfDnyUVN7
</commit_message>
<xml_diff>
--- a/system-design-101/vi/lessons/sd-10-015/slides/sd-10-015.pptx
+++ b/system-design-101/vi/lessons/sd-10-015/slides/sd-10-015.pptx
@@ -14634,7 +14634,7 @@
               <a:buChar char="•"/>
             </a:pPr>
             <a:r>
-              <a:rPr lang="en-US" sz="2250" dirty="0" spc="-3" kern="0">
+              <a:rPr lang="en-US" sz="2250" dirty="0" spc="-2" kern="0">
                 <a:solidFill>
                   <a:srgbClr val="F3EEE3"/>
                 </a:solidFill>
@@ -14642,10 +14642,10 @@
                 <a:ea typeface="Be Vietnam Pro" pitchFamily="34" charset="-122"/>
                 <a:cs typeface="Be Vietnam Pro" pitchFamily="34" charset="-120"/>
               </a:rPr>
-              <a:t>Bài</a:t>
-            </a:r>
-            <a:r>
-              <a:rPr lang="en-US" sz="2250" dirty="0" spc="1" kern="0">
+              <a:t>C#</a:t>
+            </a:r>
+            <a:r>
+              <a:rPr lang="en-US" sz="2250" dirty="0" spc="-6" kern="0">
                 <a:solidFill>
                   <a:srgbClr val="F3EEE3"/>
                 </a:solidFill>
@@ -14653,10 +14653,10 @@
                 <a:ea typeface="Be Vietnam Pro" pitchFamily="34" charset="-122"/>
                 <a:cs typeface="Be Vietnam Pro" pitchFamily="34" charset="-120"/>
               </a:rPr>
-              <a:t> không</a:t>
-            </a:r>
-            <a:r>
-              <a:rPr lang="en-US" sz="2250" dirty="0" spc="2" kern="0">
+              <a:t> chạy</a:t>
+            </a:r>
+            <a:r>
+              <a:rPr lang="en-US" sz="2250" dirty="0" spc="-19" kern="0">
                 <a:solidFill>
                   <a:srgbClr val="F3EEE3"/>
                 </a:solidFill>
@@ -14664,7 +14664,40 @@
                 <a:ea typeface="Be Vietnam Pro" pitchFamily="34" charset="-122"/>
                 <a:cs typeface="Be Vietnam Pro" pitchFamily="34" charset="-120"/>
               </a:rPr>
-              <a:t> nói</a:t>
+              <a:t> trên</a:t>
+            </a:r>
+            <a:r>
+              <a:rPr lang="en-US" sz="2250" dirty="0" spc="3" kern="0">
+                <a:solidFill>
+                  <a:srgbClr val="F3EEE3"/>
+                </a:solidFill>
+                <a:latin typeface="Be Vietnam Pro" pitchFamily="34" charset="0"/>
+                <a:ea typeface="Be Vietnam Pro" pitchFamily="34" charset="-122"/>
+                <a:cs typeface="Be Vietnam Pro" pitchFamily="34" charset="-120"/>
+              </a:rPr>
+              <a:t> CLR:</a:t>
+            </a:r>
+            <a:r>
+              <a:rPr lang="en-US" sz="2250" dirty="0" spc="6" kern="0">
+                <a:solidFill>
+                  <a:srgbClr val="F3EEE3"/>
+                </a:solidFill>
+                <a:latin typeface="Be Vietnam Pro" pitchFamily="34" charset="0"/>
+                <a:ea typeface="Be Vietnam Pro" pitchFamily="34" charset="-122"/>
+                <a:cs typeface="Be Vietnam Pro" pitchFamily="34" charset="-120"/>
+              </a:rPr>
+              <a:t> chưa</a:t>
+            </a:r>
+            <a:r>
+              <a:rPr lang="en-US" sz="2250" dirty="0" spc="13" kern="0">
+                <a:solidFill>
+                  <a:srgbClr val="F3EEE3"/>
+                </a:solidFill>
+                <a:latin typeface="Be Vietnam Pro" pitchFamily="34" charset="0"/>
+                <a:ea typeface="Be Vietnam Pro" pitchFamily="34" charset="-122"/>
+                <a:cs typeface="Be Vietnam Pro" pitchFamily="34" charset="-120"/>
+              </a:rPr>
+              <a:t> đối</a:t>
             </a:r>
             <a:r>
               <a:rPr lang="en-US" sz="2250" dirty="0" spc="-1" kern="0">
@@ -14675,40 +14708,7 @@
                 <a:ea typeface="Be Vietnam Pro" pitchFamily="34" charset="-122"/>
                 <a:cs typeface="Be Vietnam Pro" pitchFamily="34" charset="-120"/>
               </a:rPr>
-              <a:t> thêm gì</a:t>
-            </a:r>
-            <a:r>
-              <a:rPr lang="en-US" sz="2250" dirty="0" spc="-16" kern="0">
-                <a:solidFill>
-                  <a:srgbClr val="F3EEE3"/>
-                </a:solidFill>
-                <a:latin typeface="Be Vietnam Pro" pitchFamily="34" charset="0"/>
-                <a:ea typeface="Be Vietnam Pro" pitchFamily="34" charset="-122"/>
-                <a:cs typeface="Be Vietnam Pro" pitchFamily="34" charset="-120"/>
-              </a:rPr>
-              <a:t> về</a:t>
-            </a:r>
-            <a:r>
-              <a:rPr lang="en-US" sz="2250" dirty="0" spc="1" kern="0">
-                <a:solidFill>
-                  <a:srgbClr val="F3EEE3"/>
-                </a:solidFill>
-                <a:latin typeface="Be Vietnam Pro" pitchFamily="34" charset="0"/>
-                <a:ea typeface="Be Vietnam Pro" pitchFamily="34" charset="-122"/>
-                <a:cs typeface="Be Vietnam Pro" pitchFamily="34" charset="-120"/>
-              </a:rPr>
-              <a:t> cách C#</a:t>
-            </a:r>
-            <a:r>
-              <a:rPr lang="en-US" sz="2250" dirty="0" spc="-6" kern="0">
-                <a:solidFill>
-                  <a:srgbClr val="F3EEE3"/>
-                </a:solidFill>
-                <a:latin typeface="Be Vietnam Pro" pitchFamily="34" charset="0"/>
-                <a:ea typeface="Be Vietnam Pro" pitchFamily="34" charset="-122"/>
-                <a:cs typeface="Be Vietnam Pro" pitchFamily="34" charset="-120"/>
-              </a:rPr>
-              <a:t> chạy</a:t>
+              <a:t> chiếu</a:t>
             </a:r>
             <a:endParaRPr lang="en-US" sz="2250" dirty="0"/>
           </a:p>

</xml_diff>

<commit_message>
Lesson sd-10-015: show C# as its own path where CIL must be converted to machine code before it runs, in the lesson, figure, metadata and deck
Co-Authored-By: Claude Sonnet 5.5 <noreply@anthropic.com>
Claude-Session: https://claude.ai/code/session_011dmt3ZFdN8sjiTfDnyUVN7
</commit_message>
<xml_diff>
--- a/system-design-101/vi/lessons/sd-10-015/slides/sd-10-015.pptx
+++ b/system-design-101/vi/lessons/sd-10-015/slides/sd-10-015.pptx
@@ -7662,26 +7662,15 @@
               <a:t> gian.</a:t>
             </a:r>
             <a:r>
-              <a:rPr lang="en-US" sz="2850" dirty="0" spc="-8" kern="0">
-                <a:solidFill>
-                  <a:srgbClr val="14161C"/>
-                </a:solidFill>
-                <a:latin typeface="Be Vietnam Pro" pitchFamily="34" charset="0"/>
-                <a:ea typeface="Be Vietnam Pro" pitchFamily="34" charset="-122"/>
-                <a:cs typeface="Be Vietnam Pro" pitchFamily="34" charset="-120"/>
-              </a:rPr>
-              <a:t> Máy</a:t>
-            </a:r>
-            <a:r>
-              <a:rPr lang="en-US" sz="2850" dirty="0" spc="3" kern="0">
-                <a:solidFill>
-                  <a:srgbClr val="14161C"/>
-                </a:solidFill>
-                <a:latin typeface="Be Vietnam Pro" pitchFamily="34" charset="0"/>
-                <a:ea typeface="Be Vietnam Pro" pitchFamily="34" charset="-122"/>
-                <a:cs typeface="Be Vietnam Pro" pitchFamily="34" charset="-120"/>
-              </a:rPr>
-              <a:t> ảo</a:t>
+              <a:rPr lang="en-US" sz="2850" dirty="0" spc="17" kern="0">
+                <a:solidFill>
+                  <a:srgbClr val="14161C"/>
+                </a:solidFill>
+                <a:latin typeface="Be Vietnam Pro" pitchFamily="34" charset="0"/>
+                <a:ea typeface="Be Vietnam Pro" pitchFamily="34" charset="-122"/>
+                <a:cs typeface="Be Vietnam Pro" pitchFamily="34" charset="-120"/>
+              </a:rPr>
+              <a:t> JVM</a:t>
             </a:r>
             <a:r>
               <a:rPr lang="en-US" sz="2850" dirty="0" spc="-1" kern="0">
@@ -7695,7 +7684,7 @@
               <a:t> nạp</a:t>
             </a:r>
             <a:r>
-              <a:rPr lang="en-US" sz="2850" dirty="0" spc="-17" kern="0">
+              <a:rPr lang="en-US" sz="2850" dirty="0" spc="-16" kern="0">
                 <a:solidFill>
                   <a:srgbClr val="14161C"/>
                 </a:solidFill>
@@ -7706,26 +7695,59 @@
               <a:t> và</a:t>
             </a:r>
             <a:r>
-              <a:rPr lang="en-US" sz="2850" dirty="0" spc="-9" kern="0">
-                <a:solidFill>
-                  <a:srgbClr val="14161C"/>
-                </a:solidFill>
-                <a:latin typeface="Be Vietnam Pro" pitchFamily="34" charset="0"/>
-                <a:ea typeface="Be Vietnam Pro" pitchFamily="34" charset="-122"/>
-                <a:cs typeface="Be Vietnam Pro" pitchFamily="34" charset="-120"/>
-              </a:rPr>
-              <a:t> chạy</a:t>
-            </a:r>
-            <a:r>
-              <a:rPr lang="en-US" sz="2850" dirty="0" spc="-14" kern="0">
-                <a:solidFill>
-                  <a:srgbClr val="14161C"/>
-                </a:solidFill>
-                <a:latin typeface="Be Vietnam Pro" pitchFamily="34" charset="0"/>
-                <a:ea typeface="Be Vietnam Pro" pitchFamily="34" charset="-122"/>
-                <a:cs typeface="Be Vietnam Pro" pitchFamily="34" charset="-120"/>
-              </a:rPr>
-              <a:t> bytecode.</a:t>
+              <a:rPr lang="en-US" sz="2850" dirty="0" spc="-7" kern="0">
+                <a:solidFill>
+                  <a:srgbClr val="14161C"/>
+                </a:solidFill>
+                <a:latin typeface="Be Vietnam Pro" pitchFamily="34" charset="0"/>
+                <a:ea typeface="Be Vietnam Pro" pitchFamily="34" charset="-122"/>
+                <a:cs typeface="Be Vietnam Pro" pitchFamily="34" charset="-120"/>
+              </a:rPr>
+              <a:t> chạy.</a:t>
+            </a:r>
+            <a:r>
+              <a:rPr lang="en-US" sz="2850" dirty="0" spc="1" kern="0">
+                <a:solidFill>
+                  <a:srgbClr val="14161C"/>
+                </a:solidFill>
+                <a:latin typeface="Be Vietnam Pro" pitchFamily="34" charset="0"/>
+                <a:ea typeface="Be Vietnam Pro" pitchFamily="34" charset="-122"/>
+                <a:cs typeface="Be Vietnam Pro" pitchFamily="34" charset="-120"/>
+              </a:rPr>
+              <a:t> C#</a:t>
+            </a:r>
+            <a:r>
+              <a:rPr lang="en-US" sz="2850" dirty="0" spc="40" kern="0">
+                <a:solidFill>
+                  <a:srgbClr val="14161C"/>
+                </a:solidFill>
+                <a:latin typeface="Be Vietnam Pro" pitchFamily="34" charset="0"/>
+                <a:ea typeface="Be Vietnam Pro" pitchFamily="34" charset="-122"/>
+                <a:cs typeface="Be Vietnam Pro" pitchFamily="34" charset="-120"/>
+              </a:rPr>
+              <a:t> đi</a:t>
+            </a:r>
+            <a:r>
+              <a:rPr lang="en-US" sz="2850" dirty="0" spc="6" kern="0">
+                <a:solidFill>
+                  <a:srgbClr val="14161C"/>
+                </a:solidFill>
+                <a:latin typeface="Be Vietnam Pro" pitchFamily="34" charset="0"/>
+                <a:ea typeface="Be Vietnam Pro" pitchFamily="34" charset="-122"/>
+                <a:cs typeface="Be Vietnam Pro" pitchFamily="34" charset="-120"/>
+              </a:rPr>
+              <a:t> đường</a:t>
+            </a:r>
+            <a:r>
+              <a:rPr lang="en-US" sz="2850" dirty="0" spc="9" kern="0">
+                <a:solidFill>
+                  <a:srgbClr val="14161C"/>
+                </a:solidFill>
+                <a:latin typeface="Be Vietnam Pro" pitchFamily="34" charset="0"/>
+                <a:ea typeface="Be Vietnam Pro" pitchFamily="34" charset="-122"/>
+                <a:cs typeface="Be Vietnam Pro" pitchFamily="34" charset="-120"/>
+              </a:rPr>
+              <a:t> riêng.</a:t>
             </a:r>
             <a:endParaRPr lang="en-US" sz="2850" dirty="0"/>
           </a:p>
@@ -8520,29 +8542,7 @@
                 <a:ea typeface="Be Vietnam Pro" pitchFamily="34" charset="-122"/>
                 <a:cs typeface="Be Vietnam Pro" pitchFamily="34" charset="-120"/>
               </a:rPr>
-              <a:t> ảo</a:t>
-            </a:r>
-            <a:r>
-              <a:rPr lang="en-US" sz="3300" b="1" dirty="0" spc="3" kern="0">
-                <a:solidFill>
-                  <a:srgbClr val="14161C"/>
-                </a:solidFill>
-                <a:latin typeface="Be Vietnam Pro" pitchFamily="34" charset="0"/>
-                <a:ea typeface="Be Vietnam Pro" pitchFamily="34" charset="-122"/>
-                <a:cs typeface="Be Vietnam Pro" pitchFamily="34" charset="-120"/>
-              </a:rPr>
-              <a:t> (JVM,</a:t>
-            </a:r>
-            <a:r>
-              <a:rPr lang="en-US" sz="3300" b="1" dirty="0" spc="-3" kern="0">
-                <a:solidFill>
-                  <a:srgbClr val="14161C"/>
-                </a:solidFill>
-                <a:latin typeface="Be Vietnam Pro" pitchFamily="34" charset="0"/>
-                <a:ea typeface="Be Vietnam Pro" pitchFamily="34" charset="-122"/>
-                <a:cs typeface="Be Vietnam Pro" pitchFamily="34" charset="-120"/>
-              </a:rPr>
-              <a:t> CLR)</a:t>
+              <a:t> ảo JVM</a:t>
             </a:r>
             <a:endParaRPr lang="en-US" sz="3300" dirty="0"/>
           </a:p>
@@ -8576,48 +8576,59 @@
               <a:buNone/>
             </a:pPr>
             <a:r>
-              <a:rPr lang="en-US" sz="2400" dirty="0" spc="-18" kern="0">
-                <a:solidFill>
-                  <a:srgbClr val="14161C"/>
-                </a:solidFill>
-                <a:latin typeface="Be Vietnam Pro" pitchFamily="34" charset="0"/>
-                <a:ea typeface="Be Vietnam Pro" pitchFamily="34" charset="-122"/>
-                <a:cs typeface="Be Vietnam Pro" pitchFamily="34" charset="-120"/>
-              </a:rPr>
-              <a:t>Java:</a:t>
-            </a:r>
-            <a:r>
-              <a:rPr lang="en-US" sz="2400" dirty="0" spc="9" kern="0">
-                <a:solidFill>
-                  <a:srgbClr val="14161C"/>
-                </a:solidFill>
-                <a:latin typeface="Be Vietnam Pro" pitchFamily="34" charset="0"/>
-                <a:ea typeface="Be Vietnam Pro" pitchFamily="34" charset="-122"/>
-                <a:cs typeface="Be Vietnam Pro" pitchFamily="34" charset="-120"/>
-              </a:rPr>
-              <a:t> JVM;</a:t>
-            </a:r>
-            <a:r>
-              <a:rPr lang="en-US" sz="2400" dirty="0" spc="-1" kern="0">
-                <a:solidFill>
-                  <a:srgbClr val="14161C"/>
-                </a:solidFill>
-                <a:latin typeface="Be Vietnam Pro" pitchFamily="34" charset="0"/>
-                <a:ea typeface="Be Vietnam Pro" pitchFamily="34" charset="-122"/>
-                <a:cs typeface="Be Vietnam Pro" pitchFamily="34" charset="-120"/>
-              </a:rPr>
-              <a:t> C#:</a:t>
-            </a:r>
-            <a:r>
-              <a:rPr lang="en-US" sz="2400" dirty="0" spc="0" kern="0">
-                <a:solidFill>
-                  <a:srgbClr val="14161C"/>
-                </a:solidFill>
-                <a:latin typeface="Be Vietnam Pro" pitchFamily="34" charset="0"/>
-                <a:ea typeface="Be Vietnam Pro" pitchFamily="34" charset="-122"/>
-                <a:cs typeface="Be Vietnam Pro" pitchFamily="34" charset="-120"/>
-              </a:rPr>
-              <a:t> CLR.</a:t>
+              <a:rPr lang="en-US" sz="2400" dirty="0" spc="14" kern="0">
+                <a:solidFill>
+                  <a:srgbClr val="14161C"/>
+                </a:solidFill>
+                <a:latin typeface="Be Vietnam Pro" pitchFamily="34" charset="0"/>
+                <a:ea typeface="Be Vietnam Pro" pitchFamily="34" charset="-122"/>
+                <a:cs typeface="Be Vietnam Pro" pitchFamily="34" charset="-120"/>
+              </a:rPr>
+              <a:t>JVM</a:t>
+            </a:r>
+            <a:r>
+              <a:rPr lang="en-US" sz="2400" dirty="0" spc="3" kern="0">
+                <a:solidFill>
+                  <a:srgbClr val="14161C"/>
+                </a:solidFill>
+                <a:latin typeface="Be Vietnam Pro" pitchFamily="34" charset="0"/>
+                <a:ea typeface="Be Vietnam Pro" pitchFamily="34" charset="-122"/>
+                <a:cs typeface="Be Vietnam Pro" pitchFamily="34" charset="-120"/>
+              </a:rPr>
+              <a:t> nạp</a:t>
+            </a:r>
+            <a:r>
+              <a:rPr lang="en-US" sz="2400" dirty="0" spc="-16" kern="0">
+                <a:solidFill>
+                  <a:srgbClr val="14161C"/>
+                </a:solidFill>
+                <a:latin typeface="Be Vietnam Pro" pitchFamily="34" charset="0"/>
+                <a:ea typeface="Be Vietnam Pro" pitchFamily="34" charset="-122"/>
+                <a:cs typeface="Be Vietnam Pro" pitchFamily="34" charset="-120"/>
+              </a:rPr>
+              <a:t> và</a:t>
+            </a:r>
+            <a:r>
+              <a:rPr lang="en-US" sz="2400" dirty="0" spc="-7" kern="0">
+                <a:solidFill>
+                  <a:srgbClr val="14161C"/>
+                </a:solidFill>
+                <a:latin typeface="Be Vietnam Pro" pitchFamily="34" charset="0"/>
+                <a:ea typeface="Be Vietnam Pro" pitchFamily="34" charset="-122"/>
+                <a:cs typeface="Be Vietnam Pro" pitchFamily="34" charset="-120"/>
+              </a:rPr>
+              <a:t> chạy</a:t>
+            </a:r>
+            <a:r>
+              <a:rPr lang="en-US" sz="2400" dirty="0" spc="-10" kern="0">
+                <a:solidFill>
+                  <a:srgbClr val="14161C"/>
+                </a:solidFill>
+                <a:latin typeface="Be Vietnam Pro" pitchFamily="34" charset="0"/>
+                <a:ea typeface="Be Vietnam Pro" pitchFamily="34" charset="-122"/>
+                <a:cs typeface="Be Vietnam Pro" pitchFamily="34" charset="-120"/>
+              </a:rPr>
+              <a:t> bytecode.</a:t>
             </a:r>
             <a:endParaRPr lang="en-US" sz="2400" dirty="0"/>
           </a:p>
@@ -14645,6 +14656,83 @@
               <a:t>C#</a:t>
             </a:r>
             <a:r>
+              <a:rPr lang="en-US" sz="2250" dirty="0" spc="1" kern="0">
+                <a:solidFill>
+                  <a:srgbClr val="F3EEE3"/>
+                </a:solidFill>
+                <a:latin typeface="Be Vietnam Pro" pitchFamily="34" charset="0"/>
+                <a:ea typeface="Be Vietnam Pro" pitchFamily="34" charset="-122"/>
+                <a:cs typeface="Be Vietnam Pro" pitchFamily="34" charset="-120"/>
+              </a:rPr>
+              <a:t> qua</a:t>
+            </a:r>
+            <a:r>
+              <a:rPr lang="en-US" sz="2250" dirty="0" spc="2" kern="0">
+                <a:solidFill>
+                  <a:srgbClr val="F3EEE3"/>
+                </a:solidFill>
+                <a:latin typeface="Be Vietnam Pro" pitchFamily="34" charset="0"/>
+                <a:ea typeface="Be Vietnam Pro" pitchFamily="34" charset="-122"/>
+                <a:cs typeface="Be Vietnam Pro" pitchFamily="34" charset="-120"/>
+              </a:rPr>
+              <a:t> CLR: CIL</a:t>
+            </a:r>
+            <a:r>
+              <a:rPr lang="en-US" sz="2250" dirty="0" spc="0" kern="0">
+                <a:solidFill>
+                  <a:srgbClr val="F3EEE3"/>
+                </a:solidFill>
+                <a:latin typeface="Be Vietnam Pro" pitchFamily="34" charset="0"/>
+                <a:ea typeface="Be Vietnam Pro" pitchFamily="34" charset="-122"/>
+                <a:cs typeface="Be Vietnam Pro" pitchFamily="34" charset="-120"/>
+              </a:rPr>
+              <a:t> phải thành</a:t>
+            </a:r>
+            <a:r>
+              <a:rPr lang="en-US" sz="2250" dirty="0" spc="-2" kern="0">
+                <a:solidFill>
+                  <a:srgbClr val="F3EEE3"/>
+                </a:solidFill>
+                <a:latin typeface="Be Vietnam Pro" pitchFamily="34" charset="0"/>
+                <a:ea typeface="Be Vietnam Pro" pitchFamily="34" charset="-122"/>
+                <a:cs typeface="Be Vietnam Pro" pitchFamily="34" charset="-120"/>
+              </a:rPr>
+              <a:t> mã</a:t>
+            </a:r>
+            <a:r>
+              <a:rPr lang="en-US" sz="2250" dirty="0" spc="-10" kern="0">
+                <a:solidFill>
+                  <a:srgbClr val="F3EEE3"/>
+                </a:solidFill>
+                <a:latin typeface="Be Vietnam Pro" pitchFamily="34" charset="0"/>
+                <a:ea typeface="Be Vietnam Pro" pitchFamily="34" charset="-122"/>
+                <a:cs typeface="Be Vietnam Pro" pitchFamily="34" charset="-120"/>
+              </a:rPr>
+              <a:t> máy</a:t>
+            </a:r>
+            <a:r>
+              <a:rPr lang="en-US" sz="2250" dirty="0" spc="7" kern="0">
+                <a:solidFill>
+                  <a:srgbClr val="F3EEE3"/>
+                </a:solidFill>
+                <a:latin typeface="Be Vietnam Pro" pitchFamily="34" charset="0"/>
+                <a:ea typeface="Be Vietnam Pro" pitchFamily="34" charset="-122"/>
+                <a:cs typeface="Be Vietnam Pro" pitchFamily="34" charset="-120"/>
+              </a:rPr>
+              <a:t> trước</a:t>
+            </a:r>
+            <a:r>
+              <a:rPr lang="en-US" sz="2250" dirty="0" spc="-1" kern="0">
+                <a:solidFill>
+                  <a:srgbClr val="F3EEE3"/>
+                </a:solidFill>
+                <a:latin typeface="Be Vietnam Pro" pitchFamily="34" charset="0"/>
+                <a:ea typeface="Be Vietnam Pro" pitchFamily="34" charset="-122"/>
+                <a:cs typeface="Be Vietnam Pro" pitchFamily="34" charset="-120"/>
+              </a:rPr>
+              <a:t> khi</a:t>
+            </a:r>
+            <a:r>
               <a:rPr lang="en-US" sz="2250" dirty="0" spc="-6" kern="0">
                 <a:solidFill>
                   <a:srgbClr val="F3EEE3"/>
@@ -14654,61 +14742,6 @@
                 <a:cs typeface="Be Vietnam Pro" pitchFamily="34" charset="-120"/>
               </a:rPr>
               <a:t> chạy</a:t>
-            </a:r>
-            <a:r>
-              <a:rPr lang="en-US" sz="2250" dirty="0" spc="-19" kern="0">
-                <a:solidFill>
-                  <a:srgbClr val="F3EEE3"/>
-                </a:solidFill>
-                <a:latin typeface="Be Vietnam Pro" pitchFamily="34" charset="0"/>
-                <a:ea typeface="Be Vietnam Pro" pitchFamily="34" charset="-122"/>
-                <a:cs typeface="Be Vietnam Pro" pitchFamily="34" charset="-120"/>
-              </a:rPr>
-              <a:t> trên</a:t>
-            </a:r>
-            <a:r>
-              <a:rPr lang="en-US" sz="2250" dirty="0" spc="3" kern="0">
-                <a:solidFill>
-                  <a:srgbClr val="F3EEE3"/>
-                </a:solidFill>
-                <a:latin typeface="Be Vietnam Pro" pitchFamily="34" charset="0"/>
-                <a:ea typeface="Be Vietnam Pro" pitchFamily="34" charset="-122"/>
-                <a:cs typeface="Be Vietnam Pro" pitchFamily="34" charset="-120"/>
-              </a:rPr>
-              <a:t> CLR:</a:t>
-            </a:r>
-            <a:r>
-              <a:rPr lang="en-US" sz="2250" dirty="0" spc="6" kern="0">
-                <a:solidFill>
-                  <a:srgbClr val="F3EEE3"/>
-                </a:solidFill>
-                <a:latin typeface="Be Vietnam Pro" pitchFamily="34" charset="0"/>
-                <a:ea typeface="Be Vietnam Pro" pitchFamily="34" charset="-122"/>
-                <a:cs typeface="Be Vietnam Pro" pitchFamily="34" charset="-120"/>
-              </a:rPr>
-              <a:t> chưa</a:t>
-            </a:r>
-            <a:r>
-              <a:rPr lang="en-US" sz="2250" dirty="0" spc="13" kern="0">
-                <a:solidFill>
-                  <a:srgbClr val="F3EEE3"/>
-                </a:solidFill>
-                <a:latin typeface="Be Vietnam Pro" pitchFamily="34" charset="0"/>
-                <a:ea typeface="Be Vietnam Pro" pitchFamily="34" charset="-122"/>
-                <a:cs typeface="Be Vietnam Pro" pitchFamily="34" charset="-120"/>
-              </a:rPr>
-              <a:t> đối</a:t>
-            </a:r>
-            <a:r>
-              <a:rPr lang="en-US" sz="2250" dirty="0" spc="-1" kern="0">
-                <a:solidFill>
-                  <a:srgbClr val="F3EEE3"/>
-                </a:solidFill>
-                <a:latin typeface="Be Vietnam Pro" pitchFamily="34" charset="0"/>
-                <a:ea typeface="Be Vietnam Pro" pitchFamily="34" charset="-122"/>
-                <a:cs typeface="Be Vietnam Pro" pitchFamily="34" charset="-120"/>
-              </a:rPr>
-              <a:t> chiếu</a:t>
             </a:r>
             <a:endParaRPr lang="en-US" sz="2250" dirty="0"/>
           </a:p>

</xml_diff>

<commit_message>
Lesson sd-10-015: name the Microsoft source and the CIL step on the deck's sources slide
Co-Authored-By: Claude Sonnet 5.5 <noreply@anthropic.com>
Claude-Session: https://claude.ai/code/session_011dmt3ZFdN8sjiTfDnyUVN7
</commit_message>
<xml_diff>
--- a/system-design-101/vi/lessons/sd-10-015/slides/sd-10-015.pptx
+++ b/system-design-101/vi/lessons/sd-10-015/slides/sd-10-015.pptx
@@ -18759,6 +18759,28 @@
               </a:rPr>
               <a:t> OpenJDK</a:t>
             </a:r>
+            <a:r>
+              <a:rPr lang="en-US" sz="2250" b="1" dirty="0" spc="2" kern="0">
+                <a:solidFill>
+                  <a:srgbClr val="F3EEE3"/>
+                </a:solidFill>
+                <a:latin typeface="Be Vietnam Pro" pitchFamily="34" charset="0"/>
+                <a:ea typeface="Be Vietnam Pro" pitchFamily="34" charset="-122"/>
+                <a:cs typeface="Be Vietnam Pro" pitchFamily="34" charset="-120"/>
+              </a:rPr>
+              <a:t> ·</a:t>
+            </a:r>
+            <a:r>
+              <a:rPr lang="en-US" sz="2250" b="1" dirty="0" spc="-8" kern="0">
+                <a:solidFill>
+                  <a:srgbClr val="F3EEE3"/>
+                </a:solidFill>
+                <a:latin typeface="Be Vietnam Pro" pitchFamily="34" charset="0"/>
+                <a:ea typeface="Be Vietnam Pro" pitchFamily="34" charset="-122"/>
+                <a:cs typeface="Be Vietnam Pro" pitchFamily="34" charset="-120"/>
+              </a:rPr>
+              <a:t> Microsoft</a:t>
+            </a:r>
             <a:endParaRPr lang="en-US" sz="2250" dirty="0"/>
           </a:p>
         </p:txBody>
@@ -18810,10 +18832,10 @@
                 <a:ea typeface="Be Vietnam Pro" pitchFamily="34" charset="-122"/>
                 <a:cs typeface="Be Vietnam Pro" pitchFamily="34" charset="-120"/>
               </a:rPr>
-              <a:t> JIT;</a:t>
-            </a:r>
-            <a:r>
-              <a:rPr lang="en-US" sz="2100" dirty="0" spc="-11" kern="0">
+              <a:t> JIT; lệnh</a:t>
+            </a:r>
+            <a:r>
+              <a:rPr lang="en-US" sz="2100" dirty="0" spc="-23" kern="0">
                 <a:solidFill>
                   <a:srgbClr val="C4C8D6"/>
                 </a:solidFill>
@@ -18821,10 +18843,10 @@
                 <a:ea typeface="Be Vietnam Pro" pitchFamily="34" charset="-122"/>
                 <a:cs typeface="Be Vietnam Pro" pitchFamily="34" charset="-120"/>
               </a:rPr>
-              <a:t> tài</a:t>
-            </a:r>
-            <a:r>
-              <a:rPr lang="en-US" sz="2100" dirty="0" spc="0" kern="0">
+              <a:t> java;</a:t>
+            </a:r>
+            <a:r>
+              <a:rPr lang="en-US" sz="2100" dirty="0" spc="1" kern="0">
                 <a:solidFill>
                   <a:srgbClr val="C4C8D6"/>
                 </a:solidFill>
@@ -18832,10 +18854,10 @@
                 <a:ea typeface="Be Vietnam Pro" pitchFamily="34" charset="-122"/>
                 <a:cs typeface="Be Vietnam Pro" pitchFamily="34" charset="-120"/>
               </a:rPr>
-              <a:t> liệu lệnh</a:t>
-            </a:r>
-            <a:r>
-              <a:rPr lang="en-US" sz="2100" dirty="0" spc="-22" kern="0">
+              <a:t> CIL</a:t>
+            </a:r>
+            <a:r>
+              <a:rPr lang="en-US" sz="2100" dirty="0" spc="-4" kern="0">
                 <a:solidFill>
                   <a:srgbClr val="C4C8D6"/>
                 </a:solidFill>
@@ -18843,7 +18865,29 @@
                 <a:ea typeface="Be Vietnam Pro" pitchFamily="34" charset="-122"/>
                 <a:cs typeface="Be Vietnam Pro" pitchFamily="34" charset="-120"/>
               </a:rPr>
-              <a:t> java.</a:t>
+              <a:t> sang</a:t>
+            </a:r>
+            <a:r>
+              <a:rPr lang="en-US" sz="2100" dirty="0" spc="-3" kern="0">
+                <a:solidFill>
+                  <a:srgbClr val="C4C8D6"/>
+                </a:solidFill>
+                <a:latin typeface="Be Vietnam Pro" pitchFamily="34" charset="0"/>
+                <a:ea typeface="Be Vietnam Pro" pitchFamily="34" charset="-122"/>
+                <a:cs typeface="Be Vietnam Pro" pitchFamily="34" charset="-120"/>
+              </a:rPr>
+              <a:t> mã</a:t>
+            </a:r>
+            <a:r>
+              <a:rPr lang="en-US" sz="2100" dirty="0" spc="-8" kern="0">
+                <a:solidFill>
+                  <a:srgbClr val="C4C8D6"/>
+                </a:solidFill>
+                <a:latin typeface="Be Vietnam Pro" pitchFamily="34" charset="0"/>
+                <a:ea typeface="Be Vietnam Pro" pitchFamily="34" charset="-122"/>
+                <a:cs typeface="Be Vietnam Pro" pitchFamily="34" charset="-120"/>
+              </a:rPr>
+              <a:t> máy.</a:t>
             </a:r>
             <a:endParaRPr lang="en-US" sz="2100" dirty="0"/>
           </a:p>
@@ -19023,6 +19067,149 @@
               <a:t>Giải nghĩa CPU,</a:t>
             </a:r>
             <a:r>
+              <a:rPr lang="en-US" sz="1800" dirty="0" spc="5" kern="0">
+                <a:solidFill>
+                  <a:srgbClr val="9AA0B5"/>
+                </a:solidFill>
+                <a:latin typeface="Be Vietnam Pro" pitchFamily="34" charset="0"/>
+                <a:ea typeface="Be Vietnam Pro" pitchFamily="34" charset="-122"/>
+                <a:cs typeface="Be Vietnam Pro" pitchFamily="34" charset="-120"/>
+              </a:rPr>
+              <a:t> JVM,</a:t>
+            </a:r>
+            <a:r>
+              <a:rPr lang="en-US" sz="1800" dirty="0" spc="-2" kern="0">
+                <a:solidFill>
+                  <a:srgbClr val="9AA0B5"/>
+                </a:solidFill>
+                <a:latin typeface="Be Vietnam Pro" pitchFamily="34" charset="0"/>
+                <a:ea typeface="Be Vietnam Pro" pitchFamily="34" charset="-122"/>
+                <a:cs typeface="Be Vietnam Pro" pitchFamily="34" charset="-120"/>
+              </a:rPr>
+              <a:t> CLR,</a:t>
+            </a:r>
+            <a:r>
+              <a:rPr lang="en-US" sz="1800" dirty="0" spc="0" kern="0">
+                <a:solidFill>
+                  <a:srgbClr val="9AA0B5"/>
+                </a:solidFill>
+                <a:latin typeface="Be Vietnam Pro" pitchFamily="34" charset="0"/>
+                <a:ea typeface="Be Vietnam Pro" pitchFamily="34" charset="-122"/>
+                <a:cs typeface="Be Vietnam Pro" pitchFamily="34" charset="-120"/>
+              </a:rPr>
+              <a:t> CIL</a:t>
+            </a:r>
+            <a:r>
+              <a:rPr lang="en-US" sz="1800" dirty="0" spc="-12" kern="0">
+                <a:solidFill>
+                  <a:srgbClr val="9AA0B5"/>
+                </a:solidFill>
+                <a:latin typeface="Be Vietnam Pro" pitchFamily="34" charset="0"/>
+                <a:ea typeface="Be Vietnam Pro" pitchFamily="34" charset="-122"/>
+                <a:cs typeface="Be Vietnam Pro" pitchFamily="34" charset="-120"/>
+              </a:rPr>
+              <a:t> và</a:t>
+            </a:r>
+            <a:r>
+              <a:rPr lang="en-US" sz="1800" dirty="0" spc="-51" kern="0">
+                <a:solidFill>
+                  <a:srgbClr val="9AA0B5"/>
+                </a:solidFill>
+                <a:latin typeface="Be Vietnam Pro" pitchFamily="34" charset="0"/>
+                <a:ea typeface="Be Vietnam Pro" pitchFamily="34" charset="-122"/>
+                <a:cs typeface="Be Vietnam Pro" pitchFamily="34" charset="-120"/>
+              </a:rPr>
+              <a:t> AOT</a:t>
+            </a:r>
+            <a:r>
+              <a:rPr lang="en-US" sz="1800" dirty="0" spc="0" kern="0">
+                <a:solidFill>
+                  <a:srgbClr val="9AA0B5"/>
+                </a:solidFill>
+                <a:latin typeface="Be Vietnam Pro" pitchFamily="34" charset="0"/>
+                <a:ea typeface="Be Vietnam Pro" pitchFamily="34" charset="-122"/>
+                <a:cs typeface="Be Vietnam Pro" pitchFamily="34" charset="-120"/>
+              </a:rPr>
+              <a:t> là</a:t>
+            </a:r>
+            <a:r>
+              <a:rPr lang="en-US" sz="1800" dirty="0" spc="-2" kern="0">
+                <a:solidFill>
+                  <a:srgbClr val="9AA0B5"/>
+                </a:solidFill>
+                <a:latin typeface="Be Vietnam Pro" pitchFamily="34" charset="0"/>
+                <a:ea typeface="Be Vietnam Pro" pitchFamily="34" charset="-122"/>
+                <a:cs typeface="Be Vietnam Pro" pitchFamily="34" charset="-120"/>
+              </a:rPr>
+              <a:t> kiến</a:t>
+            </a:r>
+            <a:r>
+              <a:rPr lang="en-US" sz="1800" dirty="0" spc="6" kern="0">
+                <a:solidFill>
+                  <a:srgbClr val="9AA0B5"/>
+                </a:solidFill>
+                <a:latin typeface="Be Vietnam Pro" pitchFamily="34" charset="0"/>
+                <a:ea typeface="Be Vietnam Pro" pitchFamily="34" charset="-122"/>
+                <a:cs typeface="Be Vietnam Pro" pitchFamily="34" charset="-120"/>
+              </a:rPr>
+              <a:t> thức</a:t>
+            </a:r>
+            <a:r>
+              <a:rPr lang="en-US" sz="1800" dirty="0" spc="-2" kern="0">
+                <a:solidFill>
+                  <a:srgbClr val="9AA0B5"/>
+                </a:solidFill>
+                <a:latin typeface="Be Vietnam Pro" pitchFamily="34" charset="0"/>
+                <a:ea typeface="Be Vietnam Pro" pitchFamily="34" charset="-122"/>
+                <a:cs typeface="Be Vietnam Pro" pitchFamily="34" charset="-120"/>
+              </a:rPr>
+              <a:t> chung</a:t>
+            </a:r>
+            <a:r>
+              <a:rPr lang="en-US" sz="1800" dirty="0" spc="2" kern="0">
+                <a:solidFill>
+                  <a:srgbClr val="9AA0B5"/>
+                </a:solidFill>
+                <a:latin typeface="Be Vietnam Pro" pitchFamily="34" charset="0"/>
+                <a:ea typeface="Be Vietnam Pro" pitchFamily="34" charset="-122"/>
+                <a:cs typeface="Be Vietnam Pro" pitchFamily="34" charset="-120"/>
+              </a:rPr>
+              <a:t> của</a:t>
+            </a:r>
+            <a:r>
+              <a:rPr lang="en-US" sz="1800" dirty="0" spc="3" kern="0">
+                <a:solidFill>
+                  <a:srgbClr val="9AA0B5"/>
+                </a:solidFill>
+                <a:latin typeface="Be Vietnam Pro" pitchFamily="34" charset="0"/>
+                <a:ea typeface="Be Vietnam Pro" pitchFamily="34" charset="-122"/>
+                <a:cs typeface="Be Vietnam Pro" pitchFamily="34" charset="-120"/>
+              </a:rPr>
+              <a:t> người</a:t>
+            </a:r>
+            <a:r>
+              <a:rPr lang="en-US" sz="1800" dirty="0" spc="-2" kern="0">
+                <a:solidFill>
+                  <a:srgbClr val="9AA0B5"/>
+                </a:solidFill>
+                <a:latin typeface="Be Vietnam Pro" pitchFamily="34" charset="0"/>
+                <a:ea typeface="Be Vietnam Pro" pitchFamily="34" charset="-122"/>
+                <a:cs typeface="Be Vietnam Pro" pitchFamily="34" charset="-120"/>
+              </a:rPr>
+              <a:t> biên</a:t>
+            </a:r>
+            <a:r>
+              <a:rPr lang="en-US" sz="1800" dirty="0" spc="-5" kern="0">
+                <a:solidFill>
+                  <a:srgbClr val="9AA0B5"/>
+                </a:solidFill>
+                <a:latin typeface="Be Vietnam Pro" pitchFamily="34" charset="0"/>
+                <a:ea typeface="Be Vietnam Pro" pitchFamily="34" charset="-122"/>
+                <a:cs typeface="Be Vietnam Pro" pitchFamily="34" charset="-120"/>
+              </a:rPr>
+              <a:t> soạn,</a:t>
+            </a:r>
+            <a:r>
               <a:rPr lang="en-US" sz="1800" dirty="0" spc="7" kern="0">
                 <a:solidFill>
                   <a:srgbClr val="9AA0B5"/>
@@ -19031,10 +19218,10 @@
                 <a:ea typeface="Be Vietnam Pro" pitchFamily="34" charset="-122"/>
                 <a:cs typeface="Be Vietnam Pro" pitchFamily="34" charset="-120"/>
               </a:rPr>
-              <a:t> JVM</a:t>
-            </a:r>
-            <a:r>
-              <a:rPr lang="en-US" sz="1800" dirty="0" spc="-11" kern="0">
+              <a:t> chưa</a:t>
+            </a:r>
+            <a:r>
+              <a:rPr lang="en-US" sz="1800" dirty="0" spc="11" kern="0">
                 <a:solidFill>
                   <a:srgbClr val="9AA0B5"/>
                 </a:solidFill>
@@ -19042,10 +19229,10 @@
                 <a:ea typeface="Be Vietnam Pro" pitchFamily="34" charset="-122"/>
                 <a:cs typeface="Be Vietnam Pro" pitchFamily="34" charset="-120"/>
               </a:rPr>
-              <a:t> và</a:t>
-            </a:r>
-            <a:r>
-              <a:rPr lang="en-US" sz="1800" dirty="0" spc="-51" kern="0">
+              <a:t> đối</a:t>
+            </a:r>
+            <a:r>
+              <a:rPr lang="en-US" sz="1800" dirty="0" spc="-1" kern="0">
                 <a:solidFill>
                   <a:srgbClr val="9AA0B5"/>
                 </a:solidFill>
@@ -19053,10 +19240,10 @@
                 <a:ea typeface="Be Vietnam Pro" pitchFamily="34" charset="-122"/>
                 <a:cs typeface="Be Vietnam Pro" pitchFamily="34" charset="-120"/>
               </a:rPr>
-              <a:t> AOT</a:t>
-            </a:r>
-            <a:r>
-              <a:rPr lang="en-US" sz="1800" dirty="0" spc="0" kern="0">
+              <a:t> chiếu</a:t>
+            </a:r>
+            <a:r>
+              <a:rPr lang="en-US" sz="1800" dirty="0" spc="-10" kern="0">
                 <a:solidFill>
                   <a:srgbClr val="9AA0B5"/>
                 </a:solidFill>
@@ -19064,7 +19251,7 @@
                 <a:ea typeface="Be Vietnam Pro" pitchFamily="34" charset="-122"/>
                 <a:cs typeface="Be Vietnam Pro" pitchFamily="34" charset="-120"/>
               </a:rPr>
-              <a:t> là</a:t>
+              <a:t> tài</a:t>
             </a:r>
             <a:r>
               <a:rPr lang="en-US" sz="1800" dirty="0" spc="-2" kern="0">
@@ -19075,131 +19262,10 @@
                 <a:ea typeface="Be Vietnam Pro" pitchFamily="34" charset="-122"/>
                 <a:cs typeface="Be Vietnam Pro" pitchFamily="34" charset="-120"/>
               </a:rPr>
-              <a:t> kiến</a:t>
-            </a:r>
-            <a:r>
-              <a:rPr lang="en-US" sz="1800" dirty="0" spc="6" kern="0">
-                <a:solidFill>
-                  <a:srgbClr val="9AA0B5"/>
-                </a:solidFill>
-                <a:latin typeface="Be Vietnam Pro" pitchFamily="34" charset="0"/>
-                <a:ea typeface="Be Vietnam Pro" pitchFamily="34" charset="-122"/>
-                <a:cs typeface="Be Vietnam Pro" pitchFamily="34" charset="-120"/>
-              </a:rPr>
-              <a:t> thức</a:t>
-            </a:r>
-            <a:r>
-              <a:rPr lang="en-US" sz="1800" dirty="0" spc="-3" kern="0">
-                <a:solidFill>
-                  <a:srgbClr val="9AA0B5"/>
-                </a:solidFill>
-                <a:latin typeface="Be Vietnam Pro" pitchFamily="34" charset="0"/>
-                <a:ea typeface="Be Vietnam Pro" pitchFamily="34" charset="-122"/>
-                <a:cs typeface="Be Vietnam Pro" pitchFamily="34" charset="-120"/>
-              </a:rPr>
-              <a:t> chung</a:t>
-            </a:r>
-            <a:r>
-              <a:rPr lang="en-US" sz="1800" dirty="0" spc="4" kern="0">
-                <a:solidFill>
-                  <a:srgbClr val="9AA0B5"/>
-                </a:solidFill>
-                <a:latin typeface="Be Vietnam Pro" pitchFamily="34" charset="0"/>
-                <a:ea typeface="Be Vietnam Pro" pitchFamily="34" charset="-122"/>
-                <a:cs typeface="Be Vietnam Pro" pitchFamily="34" charset="-120"/>
-              </a:rPr>
-              <a:t> của</a:t>
-            </a:r>
-            <a:r>
-              <a:rPr lang="en-US" sz="1800" dirty="0" spc="2" kern="0">
-                <a:solidFill>
-                  <a:srgbClr val="9AA0B5"/>
-                </a:solidFill>
-                <a:latin typeface="Be Vietnam Pro" pitchFamily="34" charset="0"/>
-                <a:ea typeface="Be Vietnam Pro" pitchFamily="34" charset="-122"/>
-                <a:cs typeface="Be Vietnam Pro" pitchFamily="34" charset="-120"/>
-              </a:rPr>
-              <a:t> người</a:t>
+              <a:t> liệu</a:t>
             </a:r>
             <a:r>
               <a:rPr lang="en-US" sz="1800" dirty="0" spc="-1" kern="0">
-                <a:solidFill>
-                  <a:srgbClr val="9AA0B5"/>
-                </a:solidFill>
-                <a:latin typeface="Be Vietnam Pro" pitchFamily="34" charset="0"/>
-                <a:ea typeface="Be Vietnam Pro" pitchFamily="34" charset="-122"/>
-                <a:cs typeface="Be Vietnam Pro" pitchFamily="34" charset="-120"/>
-              </a:rPr>
-              <a:t> biên</a:t>
-            </a:r>
-            <a:r>
-              <a:rPr lang="en-US" sz="1800" dirty="0" spc="-5" kern="0">
-                <a:solidFill>
-                  <a:srgbClr val="9AA0B5"/>
-                </a:solidFill>
-                <a:latin typeface="Be Vietnam Pro" pitchFamily="34" charset="0"/>
-                <a:ea typeface="Be Vietnam Pro" pitchFamily="34" charset="-122"/>
-                <a:cs typeface="Be Vietnam Pro" pitchFamily="34" charset="-120"/>
-              </a:rPr>
-              <a:t> soạn,</a:t>
-            </a:r>
-            <a:r>
-              <a:rPr lang="en-US" sz="1800" dirty="0" spc="7" kern="0">
-                <a:solidFill>
-                  <a:srgbClr val="9AA0B5"/>
-                </a:solidFill>
-                <a:latin typeface="Be Vietnam Pro" pitchFamily="34" charset="0"/>
-                <a:ea typeface="Be Vietnam Pro" pitchFamily="34" charset="-122"/>
-                <a:cs typeface="Be Vietnam Pro" pitchFamily="34" charset="-120"/>
-              </a:rPr>
-              <a:t> chưa</a:t>
-            </a:r>
-            <a:r>
-              <a:rPr lang="en-US" sz="1800" dirty="0" spc="10" kern="0">
-                <a:solidFill>
-                  <a:srgbClr val="9AA0B5"/>
-                </a:solidFill>
-                <a:latin typeface="Be Vietnam Pro" pitchFamily="34" charset="0"/>
-                <a:ea typeface="Be Vietnam Pro" pitchFamily="34" charset="-122"/>
-                <a:cs typeface="Be Vietnam Pro" pitchFamily="34" charset="-120"/>
-              </a:rPr>
-              <a:t> đối</a:t>
-            </a:r>
-            <a:r>
-              <a:rPr lang="en-US" sz="1800" dirty="0" spc="-1" kern="0">
-                <a:solidFill>
-                  <a:srgbClr val="9AA0B5"/>
-                </a:solidFill>
-                <a:latin typeface="Be Vietnam Pro" pitchFamily="34" charset="0"/>
-                <a:ea typeface="Be Vietnam Pro" pitchFamily="34" charset="-122"/>
-                <a:cs typeface="Be Vietnam Pro" pitchFamily="34" charset="-120"/>
-              </a:rPr>
-              <a:t> chiếu</a:t>
-            </a:r>
-            <a:r>
-              <a:rPr lang="en-US" sz="1800" dirty="0" spc="-9" kern="0">
-                <a:solidFill>
-                  <a:srgbClr val="9AA0B5"/>
-                </a:solidFill>
-                <a:latin typeface="Be Vietnam Pro" pitchFamily="34" charset="0"/>
-                <a:ea typeface="Be Vietnam Pro" pitchFamily="34" charset="-122"/>
-                <a:cs typeface="Be Vietnam Pro" pitchFamily="34" charset="-120"/>
-              </a:rPr>
-              <a:t> tài</a:t>
-            </a:r>
-            <a:r>
-              <a:rPr lang="en-US" sz="1800" dirty="0" spc="-3" kern="0">
-                <a:solidFill>
-                  <a:srgbClr val="9AA0B5"/>
-                </a:solidFill>
-                <a:latin typeface="Be Vietnam Pro" pitchFamily="34" charset="0"/>
-                <a:ea typeface="Be Vietnam Pro" pitchFamily="34" charset="-122"/>
-                <a:cs typeface="Be Vietnam Pro" pitchFamily="34" charset="-120"/>
-              </a:rPr>
-              <a:t> liệu</a:t>
-            </a:r>
-            <a:r>
-              <a:rPr lang="en-US" sz="1800" dirty="0" spc="0" kern="0">
                 <a:solidFill>
                   <a:srgbClr val="9AA0B5"/>
                 </a:solidFill>

</xml_diff>

<commit_message>
Lesson sd-10-015: make the deck's overview slides say C# goes through CIL instead of a virtual machine running bytecode
Co-Authored-By: Claude Sonnet 5.5 <noreply@anthropic.com>
Claude-Session: https://claude.ai/code/session_011dmt3ZFdN8sjiTfDnyUVN7
</commit_message>
<xml_diff>
--- a/system-design-101/vi/lessons/sd-10-015/slides/sd-10-015.pptx
+++ b/system-design-101/vi/lessons/sd-10-015/slides/sd-10-015.pptx
@@ -2967,7 +2967,7 @@
               <a:buNone/>
             </a:pPr>
             <a:r>
-              <a:rPr lang="en-US" sz="2387" dirty="0" spc="-12" kern="0">
+              <a:rPr lang="en-US" sz="2387" dirty="0" spc="14" kern="0">
                 <a:solidFill>
                   <a:srgbClr val="C4C8D6"/>
                 </a:solidFill>
@@ -2975,10 +2975,10 @@
                 <a:ea typeface="Be Vietnam Pro" pitchFamily="34" charset="-122"/>
                 <a:cs typeface="Be Vietnam Pro" pitchFamily="34" charset="-120"/>
               </a:rPr>
-              <a:t>Máy</a:t>
-            </a:r>
-            <a:r>
-              <a:rPr lang="en-US" sz="2387" dirty="0" spc="-4" kern="0">
+              <a:t>JVM</a:t>
+            </a:r>
+            <a:r>
+              <a:rPr lang="en-US" sz="2387" dirty="0" spc="-2" kern="0">
                 <a:solidFill>
                   <a:srgbClr val="C4C8D6"/>
                 </a:solidFill>
@@ -2986,10 +2986,10 @@
                 <a:ea typeface="Be Vietnam Pro" pitchFamily="34" charset="-122"/>
                 <a:cs typeface="Be Vietnam Pro" pitchFamily="34" charset="-120"/>
               </a:rPr>
-              <a:t> ảo</a:t>
-            </a:r>
-            <a:r>
-              <a:rPr lang="en-US" sz="2387" dirty="0" spc="-1" kern="0">
+              <a:t> nạp</a:t>
+            </a:r>
+            <a:r>
+              <a:rPr lang="en-US" sz="2387" dirty="0" spc="-17" kern="0">
                 <a:solidFill>
                   <a:srgbClr val="C4C8D6"/>
                 </a:solidFill>
@@ -2997,10 +2997,10 @@
                 <a:ea typeface="Be Vietnam Pro" pitchFamily="34" charset="-122"/>
                 <a:cs typeface="Be Vietnam Pro" pitchFamily="34" charset="-120"/>
               </a:rPr>
-              <a:t> nạp</a:t>
-            </a:r>
-            <a:r>
-              <a:rPr lang="en-US" sz="2387" dirty="0" spc="-18" kern="0">
+              <a:t> và</a:t>
+            </a:r>
+            <a:r>
+              <a:rPr lang="en-US" sz="2387" dirty="0" spc="-6" kern="0">
                 <a:solidFill>
                   <a:srgbClr val="C4C8D6"/>
                 </a:solidFill>
@@ -3008,10 +3008,10 @@
                 <a:ea typeface="Be Vietnam Pro" pitchFamily="34" charset="-122"/>
                 <a:cs typeface="Be Vietnam Pro" pitchFamily="34" charset="-120"/>
               </a:rPr>
-              <a:t> và</a:t>
-            </a:r>
-            <a:r>
-              <a:rPr lang="en-US" sz="2387" dirty="0" spc="-6" kern="0">
+              <a:t> chạy;</a:t>
+            </a:r>
+            <a:r>
+              <a:rPr lang="en-US" sz="2387" dirty="0" spc="1" kern="0">
                 <a:solidFill>
                   <a:srgbClr val="C4C8D6"/>
                 </a:solidFill>
@@ -3019,10 +3019,10 @@
                 <a:ea typeface="Be Vietnam Pro" pitchFamily="34" charset="-122"/>
                 <a:cs typeface="Be Vietnam Pro" pitchFamily="34" charset="-120"/>
               </a:rPr>
-              <a:t> chạy</a:t>
-            </a:r>
-            <a:r>
-              <a:rPr lang="en-US" sz="2387" dirty="0" spc="-12" kern="0">
+              <a:t> C#</a:t>
+            </a:r>
+            <a:r>
+              <a:rPr lang="en-US" sz="2387" dirty="0" spc="-3" kern="0">
                 <a:solidFill>
                   <a:srgbClr val="C4C8D6"/>
                 </a:solidFill>
@@ -3030,7 +3030,18 @@
                 <a:ea typeface="Be Vietnam Pro" pitchFamily="34" charset="-122"/>
                 <a:cs typeface="Be Vietnam Pro" pitchFamily="34" charset="-120"/>
               </a:rPr>
-              <a:t> bytecode.</a:t>
+              <a:t> qua</a:t>
+            </a:r>
+            <a:r>
+              <a:rPr lang="en-US" sz="2387" dirty="0" spc="0" kern="0">
+                <a:solidFill>
+                  <a:srgbClr val="C4C8D6"/>
+                </a:solidFill>
+                <a:latin typeface="Be Vietnam Pro" pitchFamily="34" charset="0"/>
+                <a:ea typeface="Be Vietnam Pro" pitchFamily="34" charset="-122"/>
+                <a:cs typeface="Be Vietnam Pro" pitchFamily="34" charset="-120"/>
+              </a:rPr>
+              <a:t> CIL.</a:t>
             </a:r>
             <a:endParaRPr lang="en-US" sz="2387" dirty="0"/>
           </a:p>
@@ -4580,26 +4591,15 @@
               <a:buNone/>
             </a:pPr>
             <a:r>
-              <a:rPr lang="en-US" sz="2250" dirty="0" spc="-15" kern="0">
-                <a:solidFill>
-                  <a:srgbClr val="14161C"/>
-                </a:solidFill>
-                <a:latin typeface="Be Vietnam Pro" pitchFamily="34" charset="0"/>
-                <a:ea typeface="Be Vietnam Pro" pitchFamily="34" charset="-122"/>
-                <a:cs typeface="Be Vietnam Pro" pitchFamily="34" charset="-120"/>
-              </a:rPr>
-              <a:t>Máy</a:t>
-            </a:r>
-            <a:r>
-              <a:rPr lang="en-US" sz="2250" dirty="0" spc="-2" kern="0">
-                <a:solidFill>
-                  <a:srgbClr val="14161C"/>
-                </a:solidFill>
-                <a:latin typeface="Be Vietnam Pro" pitchFamily="34" charset="0"/>
-                <a:ea typeface="Be Vietnam Pro" pitchFamily="34" charset="-122"/>
-                <a:cs typeface="Be Vietnam Pro" pitchFamily="34" charset="-120"/>
-              </a:rPr>
-              <a:t> ảo</a:t>
+              <a:rPr lang="en-US" sz="2250" dirty="0" spc="12" kern="0">
+                <a:solidFill>
+                  <a:srgbClr val="14161C"/>
+                </a:solidFill>
+                <a:latin typeface="Be Vietnam Pro" pitchFamily="34" charset="0"/>
+                <a:ea typeface="Be Vietnam Pro" pitchFamily="34" charset="-122"/>
+                <a:cs typeface="Be Vietnam Pro" pitchFamily="34" charset="-120"/>
+              </a:rPr>
+              <a:t>JVM</a:t>
             </a:r>
             <a:r>
               <a:rPr lang="en-US" sz="2250" dirty="0" spc="1" kern="0">
@@ -4624,26 +4624,48 @@
               <a:t> và</a:t>
             </a:r>
             <a:r>
-              <a:rPr lang="en-US" sz="2250" dirty="0" spc="-7" kern="0">
-                <a:solidFill>
-                  <a:srgbClr val="14161C"/>
-                </a:solidFill>
-                <a:latin typeface="Be Vietnam Pro" pitchFamily="34" charset="0"/>
-                <a:ea typeface="Be Vietnam Pro" pitchFamily="34" charset="-122"/>
-                <a:cs typeface="Be Vietnam Pro" pitchFamily="34" charset="-120"/>
-              </a:rPr>
-              <a:t> chạy</a:t>
-            </a:r>
-            <a:r>
-              <a:rPr lang="en-US" sz="2250" dirty="0" spc="-9" kern="0">
-                <a:solidFill>
-                  <a:srgbClr val="14161C"/>
-                </a:solidFill>
-                <a:latin typeface="Be Vietnam Pro" pitchFamily="34" charset="0"/>
-                <a:ea typeface="Be Vietnam Pro" pitchFamily="34" charset="-122"/>
-                <a:cs typeface="Be Vietnam Pro" pitchFamily="34" charset="-120"/>
-              </a:rPr>
-              <a:t> bytecode.</a:t>
+              <a:rPr lang="en-US" sz="2250" dirty="0" spc="-6" kern="0">
+                <a:solidFill>
+                  <a:srgbClr val="14161C"/>
+                </a:solidFill>
+                <a:latin typeface="Be Vietnam Pro" pitchFamily="34" charset="0"/>
+                <a:ea typeface="Be Vietnam Pro" pitchFamily="34" charset="-122"/>
+                <a:cs typeface="Be Vietnam Pro" pitchFamily="34" charset="-120"/>
+              </a:rPr>
+              <a:t> chạy;</a:t>
+            </a:r>
+            <a:r>
+              <a:rPr lang="en-US" sz="2250" dirty="0" spc="0" kern="0">
+                <a:solidFill>
+                  <a:srgbClr val="14161C"/>
+                </a:solidFill>
+                <a:latin typeface="Be Vietnam Pro" pitchFamily="34" charset="0"/>
+                <a:ea typeface="Be Vietnam Pro" pitchFamily="34" charset="-122"/>
+                <a:cs typeface="Be Vietnam Pro" pitchFamily="34" charset="-120"/>
+              </a:rPr>
+              <a:t> C#</a:t>
+            </a:r>
+            <a:r>
+              <a:rPr lang="en-US" sz="2250" dirty="0" spc="1" kern="0">
+                <a:solidFill>
+                  <a:srgbClr val="14161C"/>
+                </a:solidFill>
+                <a:latin typeface="Be Vietnam Pro" pitchFamily="34" charset="0"/>
+                <a:ea typeface="Be Vietnam Pro" pitchFamily="34" charset="-122"/>
+                <a:cs typeface="Be Vietnam Pro" pitchFamily="34" charset="-120"/>
+              </a:rPr>
+              <a:t> qua</a:t>
+            </a:r>
+            <a:r>
+              <a:rPr lang="en-US" sz="2250" dirty="0" spc="3" kern="0">
+                <a:solidFill>
+                  <a:srgbClr val="14161C"/>
+                </a:solidFill>
+                <a:latin typeface="Be Vietnam Pro" pitchFamily="34" charset="0"/>
+                <a:ea typeface="Be Vietnam Pro" pitchFamily="34" charset="-122"/>
+                <a:cs typeface="Be Vietnam Pro" pitchFamily="34" charset="-120"/>
+              </a:rPr>
+              <a:t> CIL.</a:t>
             </a:r>
             <a:endParaRPr lang="en-US" sz="2250" dirty="0"/>
           </a:p>

</xml_diff>